<commit_message>
updating layout of single ticket thing
</commit_message>
<xml_diff>
--- a/qontrol/public/reports/ceo-weekly/ceo-weekly-2026-04-13/report.pptx
+++ b/qontrol/public/reports/ceo-weekly/ceo-weekly-2026-04-13/report.pptx
@@ -2,16 +2,16 @@
 <file path=ppt/presentation.xml><?xml version="1.0" encoding="utf-8"?>
 <p:presentation xmlns:p="http://schemas.openxmlformats.org/presentationml/2006/main">
   <p:sldMasterIdLst>
-    <p:sldMasterId xmlns:r="http://schemas.openxmlformats.org/officeDocument/2006/relationships" id="2147483648" r:id="R1105ec7583564e4d"/>
+    <p:sldMasterId xmlns:r="http://schemas.openxmlformats.org/officeDocument/2006/relationships" id="2147483648" r:id="Re17a5437ccf14a29"/>
   </p:sldMasterIdLst>
   <p:notesMasterIdLst>
-    <p:notesMasterId xmlns:r="http://schemas.openxmlformats.org/officeDocument/2006/relationships" r:id="R1ff3d126fba944a4"/>
+    <p:notesMasterId xmlns:r="http://schemas.openxmlformats.org/officeDocument/2006/relationships" r:id="R14cda5e14f1c4259"/>
   </p:notesMasterIdLst>
   <p:sldIdLst>
-    <p:sldId xmlns:r="http://schemas.openxmlformats.org/officeDocument/2006/relationships" id="256" r:id="R386564fb060a4246"/>
-    <p:sldId xmlns:r="http://schemas.openxmlformats.org/officeDocument/2006/relationships" id="257" r:id="Rdde20d5071b04e0e"/>
-    <p:sldId xmlns:r="http://schemas.openxmlformats.org/officeDocument/2006/relationships" id="258" r:id="R643775974da0493a"/>
-    <p:sldId xmlns:r="http://schemas.openxmlformats.org/officeDocument/2006/relationships" id="259" r:id="R37a966fdfa9f473b"/>
+    <p:sldId xmlns:r="http://schemas.openxmlformats.org/officeDocument/2006/relationships" id="256" r:id="R8a922de8403a4cbc"/>
+    <p:sldId xmlns:r="http://schemas.openxmlformats.org/officeDocument/2006/relationships" id="257" r:id="R18bb5e8a29464123"/>
+    <p:sldId xmlns:r="http://schemas.openxmlformats.org/officeDocument/2006/relationships" id="258" r:id="Refd0aa9868da4558"/>
+    <p:sldId xmlns:r="http://schemas.openxmlformats.org/officeDocument/2006/relationships" id="259" r:id="Rde4f8f6cacad457a"/>
   </p:sldIdLst>
   <p:sldSz cx="12192000" cy="6858000"/>
   <p:notesSz cx="6858000" cy="9144000"/>
@@ -681,7 +681,7 @@
           <p:cNvPr id="1" name="Title 1">
             <a:extLst xmlns:a="http://schemas.openxmlformats.org/drawingml/2006/main">
               <a:ext uri="{FF2B5EF4-FFF2-40B4-BE49-F238E27FC236}">
-                <a16:creationId xmlns:a16="http://schemas.microsoft.com/office/drawing/2014/main" id="{A81AD4A6-B4A6-4373-B696-D80D94EAA854}"/>
+                <a16:creationId xmlns:a16="http://schemas.microsoft.com/office/drawing/2014/main" id="{ACEF8999-2B9A-43AC-9BBF-C4FB1C797198}"/>
               </a:ext>
             </a:extLst>
           </p:cNvPr>
@@ -712,7 +712,7 @@
           <p:cNvPr id="2" name="Subtitle 2">
             <a:extLst xmlns:a="http://schemas.openxmlformats.org/drawingml/2006/main">
               <a:ext uri="{FF2B5EF4-FFF2-40B4-BE49-F238E27FC236}">
-                <a16:creationId xmlns:a16="http://schemas.microsoft.com/office/drawing/2014/main" id="{2CDBE2FC-5C2D-4AFF-91EB-781478309F72}"/>
+                <a16:creationId xmlns:a16="http://schemas.microsoft.com/office/drawing/2014/main" id="{AB7EB576-06F4-4666-89A0-300E4175D7A0}"/>
               </a:ext>
             </a:extLst>
           </p:cNvPr>
@@ -775,7 +775,7 @@
           <p:cNvPr id="3" name="Date Placeholder 3">
             <a:extLst xmlns:a="http://schemas.openxmlformats.org/drawingml/2006/main">
               <a:ext uri="{FF2B5EF4-FFF2-40B4-BE49-F238E27FC236}">
-                <a16:creationId xmlns:a16="http://schemas.microsoft.com/office/drawing/2014/main" id="{3ED3C5A7-792B-4482-9596-CAEAE26BED10}"/>
+                <a16:creationId xmlns:a16="http://schemas.microsoft.com/office/drawing/2014/main" id="{FBBD6D9B-344B-4638-83F0-ABDF3E30811A}"/>
               </a:ext>
             </a:extLst>
           </p:cNvPr>
@@ -796,7 +796,7 @@
           <p:cNvPr id="4" name="Footer Placeholder 4">
             <a:extLst xmlns:a="http://schemas.openxmlformats.org/drawingml/2006/main">
               <a:ext uri="{FF2B5EF4-FFF2-40B4-BE49-F238E27FC236}">
-                <a16:creationId xmlns:a16="http://schemas.microsoft.com/office/drawing/2014/main" id="{EE0E28E7-24BB-48F0-87C9-A9910985078B}"/>
+                <a16:creationId xmlns:a16="http://schemas.microsoft.com/office/drawing/2014/main" id="{1A6846A9-56AC-43AD-BE3A-02359D2C87F6}"/>
               </a:ext>
             </a:extLst>
           </p:cNvPr>
@@ -817,7 +817,7 @@
           <p:cNvPr id="5" name="Slide Number Placeholder 5">
             <a:extLst xmlns:a="http://schemas.openxmlformats.org/drawingml/2006/main">
               <a:ext uri="{FF2B5EF4-FFF2-40B4-BE49-F238E27FC236}">
-                <a16:creationId xmlns:a16="http://schemas.microsoft.com/office/drawing/2014/main" id="{A38EE67A-5EB7-40DD-A2FB-C845C008A837}"/>
+                <a16:creationId xmlns:a16="http://schemas.microsoft.com/office/drawing/2014/main" id="{5CB0B9E6-D1CD-4D78-BE01-E7D92F1A92B6}"/>
               </a:ext>
             </a:extLst>
           </p:cNvPr>
@@ -860,7 +860,7 @@
           <p:cNvPr id="1" name="Slide Number Placeholder 5">
             <a:extLst xmlns:a="http://schemas.openxmlformats.org/drawingml/2006/main">
               <a:ext uri="{FF2B5EF4-FFF2-40B4-BE49-F238E27FC236}">
-                <a16:creationId xmlns:a16="http://schemas.microsoft.com/office/drawing/2014/main" id="{0C75A3E2-9937-4520-8A70-F50426BB25C2}"/>
+                <a16:creationId xmlns:a16="http://schemas.microsoft.com/office/drawing/2014/main" id="{F455E8CE-25C0-47C3-BFAD-9B22B515D286}"/>
               </a:ext>
             </a:extLst>
           </p:cNvPr>
@@ -899,7 +899,7 @@
   </p:cSld>
   <p:clrMap bg1="lt1" tx1="dk1" bg2="lt2" tx2="dk2" accent1="accent1" accent2="accent2" accent3="accent3" accent4="accent4" accent5="accent5" accent6="accent6" hlink="hlink" folHlink="folHlink"/>
   <p:sldLayoutIdLst>
-    <p:sldLayoutId xmlns:r="http://schemas.openxmlformats.org/officeDocument/2006/relationships" id="2147483649" r:id="R74119cb18866411c"/>
+    <p:sldLayoutId xmlns:r="http://schemas.openxmlformats.org/officeDocument/2006/relationships" id="2147483649" r:id="Rb2fb9132f90b436e"/>
   </p:sldLayoutIdLst>
   <p:txStyles>
     <p:titleStyle>
@@ -1198,7 +1198,7 @@
           <p:cNvPr id="1" name="Slide Number Placeholder 5">
             <a:extLst xmlns:a="http://schemas.openxmlformats.org/drawingml/2006/main">
               <a:ext uri="{FF2B5EF4-FFF2-40B4-BE49-F238E27FC236}">
-                <a16:creationId xmlns:a16="http://schemas.microsoft.com/office/drawing/2014/main" id="{A38EE67A-5EB7-40DD-A2FB-C845C008A837}"/>
+                <a16:creationId xmlns:a16="http://schemas.microsoft.com/office/drawing/2014/main" id="{5CB0B9E6-D1CD-4D78-BE01-E7D92F1A92B6}"/>
               </a:ext>
             </a:extLst>
           </p:cNvPr>
@@ -1230,7 +1230,7 @@
           <p:cNvPr id="2" name="">
             <a:extLst xmlns:a="http://schemas.openxmlformats.org/drawingml/2006/main">
               <a:ext uri="{FF2B5EF4-FFF2-40B4-BE49-F238E27FC236}">
-                <a16:creationId xmlns:a16="http://schemas.microsoft.com/office/drawing/2014/main" id="{81B2AE70-9DF6-4D8E-96F3-1A141472EE81}"/>
+                <a16:creationId xmlns:a16="http://schemas.microsoft.com/office/drawing/2014/main" id="{E80ED2EC-8339-4047-A111-81E106719CA1}"/>
               </a:ext>
             </a:extLst>
           </p:cNvPr>
@@ -1262,7 +1262,7 @@
           <p:cNvPr id="3" name="">
             <a:extLst xmlns:a="http://schemas.openxmlformats.org/drawingml/2006/main">
               <a:ext uri="{FF2B5EF4-FFF2-40B4-BE49-F238E27FC236}">
-                <a16:creationId xmlns:a16="http://schemas.microsoft.com/office/drawing/2014/main" id="{8DA65787-2083-4159-B495-B955033F9745}"/>
+                <a16:creationId xmlns:a16="http://schemas.microsoft.com/office/drawing/2014/main" id="{8DE83409-EA8F-4F0C-9E6F-2BD31F1BAD34}"/>
               </a:ext>
             </a:extLst>
           </p:cNvPr>
@@ -1296,7 +1296,7 @@
           <p:cNvPr id="4" name="">
             <a:extLst xmlns:a="http://schemas.openxmlformats.org/drawingml/2006/main">
               <a:ext uri="{FF2B5EF4-FFF2-40B4-BE49-F238E27FC236}">
-                <a16:creationId xmlns:a16="http://schemas.microsoft.com/office/drawing/2014/main" id="{D0B45B3F-FD3E-4C9A-A134-DEEB497625B9}"/>
+                <a16:creationId xmlns:a16="http://schemas.microsoft.com/office/drawing/2014/main" id="{C152323E-C087-4288-A5A1-BD65C741197B}"/>
               </a:ext>
             </a:extLst>
           </p:cNvPr>
@@ -1330,7 +1330,7 @@
           <p:cNvPr id="5" name="">
             <a:extLst xmlns:a="http://schemas.openxmlformats.org/drawingml/2006/main">
               <a:ext uri="{FF2B5EF4-FFF2-40B4-BE49-F238E27FC236}">
-                <a16:creationId xmlns:a16="http://schemas.microsoft.com/office/drawing/2014/main" id="{EDA2B738-B3C5-4AD3-BB88-F9E51A9D989A}"/>
+                <a16:creationId xmlns:a16="http://schemas.microsoft.com/office/drawing/2014/main" id="{CA06AD8D-7609-4104-ADD2-266644097E83}"/>
               </a:ext>
             </a:extLst>
           </p:cNvPr>
@@ -1362,7 +1362,7 @@
           <p:cNvPr id="6" name="">
             <a:extLst xmlns:a="http://schemas.openxmlformats.org/drawingml/2006/main">
               <a:ext uri="{FF2B5EF4-FFF2-40B4-BE49-F238E27FC236}">
-                <a16:creationId xmlns:a16="http://schemas.microsoft.com/office/drawing/2014/main" id="{74E3193C-3ABD-4237-8D44-092806FD618A}"/>
+                <a16:creationId xmlns:a16="http://schemas.microsoft.com/office/drawing/2014/main" id="{05DADA7A-4E11-46B7-A042-65AA5F2983A1}"/>
               </a:ext>
             </a:extLst>
           </p:cNvPr>
@@ -1394,7 +1394,7 @@
           <p:cNvPr id="7" name="">
             <a:extLst xmlns:a="http://schemas.openxmlformats.org/drawingml/2006/main">
               <a:ext uri="{FF2B5EF4-FFF2-40B4-BE49-F238E27FC236}">
-                <a16:creationId xmlns:a16="http://schemas.microsoft.com/office/drawing/2014/main" id="{6905DB42-3446-4F6C-9268-B9B34A01522C}"/>
+                <a16:creationId xmlns:a16="http://schemas.microsoft.com/office/drawing/2014/main" id="{19A35A8F-9FC4-45B4-A75F-76130F5D89DF}"/>
               </a:ext>
             </a:extLst>
           </p:cNvPr>
@@ -1428,7 +1428,7 @@
           <p:cNvPr id="8" name="">
             <a:extLst xmlns:a="http://schemas.openxmlformats.org/drawingml/2006/main">
               <a:ext uri="{FF2B5EF4-FFF2-40B4-BE49-F238E27FC236}">
-                <a16:creationId xmlns:a16="http://schemas.microsoft.com/office/drawing/2014/main" id="{A3488F01-540A-4932-BDE1-5532A29EBA42}"/>
+                <a16:creationId xmlns:a16="http://schemas.microsoft.com/office/drawing/2014/main" id="{6165BA9F-8D12-43D1-AAB0-7564DBEFE067}"/>
               </a:ext>
             </a:extLst>
           </p:cNvPr>
@@ -1485,7 +1485,7 @@
           <p:cNvPr id="9" name="">
             <a:extLst xmlns:a="http://schemas.openxmlformats.org/drawingml/2006/main">
               <a:ext uri="{FF2B5EF4-FFF2-40B4-BE49-F238E27FC236}">
-                <a16:creationId xmlns:a16="http://schemas.microsoft.com/office/drawing/2014/main" id="{68C09B06-8DC0-4B43-9D7E-7D71984F3110}"/>
+                <a16:creationId xmlns:a16="http://schemas.microsoft.com/office/drawing/2014/main" id="{23FF5E73-19E7-4F5E-B460-30E625C8C7F3}"/>
               </a:ext>
             </a:extLst>
           </p:cNvPr>
@@ -1542,7 +1542,7 @@
           <p:cNvPr id="10" name="">
             <a:extLst xmlns:a="http://schemas.openxmlformats.org/drawingml/2006/main">
               <a:ext uri="{FF2B5EF4-FFF2-40B4-BE49-F238E27FC236}">
-                <a16:creationId xmlns:a16="http://schemas.microsoft.com/office/drawing/2014/main" id="{72A7C661-711A-455F-A778-C1ED14377310}"/>
+                <a16:creationId xmlns:a16="http://schemas.microsoft.com/office/drawing/2014/main" id="{3189639C-8281-4BE7-90F0-D069EC472FB4}"/>
               </a:ext>
             </a:extLst>
           </p:cNvPr>
@@ -1599,7 +1599,7 @@
           <p:cNvPr id="11" name="">
             <a:extLst xmlns:a="http://schemas.openxmlformats.org/drawingml/2006/main">
               <a:ext uri="{FF2B5EF4-FFF2-40B4-BE49-F238E27FC236}">
-                <a16:creationId xmlns:a16="http://schemas.microsoft.com/office/drawing/2014/main" id="{E5B9E79A-7F40-44C4-B250-924383195093}"/>
+                <a16:creationId xmlns:a16="http://schemas.microsoft.com/office/drawing/2014/main" id="{3A30DE36-0EE1-4FAE-A3F4-0EA47CF17034}"/>
               </a:ext>
             </a:extLst>
           </p:cNvPr>
@@ -1656,7 +1656,7 @@
           <p:cNvPr id="12" name="">
             <a:extLst xmlns:a="http://schemas.openxmlformats.org/drawingml/2006/main">
               <a:ext uri="{FF2B5EF4-FFF2-40B4-BE49-F238E27FC236}">
-                <a16:creationId xmlns:a16="http://schemas.microsoft.com/office/drawing/2014/main" id="{D6867044-F75A-4A50-9E78-9762255ADB7F}"/>
+                <a16:creationId xmlns:a16="http://schemas.microsoft.com/office/drawing/2014/main" id="{3EC07DF1-A91E-4CFF-81D8-F8A81CDB4711}"/>
               </a:ext>
             </a:extLst>
           </p:cNvPr>
@@ -1690,7 +1690,7 @@
           <p:cNvPr id="13" name="">
             <a:extLst xmlns:a="http://schemas.openxmlformats.org/drawingml/2006/main">
               <a:ext uri="{FF2B5EF4-FFF2-40B4-BE49-F238E27FC236}">
-                <a16:creationId xmlns:a16="http://schemas.microsoft.com/office/drawing/2014/main" id="{50F22F38-8ED8-42EC-B1DD-E6C5BE1B407B}"/>
+                <a16:creationId xmlns:a16="http://schemas.microsoft.com/office/drawing/2014/main" id="{2BF2862D-30F3-40F0-B303-FBA68BE9B6FA}"/>
               </a:ext>
             </a:extLst>
           </p:cNvPr>
@@ -1737,7 +1737,7 @@
                   <a:srgbClr val="FFFFFF"/>
                 </a:solidFill>
               </a:rPr>
-              <a:t>Generated Apr 19, 2026, 7:42 AM</a:t>
+              <a:t>Generated Apr 19, 2026, 8:55 AM</a:t>
             </a:r>
           </a:p>
         </p:txBody>
@@ -1747,7 +1747,7 @@
           <p:cNvPr id="14" name="">
             <a:extLst xmlns:a="http://schemas.openxmlformats.org/drawingml/2006/main">
               <a:ext uri="{FF2B5EF4-FFF2-40B4-BE49-F238E27FC236}">
-                <a16:creationId xmlns:a16="http://schemas.microsoft.com/office/drawing/2014/main" id="{1CDC6045-8BBE-4F5D-B422-6747CCF850EE}"/>
+                <a16:creationId xmlns:a16="http://schemas.microsoft.com/office/drawing/2014/main" id="{3D46D3C5-6E99-4132-B02B-DCCC9BFB13F8}"/>
               </a:ext>
             </a:extLst>
           </p:cNvPr>
@@ -1804,7 +1804,7 @@
           <p:cNvPr id="15" name="">
             <a:extLst xmlns:a="http://schemas.openxmlformats.org/drawingml/2006/main">
               <a:ext uri="{FF2B5EF4-FFF2-40B4-BE49-F238E27FC236}">
-                <a16:creationId xmlns:a16="http://schemas.microsoft.com/office/drawing/2014/main" id="{535051FF-4163-46A3-8B09-17CB0B97CBA1}"/>
+                <a16:creationId xmlns:a16="http://schemas.microsoft.com/office/drawing/2014/main" id="{246FCE4E-B364-405D-A09B-E36AD03E8595}"/>
               </a:ext>
             </a:extLst>
           </p:cNvPr>
@@ -1838,7 +1838,7 @@
           <p:cNvPr id="16" name="">
             <a:extLst xmlns:a="http://schemas.openxmlformats.org/drawingml/2006/main">
               <a:ext uri="{FF2B5EF4-FFF2-40B4-BE49-F238E27FC236}">
-                <a16:creationId xmlns:a16="http://schemas.microsoft.com/office/drawing/2014/main" id="{041B6400-3849-4E65-8954-1AA306FFF362}"/>
+                <a16:creationId xmlns:a16="http://schemas.microsoft.com/office/drawing/2014/main" id="{CCA59F77-3922-498A-839E-DD204A57E9AA}"/>
               </a:ext>
             </a:extLst>
           </p:cNvPr>
@@ -1895,7 +1895,7 @@
           <p:cNvPr id="17" name="">
             <a:extLst xmlns:a="http://schemas.openxmlformats.org/drawingml/2006/main">
               <a:ext uri="{FF2B5EF4-FFF2-40B4-BE49-F238E27FC236}">
-                <a16:creationId xmlns:a16="http://schemas.microsoft.com/office/drawing/2014/main" id="{B6ED6E86-481F-4FE8-B7BC-CC4B09F53C31}"/>
+                <a16:creationId xmlns:a16="http://schemas.microsoft.com/office/drawing/2014/main" id="{2C478D34-C2AE-4444-8B23-C56F1A5786E7}"/>
               </a:ext>
             </a:extLst>
           </p:cNvPr>
@@ -1952,7 +1952,7 @@
           <p:cNvPr id="18" name="">
             <a:extLst xmlns:a="http://schemas.openxmlformats.org/drawingml/2006/main">
               <a:ext uri="{FF2B5EF4-FFF2-40B4-BE49-F238E27FC236}">
-                <a16:creationId xmlns:a16="http://schemas.microsoft.com/office/drawing/2014/main" id="{74A9541E-17C3-4AFC-9C16-0740E9B28D13}"/>
+                <a16:creationId xmlns:a16="http://schemas.microsoft.com/office/drawing/2014/main" id="{3AB2D7AA-6400-4E23-8C1F-C3492858FB32}"/>
               </a:ext>
             </a:extLst>
           </p:cNvPr>
@@ -1986,7 +1986,7 @@
           <p:cNvPr id="19" name="">
             <a:extLst xmlns:a="http://schemas.openxmlformats.org/drawingml/2006/main">
               <a:ext uri="{FF2B5EF4-FFF2-40B4-BE49-F238E27FC236}">
-                <a16:creationId xmlns:a16="http://schemas.microsoft.com/office/drawing/2014/main" id="{011E486F-9020-4A1B-ADBE-0A85244675A8}"/>
+                <a16:creationId xmlns:a16="http://schemas.microsoft.com/office/drawing/2014/main" id="{53AD448B-EC81-4205-AFF7-CB7BEB54AAF6}"/>
               </a:ext>
             </a:extLst>
           </p:cNvPr>
@@ -2043,7 +2043,7 @@
           <p:cNvPr id="20" name="">
             <a:extLst xmlns:a="http://schemas.openxmlformats.org/drawingml/2006/main">
               <a:ext uri="{FF2B5EF4-FFF2-40B4-BE49-F238E27FC236}">
-                <a16:creationId xmlns:a16="http://schemas.microsoft.com/office/drawing/2014/main" id="{ACBF89E8-2501-4A62-B090-B45291CBE207}"/>
+                <a16:creationId xmlns:a16="http://schemas.microsoft.com/office/drawing/2014/main" id="{E1FB6C2B-69AF-4A98-BE52-16CA9C7C29B7}"/>
               </a:ext>
             </a:extLst>
           </p:cNvPr>
@@ -2100,7 +2100,7 @@
           <p:cNvPr id="21" name="">
             <a:extLst xmlns:a="http://schemas.openxmlformats.org/drawingml/2006/main">
               <a:ext uri="{FF2B5EF4-FFF2-40B4-BE49-F238E27FC236}">
-                <a16:creationId xmlns:a16="http://schemas.microsoft.com/office/drawing/2014/main" id="{B76F6775-EC25-463F-89A7-7F32366DF7D6}"/>
+                <a16:creationId xmlns:a16="http://schemas.microsoft.com/office/drawing/2014/main" id="{97E4A8AC-8768-47D5-AA12-ED65471A4C72}"/>
               </a:ext>
             </a:extLst>
           </p:cNvPr>
@@ -2134,7 +2134,7 @@
           <p:cNvPr id="22" name="">
             <a:extLst xmlns:a="http://schemas.openxmlformats.org/drawingml/2006/main">
               <a:ext uri="{FF2B5EF4-FFF2-40B4-BE49-F238E27FC236}">
-                <a16:creationId xmlns:a16="http://schemas.microsoft.com/office/drawing/2014/main" id="{56CB1851-D19E-499F-8429-3C3FEBEADDD4}"/>
+                <a16:creationId xmlns:a16="http://schemas.microsoft.com/office/drawing/2014/main" id="{FC2C7E19-E2AD-49DC-B61C-785CCE61D11D}"/>
               </a:ext>
             </a:extLst>
           </p:cNvPr>
@@ -2191,7 +2191,7 @@
           <p:cNvPr id="23" name="">
             <a:extLst xmlns:a="http://schemas.openxmlformats.org/drawingml/2006/main">
               <a:ext uri="{FF2B5EF4-FFF2-40B4-BE49-F238E27FC236}">
-                <a16:creationId xmlns:a16="http://schemas.microsoft.com/office/drawing/2014/main" id="{96B72339-CE74-4FE1-9ADC-FFCEAEC9A9EE}"/>
+                <a16:creationId xmlns:a16="http://schemas.microsoft.com/office/drawing/2014/main" id="{AA1B168A-797F-4B97-B06C-728ED0CAF486}"/>
               </a:ext>
             </a:extLst>
           </p:cNvPr>
@@ -2238,7 +2238,7 @@
                   <a:srgbClr val="17212B"/>
                 </a:solidFill>
               </a:rPr>
-              <a:t>153</a:t>
+              <a:t>133</a:t>
             </a:r>
           </a:p>
         </p:txBody>
@@ -2248,7 +2248,7 @@
           <p:cNvPr id="24" name="">
             <a:extLst xmlns:a="http://schemas.openxmlformats.org/drawingml/2006/main">
               <a:ext uri="{FF2B5EF4-FFF2-40B4-BE49-F238E27FC236}">
-                <a16:creationId xmlns:a16="http://schemas.microsoft.com/office/drawing/2014/main" id="{351995B1-E962-4792-8D67-9834078C4A5E}"/>
+                <a16:creationId xmlns:a16="http://schemas.microsoft.com/office/drawing/2014/main" id="{037C9C13-99B7-4BC8-9E63-C92852E64269}"/>
               </a:ext>
             </a:extLst>
           </p:cNvPr>
@@ -2282,7 +2282,7 @@
           <p:cNvPr id="25" name="">
             <a:extLst xmlns:a="http://schemas.openxmlformats.org/drawingml/2006/main">
               <a:ext uri="{FF2B5EF4-FFF2-40B4-BE49-F238E27FC236}">
-                <a16:creationId xmlns:a16="http://schemas.microsoft.com/office/drawing/2014/main" id="{EC400A59-5A75-4CF2-AD24-C2FBDD84594A}"/>
+                <a16:creationId xmlns:a16="http://schemas.microsoft.com/office/drawing/2014/main" id="{FD2D3774-771B-4E91-A074-8E5917E04F53}"/>
               </a:ext>
             </a:extLst>
           </p:cNvPr>
@@ -2339,7 +2339,7 @@
           <p:cNvPr id="26" name="">
             <a:extLst xmlns:a="http://schemas.openxmlformats.org/drawingml/2006/main">
               <a:ext uri="{FF2B5EF4-FFF2-40B4-BE49-F238E27FC236}">
-                <a16:creationId xmlns:a16="http://schemas.microsoft.com/office/drawing/2014/main" id="{579044F2-1B67-4FDC-98C8-62C593D5F33C}"/>
+                <a16:creationId xmlns:a16="http://schemas.microsoft.com/office/drawing/2014/main" id="{340CCC1E-3960-4E8F-8F21-45AF8F36EA72}"/>
               </a:ext>
             </a:extLst>
           </p:cNvPr>
@@ -2396,7 +2396,7 @@
           <p:cNvPr id="27" name="">
             <a:extLst xmlns:a="http://schemas.openxmlformats.org/drawingml/2006/main">
               <a:ext uri="{FF2B5EF4-FFF2-40B4-BE49-F238E27FC236}">
-                <a16:creationId xmlns:a16="http://schemas.microsoft.com/office/drawing/2014/main" id="{4BD92EF8-6DF3-4C53-9057-6887C6FE9BA0}"/>
+                <a16:creationId xmlns:a16="http://schemas.microsoft.com/office/drawing/2014/main" id="{FE3477A3-7537-469F-9C7E-22F28FBB5F0C}"/>
               </a:ext>
             </a:extLst>
           </p:cNvPr>
@@ -2443,7 +2443,7 @@
                   <a:srgbClr val="52616F"/>
                 </a:solidFill>
               </a:rPr>
-              <a:t>MO currently owns 97 open tickets, including 20 high-severity items and 94 overdue follow-ups. That queue scores 203 points above the peer median on the executive backlog index.</a:t>
+              <a:t>MO currently owns 97 open tickets, including 20 high-severity items and 74 overdue follow-ups. That queue scores 123 points above the peer median on the executive backlog index.</a:t>
             </a:r>
           </a:p>
         </p:txBody>
@@ -2453,7 +2453,7 @@
           <p:cNvPr id="28" name="">
             <a:extLst xmlns:a="http://schemas.openxmlformats.org/drawingml/2006/main">
               <a:ext uri="{FF2B5EF4-FFF2-40B4-BE49-F238E27FC236}">
-                <a16:creationId xmlns:a16="http://schemas.microsoft.com/office/drawing/2014/main" id="{F8186DBF-1D0C-4B79-BC21-0FD34741C38D}"/>
+                <a16:creationId xmlns:a16="http://schemas.microsoft.com/office/drawing/2014/main" id="{830A34BF-F351-475D-9199-9DA2B9B1578D}"/>
               </a:ext>
             </a:extLst>
           </p:cNvPr>
@@ -2487,7 +2487,7 @@
           <p:cNvPr id="29" name="">
             <a:extLst xmlns:a="http://schemas.openxmlformats.org/drawingml/2006/main">
               <a:ext uri="{FF2B5EF4-FFF2-40B4-BE49-F238E27FC236}">
-                <a16:creationId xmlns:a16="http://schemas.microsoft.com/office/drawing/2014/main" id="{C52BF244-E0DC-4D08-9108-91EBEB9236C3}"/>
+                <a16:creationId xmlns:a16="http://schemas.microsoft.com/office/drawing/2014/main" id="{9B2D181D-63D0-4223-9B07-13F5A6B56BE2}"/>
               </a:ext>
             </a:extLst>
           </p:cNvPr>
@@ -2542,7 +2542,7 @@
     </p:spTree>
     <p:extLst>
       <p:ext uri="{BB962C8B-B14F-4D97-AF65-F5344CB8AC3E}">
-        <p14:creationId xmlns:p14="http://schemas.microsoft.com/office/powerpoint/2010/main" val="948426142"/>
+        <p14:creationId xmlns:p14="http://schemas.microsoft.com/office/powerpoint/2010/main" val="1216271195"/>
       </p:ext>
     </p:extLst>
   </p:cSld>
@@ -2566,7 +2566,7 @@
           <p:cNvPr id="1" name="Slide Number Placeholder 5">
             <a:extLst xmlns:a="http://schemas.openxmlformats.org/drawingml/2006/main">
               <a:ext uri="{FF2B5EF4-FFF2-40B4-BE49-F238E27FC236}">
-                <a16:creationId xmlns:a16="http://schemas.microsoft.com/office/drawing/2014/main" id="{A38EE67A-5EB7-40DD-A2FB-C845C008A837}"/>
+                <a16:creationId xmlns:a16="http://schemas.microsoft.com/office/drawing/2014/main" id="{5CB0B9E6-D1CD-4D78-BE01-E7D92F1A92B6}"/>
               </a:ext>
             </a:extLst>
           </p:cNvPr>
@@ -2598,7 +2598,7 @@
           <p:cNvPr id="2" name="">
             <a:extLst xmlns:a="http://schemas.openxmlformats.org/drawingml/2006/main">
               <a:ext uri="{FF2B5EF4-FFF2-40B4-BE49-F238E27FC236}">
-                <a16:creationId xmlns:a16="http://schemas.microsoft.com/office/drawing/2014/main" id="{B50D1493-8AA6-4DB1-AF59-F8EBC39194AA}"/>
+                <a16:creationId xmlns:a16="http://schemas.microsoft.com/office/drawing/2014/main" id="{5AE5F8AD-3B4F-4433-BD51-7B281972783E}"/>
               </a:ext>
             </a:extLst>
           </p:cNvPr>
@@ -2630,7 +2630,7 @@
           <p:cNvPr id="3" name="">
             <a:extLst xmlns:a="http://schemas.openxmlformats.org/drawingml/2006/main">
               <a:ext uri="{FF2B5EF4-FFF2-40B4-BE49-F238E27FC236}">
-                <a16:creationId xmlns:a16="http://schemas.microsoft.com/office/drawing/2014/main" id="{4FC463DC-6880-4ADB-A4D5-58140EB627F9}"/>
+                <a16:creationId xmlns:a16="http://schemas.microsoft.com/office/drawing/2014/main" id="{2B691B76-20FA-4ED3-B30F-64D50DB1EEB4}"/>
               </a:ext>
             </a:extLst>
           </p:cNvPr>
@@ -2687,7 +2687,7 @@
           <p:cNvPr id="4" name="">
             <a:extLst xmlns:a="http://schemas.openxmlformats.org/drawingml/2006/main">
               <a:ext uri="{FF2B5EF4-FFF2-40B4-BE49-F238E27FC236}">
-                <a16:creationId xmlns:a16="http://schemas.microsoft.com/office/drawing/2014/main" id="{06043F77-72EB-4A5A-960B-4FA513D06862}"/>
+                <a16:creationId xmlns:a16="http://schemas.microsoft.com/office/drawing/2014/main" id="{2D662222-FF7E-4046-886D-4E42F03EAADD}"/>
               </a:ext>
             </a:extLst>
           </p:cNvPr>
@@ -2744,7 +2744,7 @@
           <p:cNvPr id="5" name="">
             <a:extLst xmlns:a="http://schemas.openxmlformats.org/drawingml/2006/main">
               <a:ext uri="{FF2B5EF4-FFF2-40B4-BE49-F238E27FC236}">
-                <a16:creationId xmlns:a16="http://schemas.microsoft.com/office/drawing/2014/main" id="{697CBEB4-0449-474B-B8A4-023E9121772C}"/>
+                <a16:creationId xmlns:a16="http://schemas.microsoft.com/office/drawing/2014/main" id="{DB47AA2E-1E0A-4F4B-94D6-6537613388FA}"/>
               </a:ext>
             </a:extLst>
           </p:cNvPr>
@@ -2801,7 +2801,7 @@
           <p:cNvPr id="6" name="">
             <a:extLst xmlns:a="http://schemas.openxmlformats.org/drawingml/2006/main">
               <a:ext uri="{FF2B5EF4-FFF2-40B4-BE49-F238E27FC236}">
-                <a16:creationId xmlns:a16="http://schemas.microsoft.com/office/drawing/2014/main" id="{4CE9EBF5-9320-4E91-8479-43F21B57DC24}"/>
+                <a16:creationId xmlns:a16="http://schemas.microsoft.com/office/drawing/2014/main" id="{A9A1189B-58D6-42A4-B2C7-919354212023}"/>
               </a:ext>
             </a:extLst>
           </p:cNvPr>
@@ -2835,7 +2835,7 @@
           <p:cNvPr id="7" name="">
             <a:extLst xmlns:a="http://schemas.openxmlformats.org/drawingml/2006/main">
               <a:ext uri="{FF2B5EF4-FFF2-40B4-BE49-F238E27FC236}">
-                <a16:creationId xmlns:a16="http://schemas.microsoft.com/office/drawing/2014/main" id="{969EB343-FF00-46CA-B8D3-131F69EB550A}"/>
+                <a16:creationId xmlns:a16="http://schemas.microsoft.com/office/drawing/2014/main" id="{A866AC0E-BB82-4934-B6B8-4C69CEA5F5C6}"/>
               </a:ext>
             </a:extLst>
           </p:cNvPr>
@@ -2867,7 +2867,7 @@
           <p:cNvPr id="8" name="">
             <a:extLst xmlns:a="http://schemas.openxmlformats.org/drawingml/2006/main">
               <a:ext uri="{FF2B5EF4-FFF2-40B4-BE49-F238E27FC236}">
-                <a16:creationId xmlns:a16="http://schemas.microsoft.com/office/drawing/2014/main" id="{5E6B8412-271F-466B-BA6D-F1B70B99857E}"/>
+                <a16:creationId xmlns:a16="http://schemas.microsoft.com/office/drawing/2014/main" id="{8AA9477B-3484-4F39-9E12-928DC2400AA2}"/>
               </a:ext>
             </a:extLst>
           </p:cNvPr>
@@ -2924,7 +2924,7 @@
           <p:cNvPr id="9" name="">
             <a:extLst xmlns:a="http://schemas.openxmlformats.org/drawingml/2006/main">
               <a:ext uri="{FF2B5EF4-FFF2-40B4-BE49-F238E27FC236}">
-                <a16:creationId xmlns:a16="http://schemas.microsoft.com/office/drawing/2014/main" id="{91D25AE4-6303-4196-B270-69704A02DCA3}"/>
+                <a16:creationId xmlns:a16="http://schemas.microsoft.com/office/drawing/2014/main" id="{7A5C43F4-D1F8-4C21-BC98-EB859BD4DA0D}"/>
               </a:ext>
             </a:extLst>
           </p:cNvPr>
@@ -2981,7 +2981,7 @@
           <p:cNvPr id="10" name="">
             <a:extLst xmlns:a="http://schemas.openxmlformats.org/drawingml/2006/main">
               <a:ext uri="{FF2B5EF4-FFF2-40B4-BE49-F238E27FC236}">
-                <a16:creationId xmlns:a16="http://schemas.microsoft.com/office/drawing/2014/main" id="{88065726-38C0-45DE-A80E-A8B60ADAF62B}"/>
+                <a16:creationId xmlns:a16="http://schemas.microsoft.com/office/drawing/2014/main" id="{B5C5E693-7F5B-4959-B816-1BD8B462EDFC}"/>
               </a:ext>
             </a:extLst>
           </p:cNvPr>
@@ -3038,7 +3038,7 @@
           <p:cNvPr id="11" name="">
             <a:extLst xmlns:a="http://schemas.openxmlformats.org/drawingml/2006/main">
               <a:ext uri="{FF2B5EF4-FFF2-40B4-BE49-F238E27FC236}">
-                <a16:creationId xmlns:a16="http://schemas.microsoft.com/office/drawing/2014/main" id="{5329AE2E-09BC-4C58-8C71-C412F1A9BDDA}"/>
+                <a16:creationId xmlns:a16="http://schemas.microsoft.com/office/drawing/2014/main" id="{CDB9A1CB-E255-425D-9775-643A68EDEF62}"/>
               </a:ext>
             </a:extLst>
           </p:cNvPr>
@@ -3095,7 +3095,7 @@
           <p:cNvPr id="12" name="">
             <a:extLst xmlns:a="http://schemas.openxmlformats.org/drawingml/2006/main">
               <a:ext uri="{FF2B5EF4-FFF2-40B4-BE49-F238E27FC236}">
-                <a16:creationId xmlns:a16="http://schemas.microsoft.com/office/drawing/2014/main" id="{9FBFE27B-545D-4D15-8AC7-25F0E748E7A9}"/>
+                <a16:creationId xmlns:a16="http://schemas.microsoft.com/office/drawing/2014/main" id="{6F3D8B00-84AB-4C76-AFB4-69B8BEDF5CAF}"/>
               </a:ext>
             </a:extLst>
           </p:cNvPr>
@@ -3152,7 +3152,7 @@
           <p:cNvPr id="13" name="">
             <a:extLst xmlns:a="http://schemas.openxmlformats.org/drawingml/2006/main">
               <a:ext uri="{FF2B5EF4-FFF2-40B4-BE49-F238E27FC236}">
-                <a16:creationId xmlns:a16="http://schemas.microsoft.com/office/drawing/2014/main" id="{CD5D6EB2-36B8-4EFB-AFDD-D2015C559F4B}"/>
+                <a16:creationId xmlns:a16="http://schemas.microsoft.com/office/drawing/2014/main" id="{784285A4-EAF4-4B81-A237-B9E69FC0D31E}"/>
               </a:ext>
             </a:extLst>
           </p:cNvPr>
@@ -3209,7 +3209,7 @@
           <p:cNvPr id="14" name="">
             <a:extLst xmlns:a="http://schemas.openxmlformats.org/drawingml/2006/main">
               <a:ext uri="{FF2B5EF4-FFF2-40B4-BE49-F238E27FC236}">
-                <a16:creationId xmlns:a16="http://schemas.microsoft.com/office/drawing/2014/main" id="{66F33E5F-FC8B-444F-BC4D-3607E2DB38CF}"/>
+                <a16:creationId xmlns:a16="http://schemas.microsoft.com/office/drawing/2014/main" id="{3C26FFB8-D823-4036-BCE0-59A21DA5FCD0}"/>
               </a:ext>
             </a:extLst>
           </p:cNvPr>
@@ -3241,7 +3241,7 @@
           <p:cNvPr id="15" name="">
             <a:extLst xmlns:a="http://schemas.openxmlformats.org/drawingml/2006/main">
               <a:ext uri="{FF2B5EF4-FFF2-40B4-BE49-F238E27FC236}">
-                <a16:creationId xmlns:a16="http://schemas.microsoft.com/office/drawing/2014/main" id="{DA83791E-AA08-48F6-91AA-2ECA8FCF4513}"/>
+                <a16:creationId xmlns:a16="http://schemas.microsoft.com/office/drawing/2014/main" id="{2B212F71-C0AB-4AA7-8EDD-43974874D652}"/>
               </a:ext>
             </a:extLst>
           </p:cNvPr>
@@ -3288,7 +3288,7 @@
                   <a:srgbClr val="0B706F"/>
                 </a:solidFill>
               </a:rPr>
-              <a:t>DEF-00030</a:t>
+              <a:t>DEF-00019</a:t>
             </a:r>
           </a:p>
         </p:txBody>
@@ -3298,7 +3298,7 @@
           <p:cNvPr id="16" name="">
             <a:extLst xmlns:a="http://schemas.openxmlformats.org/drawingml/2006/main">
               <a:ext uri="{FF2B5EF4-FFF2-40B4-BE49-F238E27FC236}">
-                <a16:creationId xmlns:a16="http://schemas.microsoft.com/office/drawing/2014/main" id="{4AE8D801-7BE3-4861-84A1-BEC3C3756FAE}"/>
+                <a16:creationId xmlns:a16="http://schemas.microsoft.com/office/drawing/2014/main" id="{A9D13401-770A-494A-82C1-0D99E3AC9B2B}"/>
               </a:ext>
             </a:extLst>
           </p:cNvPr>
@@ -3345,7 +3345,7 @@
                   <a:srgbClr val="17212B"/>
                 </a:solidFill>
               </a:rPr>
-              <a:t>VIB_FAIL on PRD-00272</a:t>
+              <a:t>SOLDER_COLD on PRD-00021</a:t>
             </a:r>
           </a:p>
         </p:txBody>
@@ -3355,7 +3355,7 @@
           <p:cNvPr id="17" name="">
             <a:extLst xmlns:a="http://schemas.openxmlformats.org/drawingml/2006/main">
               <a:ext uri="{FF2B5EF4-FFF2-40B4-BE49-F238E27FC236}">
-                <a16:creationId xmlns:a16="http://schemas.microsoft.com/office/drawing/2014/main" id="{9CAFA3F8-6771-45F0-B6F5-1D0A6CC8A2C5}"/>
+                <a16:creationId xmlns:a16="http://schemas.microsoft.com/office/drawing/2014/main" id="{9D423C89-F2DD-459F-A290-3D1C6464CE30}"/>
               </a:ext>
             </a:extLst>
           </p:cNvPr>
@@ -3402,7 +3402,7 @@
                   <a:srgbClr val="BF3F35"/>
                 </a:solidFill>
               </a:rPr>
-              <a:t>MO</a:t>
+              <a:t>SC</a:t>
             </a:r>
           </a:p>
         </p:txBody>
@@ -3412,7 +3412,7 @@
           <p:cNvPr id="18" name="">
             <a:extLst xmlns:a="http://schemas.openxmlformats.org/drawingml/2006/main">
               <a:ext uri="{FF2B5EF4-FFF2-40B4-BE49-F238E27FC236}">
-                <a16:creationId xmlns:a16="http://schemas.microsoft.com/office/drawing/2014/main" id="{AB8C91A2-6F00-4F16-BD29-30923B50B0A3}"/>
+                <a16:creationId xmlns:a16="http://schemas.microsoft.com/office/drawing/2014/main" id="{C8489146-9F4B-401C-8530-711434009120}"/>
               </a:ext>
             </a:extLst>
           </p:cNvPr>
@@ -3446,7 +3446,7 @@
           <p:cNvPr id="19" name="">
             <a:extLst xmlns:a="http://schemas.openxmlformats.org/drawingml/2006/main">
               <a:ext uri="{FF2B5EF4-FFF2-40B4-BE49-F238E27FC236}">
-                <a16:creationId xmlns:a16="http://schemas.microsoft.com/office/drawing/2014/main" id="{ABE1BD32-1A48-433B-9EAB-38B32AFECBC9}"/>
+                <a16:creationId xmlns:a16="http://schemas.microsoft.com/office/drawing/2014/main" id="{BF5FC407-2B9C-4F58-82F4-021CF790222B}"/>
               </a:ext>
             </a:extLst>
           </p:cNvPr>
@@ -3503,7 +3503,7 @@
           <p:cNvPr id="20" name="">
             <a:extLst xmlns:a="http://schemas.openxmlformats.org/drawingml/2006/main">
               <a:ext uri="{FF2B5EF4-FFF2-40B4-BE49-F238E27FC236}">
-                <a16:creationId xmlns:a16="http://schemas.microsoft.com/office/drawing/2014/main" id="{3F286080-0823-4607-A23D-74E2D91BE3BD}"/>
+                <a16:creationId xmlns:a16="http://schemas.microsoft.com/office/drawing/2014/main" id="{C2C887C8-E371-4946-A37F-BAFEEB55B5D7}"/>
               </a:ext>
             </a:extLst>
           </p:cNvPr>
@@ -3537,7 +3537,7 @@
           <p:cNvPr id="21" name="">
             <a:extLst xmlns:a="http://schemas.openxmlformats.org/drawingml/2006/main">
               <a:ext uri="{FF2B5EF4-FFF2-40B4-BE49-F238E27FC236}">
-                <a16:creationId xmlns:a16="http://schemas.microsoft.com/office/drawing/2014/main" id="{1EFE0A93-C895-4941-A9DB-29F593C4BC73}"/>
+                <a16:creationId xmlns:a16="http://schemas.microsoft.com/office/drawing/2014/main" id="{A60D0509-DF57-4CF8-B44D-6C4ACEC1676B}"/>
               </a:ext>
             </a:extLst>
           </p:cNvPr>
@@ -3594,7 +3594,7 @@
           <p:cNvPr id="22" name="">
             <a:extLst xmlns:a="http://schemas.openxmlformats.org/drawingml/2006/main">
               <a:ext uri="{FF2B5EF4-FFF2-40B4-BE49-F238E27FC236}">
-                <a16:creationId xmlns:a16="http://schemas.microsoft.com/office/drawing/2014/main" id="{4D351D34-B551-4342-AE88-2CB898E15925}"/>
+                <a16:creationId xmlns:a16="http://schemas.microsoft.com/office/drawing/2014/main" id="{24E3F4E7-C4E3-4EC6-B73F-1ADA6C5DA96C}"/>
               </a:ext>
             </a:extLst>
           </p:cNvPr>
@@ -3651,7 +3651,7 @@
           <p:cNvPr id="23" name="">
             <a:extLst xmlns:a="http://schemas.openxmlformats.org/drawingml/2006/main">
               <a:ext uri="{FF2B5EF4-FFF2-40B4-BE49-F238E27FC236}">
-                <a16:creationId xmlns:a16="http://schemas.microsoft.com/office/drawing/2014/main" id="{E59B45F7-417A-4B28-94FB-E10E649BC37A}"/>
+                <a16:creationId xmlns:a16="http://schemas.microsoft.com/office/drawing/2014/main" id="{C6E1FEEF-6100-46CC-A280-DF7B4126CE14}"/>
               </a:ext>
             </a:extLst>
           </p:cNvPr>
@@ -3683,7 +3683,7 @@
           <p:cNvPr id="24" name="">
             <a:extLst xmlns:a="http://schemas.openxmlformats.org/drawingml/2006/main">
               <a:ext uri="{FF2B5EF4-FFF2-40B4-BE49-F238E27FC236}">
-                <a16:creationId xmlns:a16="http://schemas.microsoft.com/office/drawing/2014/main" id="{F841DC70-3431-4324-A1D6-8D74AB7E9077}"/>
+                <a16:creationId xmlns:a16="http://schemas.microsoft.com/office/drawing/2014/main" id="{3DD021CB-6C3A-468D-A957-F1B4359A2B73}"/>
               </a:ext>
             </a:extLst>
           </p:cNvPr>
@@ -3715,7 +3715,7 @@
           <p:cNvPr id="25" name="">
             <a:extLst xmlns:a="http://schemas.openxmlformats.org/drawingml/2006/main">
               <a:ext uri="{FF2B5EF4-FFF2-40B4-BE49-F238E27FC236}">
-                <a16:creationId xmlns:a16="http://schemas.microsoft.com/office/drawing/2014/main" id="{6E5353A2-B294-43A9-9F8C-3D2625AE5D17}"/>
+                <a16:creationId xmlns:a16="http://schemas.microsoft.com/office/drawing/2014/main" id="{F95F2190-2853-4B02-ABBB-DE43EE778C98}"/>
               </a:ext>
             </a:extLst>
           </p:cNvPr>
@@ -3762,7 +3762,7 @@
                   <a:srgbClr val="0B706F"/>
                 </a:solidFill>
               </a:rPr>
-              <a:t>DEF-00037</a:t>
+              <a:t>DEF-00007</a:t>
             </a:r>
           </a:p>
         </p:txBody>
@@ -3772,7 +3772,7 @@
           <p:cNvPr id="26" name="">
             <a:extLst xmlns:a="http://schemas.openxmlformats.org/drawingml/2006/main">
               <a:ext uri="{FF2B5EF4-FFF2-40B4-BE49-F238E27FC236}">
-                <a16:creationId xmlns:a16="http://schemas.microsoft.com/office/drawing/2014/main" id="{F1A7C764-EFE7-4132-8831-0CB334A75E59}"/>
+                <a16:creationId xmlns:a16="http://schemas.microsoft.com/office/drawing/2014/main" id="{5E57EAC8-2236-4B98-853F-1F476C7C5C37}"/>
               </a:ext>
             </a:extLst>
           </p:cNvPr>
@@ -3819,7 +3819,7 @@
                   <a:srgbClr val="17212B"/>
                 </a:solidFill>
               </a:rPr>
-              <a:t>VIB_FAIL on PRD-00485</a:t>
+              <a:t>SOLDER_COLD on PRD-00018</a:t>
             </a:r>
           </a:p>
         </p:txBody>
@@ -3829,7 +3829,7 @@
           <p:cNvPr id="27" name="">
             <a:extLst xmlns:a="http://schemas.openxmlformats.org/drawingml/2006/main">
               <a:ext uri="{FF2B5EF4-FFF2-40B4-BE49-F238E27FC236}">
-                <a16:creationId xmlns:a16="http://schemas.microsoft.com/office/drawing/2014/main" id="{06EEFA06-9677-4579-BCD2-BEF814227C0C}"/>
+                <a16:creationId xmlns:a16="http://schemas.microsoft.com/office/drawing/2014/main" id="{028E2873-E5A4-4C28-B6F7-F3A57419F810}"/>
               </a:ext>
             </a:extLst>
           </p:cNvPr>
@@ -3876,7 +3876,7 @@
                   <a:srgbClr val="BF3F35"/>
                 </a:solidFill>
               </a:rPr>
-              <a:t>MO</a:t>
+              <a:t>SC</a:t>
             </a:r>
           </a:p>
         </p:txBody>
@@ -3886,7 +3886,7 @@
           <p:cNvPr id="28" name="">
             <a:extLst xmlns:a="http://schemas.openxmlformats.org/drawingml/2006/main">
               <a:ext uri="{FF2B5EF4-FFF2-40B4-BE49-F238E27FC236}">
-                <a16:creationId xmlns:a16="http://schemas.microsoft.com/office/drawing/2014/main" id="{FF417347-FB68-49E0-B003-B563A84B88A5}"/>
+                <a16:creationId xmlns:a16="http://schemas.microsoft.com/office/drawing/2014/main" id="{45EAC0F0-15CA-4CDC-878D-B7D55C2A3033}"/>
               </a:ext>
             </a:extLst>
           </p:cNvPr>
@@ -3920,7 +3920,7 @@
           <p:cNvPr id="29" name="">
             <a:extLst xmlns:a="http://schemas.openxmlformats.org/drawingml/2006/main">
               <a:ext uri="{FF2B5EF4-FFF2-40B4-BE49-F238E27FC236}">
-                <a16:creationId xmlns:a16="http://schemas.microsoft.com/office/drawing/2014/main" id="{C579DC60-6A51-4FEA-A6B1-D60578253899}"/>
+                <a16:creationId xmlns:a16="http://schemas.microsoft.com/office/drawing/2014/main" id="{86089B97-6877-4FA2-9E3B-D4370AF971DB}"/>
               </a:ext>
             </a:extLst>
           </p:cNvPr>
@@ -3977,7 +3977,7 @@
           <p:cNvPr id="30" name="">
             <a:extLst xmlns:a="http://schemas.openxmlformats.org/drawingml/2006/main">
               <a:ext uri="{FF2B5EF4-FFF2-40B4-BE49-F238E27FC236}">
-                <a16:creationId xmlns:a16="http://schemas.microsoft.com/office/drawing/2014/main" id="{72ED418C-27FC-4D12-8786-4F34C8A8AFEE}"/>
+                <a16:creationId xmlns:a16="http://schemas.microsoft.com/office/drawing/2014/main" id="{C3B6B41E-0A83-4F9C-BB02-5904E1823BFA}"/>
               </a:ext>
             </a:extLst>
           </p:cNvPr>
@@ -4011,7 +4011,7 @@
           <p:cNvPr id="31" name="">
             <a:extLst xmlns:a="http://schemas.openxmlformats.org/drawingml/2006/main">
               <a:ext uri="{FF2B5EF4-FFF2-40B4-BE49-F238E27FC236}">
-                <a16:creationId xmlns:a16="http://schemas.microsoft.com/office/drawing/2014/main" id="{880F5538-4CF1-4EFE-A348-DCDF9148E00E}"/>
+                <a16:creationId xmlns:a16="http://schemas.microsoft.com/office/drawing/2014/main" id="{F87D9E69-084E-469D-A728-2727EB00F97F}"/>
               </a:ext>
             </a:extLst>
           </p:cNvPr>
@@ -4068,7 +4068,7 @@
           <p:cNvPr id="32" name="">
             <a:extLst xmlns:a="http://schemas.openxmlformats.org/drawingml/2006/main">
               <a:ext uri="{FF2B5EF4-FFF2-40B4-BE49-F238E27FC236}">
-                <a16:creationId xmlns:a16="http://schemas.microsoft.com/office/drawing/2014/main" id="{15FC3135-197A-45E0-A5F1-AD22DC1BAD52}"/>
+                <a16:creationId xmlns:a16="http://schemas.microsoft.com/office/drawing/2014/main" id="{57921E65-8C06-46BD-9C13-2E29F597F030}"/>
               </a:ext>
             </a:extLst>
           </p:cNvPr>
@@ -4125,7 +4125,7 @@
           <p:cNvPr id="33" name="">
             <a:extLst xmlns:a="http://schemas.openxmlformats.org/drawingml/2006/main">
               <a:ext uri="{FF2B5EF4-FFF2-40B4-BE49-F238E27FC236}">
-                <a16:creationId xmlns:a16="http://schemas.microsoft.com/office/drawing/2014/main" id="{30A265AE-1797-4739-B3F3-FC656CF3AEB8}"/>
+                <a16:creationId xmlns:a16="http://schemas.microsoft.com/office/drawing/2014/main" id="{24C3C847-1A14-4B14-970D-6102BBF99480}"/>
               </a:ext>
             </a:extLst>
           </p:cNvPr>
@@ -4157,7 +4157,7 @@
           <p:cNvPr id="34" name="">
             <a:extLst xmlns:a="http://schemas.openxmlformats.org/drawingml/2006/main">
               <a:ext uri="{FF2B5EF4-FFF2-40B4-BE49-F238E27FC236}">
-                <a16:creationId xmlns:a16="http://schemas.microsoft.com/office/drawing/2014/main" id="{B3AEDB4D-C5C6-442B-A23A-30F1E61F59A7}"/>
+                <a16:creationId xmlns:a16="http://schemas.microsoft.com/office/drawing/2014/main" id="{7C8EFA8B-3D8F-45A0-BE9E-2040E8E65A2A}"/>
               </a:ext>
             </a:extLst>
           </p:cNvPr>
@@ -4189,7 +4189,7 @@
           <p:cNvPr id="35" name="">
             <a:extLst xmlns:a="http://schemas.openxmlformats.org/drawingml/2006/main">
               <a:ext uri="{FF2B5EF4-FFF2-40B4-BE49-F238E27FC236}">
-                <a16:creationId xmlns:a16="http://schemas.microsoft.com/office/drawing/2014/main" id="{E9F76911-7F25-4CD1-9E6B-58AB608B53D9}"/>
+                <a16:creationId xmlns:a16="http://schemas.microsoft.com/office/drawing/2014/main" id="{3F919C2A-39F3-4062-A110-CED3E964FED3}"/>
               </a:ext>
             </a:extLst>
           </p:cNvPr>
@@ -4236,7 +4236,7 @@
                   <a:srgbClr val="0B706F"/>
                 </a:solidFill>
               </a:rPr>
-              <a:t>DEF-00038</a:t>
+              <a:t>DEF-00012</a:t>
             </a:r>
           </a:p>
         </p:txBody>
@@ -4246,7 +4246,7 @@
           <p:cNvPr id="36" name="">
             <a:extLst xmlns:a="http://schemas.openxmlformats.org/drawingml/2006/main">
               <a:ext uri="{FF2B5EF4-FFF2-40B4-BE49-F238E27FC236}">
-                <a16:creationId xmlns:a16="http://schemas.microsoft.com/office/drawing/2014/main" id="{7986BAEF-FAC0-4704-ACFA-240B7409D75C}"/>
+                <a16:creationId xmlns:a16="http://schemas.microsoft.com/office/drawing/2014/main" id="{9BD862B2-9DF2-44E7-A294-4425BD7BADD7}"/>
               </a:ext>
             </a:extLst>
           </p:cNvPr>
@@ -4293,7 +4293,7 @@
                   <a:srgbClr val="17212B"/>
                 </a:solidFill>
               </a:rPr>
-              <a:t>VIB_FAIL on PRD-00234</a:t>
+              <a:t>SOLDER_COLD on PRD-00002</a:t>
             </a:r>
           </a:p>
         </p:txBody>
@@ -4303,7 +4303,7 @@
           <p:cNvPr id="37" name="">
             <a:extLst xmlns:a="http://schemas.openxmlformats.org/drawingml/2006/main">
               <a:ext uri="{FF2B5EF4-FFF2-40B4-BE49-F238E27FC236}">
-                <a16:creationId xmlns:a16="http://schemas.microsoft.com/office/drawing/2014/main" id="{327FBFB6-1252-4C78-9824-637388B75583}"/>
+                <a16:creationId xmlns:a16="http://schemas.microsoft.com/office/drawing/2014/main" id="{BDB4D08D-DEB3-44CF-9BAD-7CA168C74512}"/>
               </a:ext>
             </a:extLst>
           </p:cNvPr>
@@ -4350,7 +4350,7 @@
                   <a:srgbClr val="BF3F35"/>
                 </a:solidFill>
               </a:rPr>
-              <a:t>MO</a:t>
+              <a:t>SC</a:t>
             </a:r>
           </a:p>
         </p:txBody>
@@ -4360,7 +4360,7 @@
           <p:cNvPr id="38" name="">
             <a:extLst xmlns:a="http://schemas.openxmlformats.org/drawingml/2006/main">
               <a:ext uri="{FF2B5EF4-FFF2-40B4-BE49-F238E27FC236}">
-                <a16:creationId xmlns:a16="http://schemas.microsoft.com/office/drawing/2014/main" id="{A689BF1F-E698-4135-AA36-90E3247A470C}"/>
+                <a16:creationId xmlns:a16="http://schemas.microsoft.com/office/drawing/2014/main" id="{25C3837A-0F8F-4751-81C9-108F92ECC1D7}"/>
               </a:ext>
             </a:extLst>
           </p:cNvPr>
@@ -4394,7 +4394,7 @@
           <p:cNvPr id="39" name="">
             <a:extLst xmlns:a="http://schemas.openxmlformats.org/drawingml/2006/main">
               <a:ext uri="{FF2B5EF4-FFF2-40B4-BE49-F238E27FC236}">
-                <a16:creationId xmlns:a16="http://schemas.microsoft.com/office/drawing/2014/main" id="{2581291E-BA4E-4A37-9D61-81E89108AF3F}"/>
+                <a16:creationId xmlns:a16="http://schemas.microsoft.com/office/drawing/2014/main" id="{BA61696C-82BD-4671-B8EF-F6AA270D2A8F}"/>
               </a:ext>
             </a:extLst>
           </p:cNvPr>
@@ -4451,7 +4451,7 @@
           <p:cNvPr id="40" name="">
             <a:extLst xmlns:a="http://schemas.openxmlformats.org/drawingml/2006/main">
               <a:ext uri="{FF2B5EF4-FFF2-40B4-BE49-F238E27FC236}">
-                <a16:creationId xmlns:a16="http://schemas.microsoft.com/office/drawing/2014/main" id="{101E00D8-582D-41BA-8414-F97E0A1D1444}"/>
+                <a16:creationId xmlns:a16="http://schemas.microsoft.com/office/drawing/2014/main" id="{3F2B449F-376D-4ADC-81D9-EDEB87019D29}"/>
               </a:ext>
             </a:extLst>
           </p:cNvPr>
@@ -4485,7 +4485,7 @@
           <p:cNvPr id="41" name="">
             <a:extLst xmlns:a="http://schemas.openxmlformats.org/drawingml/2006/main">
               <a:ext uri="{FF2B5EF4-FFF2-40B4-BE49-F238E27FC236}">
-                <a16:creationId xmlns:a16="http://schemas.microsoft.com/office/drawing/2014/main" id="{B2CB6B02-544C-4E0A-B6E1-B1674E501E07}"/>
+                <a16:creationId xmlns:a16="http://schemas.microsoft.com/office/drawing/2014/main" id="{68DAC967-7864-4467-9B59-8F6EB94B2EAC}"/>
               </a:ext>
             </a:extLst>
           </p:cNvPr>
@@ -4542,7 +4542,7 @@
           <p:cNvPr id="42" name="">
             <a:extLst xmlns:a="http://schemas.openxmlformats.org/drawingml/2006/main">
               <a:ext uri="{FF2B5EF4-FFF2-40B4-BE49-F238E27FC236}">
-                <a16:creationId xmlns:a16="http://schemas.microsoft.com/office/drawing/2014/main" id="{30913327-9344-4A46-901A-9F27DACE0140}"/>
+                <a16:creationId xmlns:a16="http://schemas.microsoft.com/office/drawing/2014/main" id="{F752A66E-339F-479F-8B36-0EB2FFBB70A6}"/>
               </a:ext>
             </a:extLst>
           </p:cNvPr>
@@ -4599,7 +4599,7 @@
           <p:cNvPr id="43" name="">
             <a:extLst xmlns:a="http://schemas.openxmlformats.org/drawingml/2006/main">
               <a:ext uri="{FF2B5EF4-FFF2-40B4-BE49-F238E27FC236}">
-                <a16:creationId xmlns:a16="http://schemas.microsoft.com/office/drawing/2014/main" id="{AD397C3A-C0C6-4A34-84E8-991964A7F752}"/>
+                <a16:creationId xmlns:a16="http://schemas.microsoft.com/office/drawing/2014/main" id="{05D9AA8A-1547-487E-A92B-E9E96CBAC13F}"/>
               </a:ext>
             </a:extLst>
           </p:cNvPr>
@@ -4631,7 +4631,7 @@
           <p:cNvPr id="44" name="">
             <a:extLst xmlns:a="http://schemas.openxmlformats.org/drawingml/2006/main">
               <a:ext uri="{FF2B5EF4-FFF2-40B4-BE49-F238E27FC236}">
-                <a16:creationId xmlns:a16="http://schemas.microsoft.com/office/drawing/2014/main" id="{CE99B3E3-88CA-4561-9633-58D93E308BBA}"/>
+                <a16:creationId xmlns:a16="http://schemas.microsoft.com/office/drawing/2014/main" id="{976648BA-767B-4FE9-A2EE-1D36B3FC8E8B}"/>
               </a:ext>
             </a:extLst>
           </p:cNvPr>
@@ -4663,7 +4663,7 @@
           <p:cNvPr id="45" name="">
             <a:extLst xmlns:a="http://schemas.openxmlformats.org/drawingml/2006/main">
               <a:ext uri="{FF2B5EF4-FFF2-40B4-BE49-F238E27FC236}">
-                <a16:creationId xmlns:a16="http://schemas.microsoft.com/office/drawing/2014/main" id="{C8C5D19B-DB90-453B-B5F8-38B997E5E25A}"/>
+                <a16:creationId xmlns:a16="http://schemas.microsoft.com/office/drawing/2014/main" id="{F56B7BA3-A330-474E-805F-1F588D92687D}"/>
               </a:ext>
             </a:extLst>
           </p:cNvPr>
@@ -4710,7 +4710,7 @@
                   <a:srgbClr val="0B706F"/>
                 </a:solidFill>
               </a:rPr>
-              <a:t>DEF-00045</a:t>
+              <a:t>DEF-00004</a:t>
             </a:r>
           </a:p>
         </p:txBody>
@@ -4720,7 +4720,7 @@
           <p:cNvPr id="46" name="">
             <a:extLst xmlns:a="http://schemas.openxmlformats.org/drawingml/2006/main">
               <a:ext uri="{FF2B5EF4-FFF2-40B4-BE49-F238E27FC236}">
-                <a16:creationId xmlns:a16="http://schemas.microsoft.com/office/drawing/2014/main" id="{F4C42F07-7F17-4E08-88E4-B4BD3F134C38}"/>
+                <a16:creationId xmlns:a16="http://schemas.microsoft.com/office/drawing/2014/main" id="{9E021218-C739-4CB8-96AF-EB26D3BD9EA4}"/>
               </a:ext>
             </a:extLst>
           </p:cNvPr>
@@ -4767,7 +4767,7 @@
                   <a:srgbClr val="17212B"/>
                 </a:solidFill>
               </a:rPr>
-              <a:t>VIB_FAIL on PRD-00056</a:t>
+              <a:t>SOLDER_COLD on PRD-00027</a:t>
             </a:r>
           </a:p>
         </p:txBody>
@@ -4777,7 +4777,7 @@
           <p:cNvPr id="47" name="">
             <a:extLst xmlns:a="http://schemas.openxmlformats.org/drawingml/2006/main">
               <a:ext uri="{FF2B5EF4-FFF2-40B4-BE49-F238E27FC236}">
-                <a16:creationId xmlns:a16="http://schemas.microsoft.com/office/drawing/2014/main" id="{BDCC354A-8BB8-441C-94A1-66A7012D161B}"/>
+                <a16:creationId xmlns:a16="http://schemas.microsoft.com/office/drawing/2014/main" id="{A17EE71A-9BC2-4DBA-8920-013FF528B002}"/>
               </a:ext>
             </a:extLst>
           </p:cNvPr>
@@ -4824,7 +4824,7 @@
                   <a:srgbClr val="BF3F35"/>
                 </a:solidFill>
               </a:rPr>
-              <a:t>MO</a:t>
+              <a:t>SC</a:t>
             </a:r>
           </a:p>
         </p:txBody>
@@ -4834,7 +4834,7 @@
           <p:cNvPr id="48" name="">
             <a:extLst xmlns:a="http://schemas.openxmlformats.org/drawingml/2006/main">
               <a:ext uri="{FF2B5EF4-FFF2-40B4-BE49-F238E27FC236}">
-                <a16:creationId xmlns:a16="http://schemas.microsoft.com/office/drawing/2014/main" id="{6437FC5E-E931-452E-8C35-96F5E75741E6}"/>
+                <a16:creationId xmlns:a16="http://schemas.microsoft.com/office/drawing/2014/main" id="{5C54FF60-9C30-4C22-9491-76DDDD00404E}"/>
               </a:ext>
             </a:extLst>
           </p:cNvPr>
@@ -4868,7 +4868,7 @@
           <p:cNvPr id="49" name="">
             <a:extLst xmlns:a="http://schemas.openxmlformats.org/drawingml/2006/main">
               <a:ext uri="{FF2B5EF4-FFF2-40B4-BE49-F238E27FC236}">
-                <a16:creationId xmlns:a16="http://schemas.microsoft.com/office/drawing/2014/main" id="{79616D31-8136-4182-8ABE-C16F94FE34EA}"/>
+                <a16:creationId xmlns:a16="http://schemas.microsoft.com/office/drawing/2014/main" id="{15BCBB93-DB41-4D85-AF05-1BC06E6E49ED}"/>
               </a:ext>
             </a:extLst>
           </p:cNvPr>
@@ -4925,7 +4925,7 @@
           <p:cNvPr id="50" name="">
             <a:extLst xmlns:a="http://schemas.openxmlformats.org/drawingml/2006/main">
               <a:ext uri="{FF2B5EF4-FFF2-40B4-BE49-F238E27FC236}">
-                <a16:creationId xmlns:a16="http://schemas.microsoft.com/office/drawing/2014/main" id="{E6BF2944-A5C1-4C01-AD4A-4318AFD2272B}"/>
+                <a16:creationId xmlns:a16="http://schemas.microsoft.com/office/drawing/2014/main" id="{B269FC66-4BCA-4CF1-891A-D797E01C917A}"/>
               </a:ext>
             </a:extLst>
           </p:cNvPr>
@@ -4959,7 +4959,7 @@
           <p:cNvPr id="51" name="">
             <a:extLst xmlns:a="http://schemas.openxmlformats.org/drawingml/2006/main">
               <a:ext uri="{FF2B5EF4-FFF2-40B4-BE49-F238E27FC236}">
-                <a16:creationId xmlns:a16="http://schemas.microsoft.com/office/drawing/2014/main" id="{44B618A4-23D4-43DB-B405-3BA6007F9A33}"/>
+                <a16:creationId xmlns:a16="http://schemas.microsoft.com/office/drawing/2014/main" id="{174CE1CD-FEC2-430F-86CF-643309FF524F}"/>
               </a:ext>
             </a:extLst>
           </p:cNvPr>
@@ -5016,7 +5016,7 @@
           <p:cNvPr id="52" name="">
             <a:extLst xmlns:a="http://schemas.openxmlformats.org/drawingml/2006/main">
               <a:ext uri="{FF2B5EF4-FFF2-40B4-BE49-F238E27FC236}">
-                <a16:creationId xmlns:a16="http://schemas.microsoft.com/office/drawing/2014/main" id="{1CA0D6B8-48D7-41FE-A5BF-8BE7B9FFB4CC}"/>
+                <a16:creationId xmlns:a16="http://schemas.microsoft.com/office/drawing/2014/main" id="{8859F7BF-32A1-4310-96A2-2DA0688B6A64}"/>
               </a:ext>
             </a:extLst>
           </p:cNvPr>
@@ -5073,7 +5073,7 @@
           <p:cNvPr id="53" name="">
             <a:extLst xmlns:a="http://schemas.openxmlformats.org/drawingml/2006/main">
               <a:ext uri="{FF2B5EF4-FFF2-40B4-BE49-F238E27FC236}">
-                <a16:creationId xmlns:a16="http://schemas.microsoft.com/office/drawing/2014/main" id="{CC90F466-A67D-498E-A371-0158B6F1922E}"/>
+                <a16:creationId xmlns:a16="http://schemas.microsoft.com/office/drawing/2014/main" id="{5BA85EB6-498A-4DE3-8A0B-6A935E4CD26E}"/>
               </a:ext>
             </a:extLst>
           </p:cNvPr>
@@ -5105,7 +5105,7 @@
           <p:cNvPr id="54" name="">
             <a:extLst xmlns:a="http://schemas.openxmlformats.org/drawingml/2006/main">
               <a:ext uri="{FF2B5EF4-FFF2-40B4-BE49-F238E27FC236}">
-                <a16:creationId xmlns:a16="http://schemas.microsoft.com/office/drawing/2014/main" id="{94A477AA-7CE0-4329-AB44-305A3A2E257D}"/>
+                <a16:creationId xmlns:a16="http://schemas.microsoft.com/office/drawing/2014/main" id="{A0955521-4A00-437A-BF8D-743838FB04AB}"/>
               </a:ext>
             </a:extLst>
           </p:cNvPr>
@@ -5137,7 +5137,7 @@
           <p:cNvPr id="55" name="">
             <a:extLst xmlns:a="http://schemas.openxmlformats.org/drawingml/2006/main">
               <a:ext uri="{FF2B5EF4-FFF2-40B4-BE49-F238E27FC236}">
-                <a16:creationId xmlns:a16="http://schemas.microsoft.com/office/drawing/2014/main" id="{178F2847-5F5A-494E-B0EC-CC9280D2A0F6}"/>
+                <a16:creationId xmlns:a16="http://schemas.microsoft.com/office/drawing/2014/main" id="{E4567B9B-7CE6-4920-93B6-E2FD953E0203}"/>
               </a:ext>
             </a:extLst>
           </p:cNvPr>
@@ -5184,7 +5184,7 @@
                   <a:srgbClr val="0B706F"/>
                 </a:solidFill>
               </a:rPr>
-              <a:t>DEF-00029</a:t>
+              <a:t>DEF-00023</a:t>
             </a:r>
           </a:p>
         </p:txBody>
@@ -5194,7 +5194,7 @@
           <p:cNvPr id="56" name="">
             <a:extLst xmlns:a="http://schemas.openxmlformats.org/drawingml/2006/main">
               <a:ext uri="{FF2B5EF4-FFF2-40B4-BE49-F238E27FC236}">
-                <a16:creationId xmlns:a16="http://schemas.microsoft.com/office/drawing/2014/main" id="{B05391B8-3E44-41C1-84C0-1312DC6F05C7}"/>
+                <a16:creationId xmlns:a16="http://schemas.microsoft.com/office/drawing/2014/main" id="{4EC5A725-9072-4CE1-82D7-79F6774B987E}"/>
               </a:ext>
             </a:extLst>
           </p:cNvPr>
@@ -5241,7 +5241,7 @@
                   <a:srgbClr val="17212B"/>
                 </a:solidFill>
               </a:rPr>
-              <a:t>VIB_FAIL on PRD-00491</a:t>
+              <a:t>SOLDER_COLD on PRD-00016</a:t>
             </a:r>
           </a:p>
         </p:txBody>
@@ -5251,7 +5251,7 @@
           <p:cNvPr id="57" name="">
             <a:extLst xmlns:a="http://schemas.openxmlformats.org/drawingml/2006/main">
               <a:ext uri="{FF2B5EF4-FFF2-40B4-BE49-F238E27FC236}">
-                <a16:creationId xmlns:a16="http://schemas.microsoft.com/office/drawing/2014/main" id="{99904882-083C-4A93-9781-90E2A6401B05}"/>
+                <a16:creationId xmlns:a16="http://schemas.microsoft.com/office/drawing/2014/main" id="{2DE3EB0E-D96D-4106-80ED-C1F50AF51C7C}"/>
               </a:ext>
             </a:extLst>
           </p:cNvPr>
@@ -5298,7 +5298,7 @@
                   <a:srgbClr val="BF3F35"/>
                 </a:solidFill>
               </a:rPr>
-              <a:t>MO</a:t>
+              <a:t>SC</a:t>
             </a:r>
           </a:p>
         </p:txBody>
@@ -5308,7 +5308,7 @@
           <p:cNvPr id="58" name="">
             <a:extLst xmlns:a="http://schemas.openxmlformats.org/drawingml/2006/main">
               <a:ext uri="{FF2B5EF4-FFF2-40B4-BE49-F238E27FC236}">
-                <a16:creationId xmlns:a16="http://schemas.microsoft.com/office/drawing/2014/main" id="{D9A0FCA2-7651-465D-B495-67775D92D8D9}"/>
+                <a16:creationId xmlns:a16="http://schemas.microsoft.com/office/drawing/2014/main" id="{D187E7B9-3084-4624-8FE4-A33A8632615F}"/>
               </a:ext>
             </a:extLst>
           </p:cNvPr>
@@ -5342,7 +5342,7 @@
           <p:cNvPr id="59" name="">
             <a:extLst xmlns:a="http://schemas.openxmlformats.org/drawingml/2006/main">
               <a:ext uri="{FF2B5EF4-FFF2-40B4-BE49-F238E27FC236}">
-                <a16:creationId xmlns:a16="http://schemas.microsoft.com/office/drawing/2014/main" id="{BAD06D7A-7626-49E3-9188-7ED5388EDE36}"/>
+                <a16:creationId xmlns:a16="http://schemas.microsoft.com/office/drawing/2014/main" id="{7A5B3826-1FDA-4B60-9A61-EDC05372B46C}"/>
               </a:ext>
             </a:extLst>
           </p:cNvPr>
@@ -5399,7 +5399,7 @@
           <p:cNvPr id="60" name="">
             <a:extLst xmlns:a="http://schemas.openxmlformats.org/drawingml/2006/main">
               <a:ext uri="{FF2B5EF4-FFF2-40B4-BE49-F238E27FC236}">
-                <a16:creationId xmlns:a16="http://schemas.microsoft.com/office/drawing/2014/main" id="{58E67515-5BB5-46B1-A4E4-8C3BF0ED0C18}"/>
+                <a16:creationId xmlns:a16="http://schemas.microsoft.com/office/drawing/2014/main" id="{41AE709E-BC8E-43E4-BB2F-4EA6BABFA330}"/>
               </a:ext>
             </a:extLst>
           </p:cNvPr>
@@ -5433,7 +5433,7 @@
           <p:cNvPr id="61" name="">
             <a:extLst xmlns:a="http://schemas.openxmlformats.org/drawingml/2006/main">
               <a:ext uri="{FF2B5EF4-FFF2-40B4-BE49-F238E27FC236}">
-                <a16:creationId xmlns:a16="http://schemas.microsoft.com/office/drawing/2014/main" id="{B8B78A70-447E-4C28-ADCF-F67BD6F57BC4}"/>
+                <a16:creationId xmlns:a16="http://schemas.microsoft.com/office/drawing/2014/main" id="{B9EC143D-2266-4E90-99DA-3B426BF0C1A5}"/>
               </a:ext>
             </a:extLst>
           </p:cNvPr>
@@ -5490,7 +5490,7 @@
           <p:cNvPr id="62" name="">
             <a:extLst xmlns:a="http://schemas.openxmlformats.org/drawingml/2006/main">
               <a:ext uri="{FF2B5EF4-FFF2-40B4-BE49-F238E27FC236}">
-                <a16:creationId xmlns:a16="http://schemas.microsoft.com/office/drawing/2014/main" id="{093D2261-340E-473A-A604-4BD91EDAD5C1}"/>
+                <a16:creationId xmlns:a16="http://schemas.microsoft.com/office/drawing/2014/main" id="{7E8B2C54-3039-4111-940B-4DBEA04D9B6B}"/>
               </a:ext>
             </a:extLst>
           </p:cNvPr>
@@ -5547,7 +5547,7 @@
           <p:cNvPr id="63" name="">
             <a:extLst xmlns:a="http://schemas.openxmlformats.org/drawingml/2006/main">
               <a:ext uri="{FF2B5EF4-FFF2-40B4-BE49-F238E27FC236}">
-                <a16:creationId xmlns:a16="http://schemas.microsoft.com/office/drawing/2014/main" id="{D1E51B83-6279-4E3A-9D0D-6655AB517483}"/>
+                <a16:creationId xmlns:a16="http://schemas.microsoft.com/office/drawing/2014/main" id="{91A10508-3B28-41B2-BDFC-868B0E3719FA}"/>
               </a:ext>
             </a:extLst>
           </p:cNvPr>
@@ -5579,7 +5579,7 @@
           <p:cNvPr id="64" name="">
             <a:extLst xmlns:a="http://schemas.openxmlformats.org/drawingml/2006/main">
               <a:ext uri="{FF2B5EF4-FFF2-40B4-BE49-F238E27FC236}">
-                <a16:creationId xmlns:a16="http://schemas.microsoft.com/office/drawing/2014/main" id="{BBA6B81C-8660-48A3-B884-DBFD66C6C8DB}"/>
+                <a16:creationId xmlns:a16="http://schemas.microsoft.com/office/drawing/2014/main" id="{8E68A8A6-8941-4D32-9253-7292DE5665EE}"/>
               </a:ext>
             </a:extLst>
           </p:cNvPr>
@@ -5611,7 +5611,7 @@
           <p:cNvPr id="65" name="">
             <a:extLst xmlns:a="http://schemas.openxmlformats.org/drawingml/2006/main">
               <a:ext uri="{FF2B5EF4-FFF2-40B4-BE49-F238E27FC236}">
-                <a16:creationId xmlns:a16="http://schemas.microsoft.com/office/drawing/2014/main" id="{059669D8-0B8C-4569-95DA-0B7E69FCA607}"/>
+                <a16:creationId xmlns:a16="http://schemas.microsoft.com/office/drawing/2014/main" id="{32CAD304-5E1F-4B36-A8E0-B9DD64F52641}"/>
               </a:ext>
             </a:extLst>
           </p:cNvPr>
@@ -5658,7 +5658,7 @@
                   <a:srgbClr val="0B706F"/>
                 </a:solidFill>
               </a:rPr>
-              <a:t>DEF-00044</a:t>
+              <a:t>DEF-00013</a:t>
             </a:r>
           </a:p>
         </p:txBody>
@@ -5668,7 +5668,7 @@
           <p:cNvPr id="66" name="">
             <a:extLst xmlns:a="http://schemas.openxmlformats.org/drawingml/2006/main">
               <a:ext uri="{FF2B5EF4-FFF2-40B4-BE49-F238E27FC236}">
-                <a16:creationId xmlns:a16="http://schemas.microsoft.com/office/drawing/2014/main" id="{5A4A3545-FD9F-4300-9C70-3A526287C0C2}"/>
+                <a16:creationId xmlns:a16="http://schemas.microsoft.com/office/drawing/2014/main" id="{C14EB2F0-8EC6-4092-B123-583B6ECE6EBC}"/>
               </a:ext>
             </a:extLst>
           </p:cNvPr>
@@ -5715,7 +5715,7 @@
                   <a:srgbClr val="17212B"/>
                 </a:solidFill>
               </a:rPr>
-              <a:t>VIB_FAIL on PRD-00037</a:t>
+              <a:t>SOLDER_COLD on PRD-00017</a:t>
             </a:r>
           </a:p>
         </p:txBody>
@@ -5725,7 +5725,7 @@
           <p:cNvPr id="67" name="">
             <a:extLst xmlns:a="http://schemas.openxmlformats.org/drawingml/2006/main">
               <a:ext uri="{FF2B5EF4-FFF2-40B4-BE49-F238E27FC236}">
-                <a16:creationId xmlns:a16="http://schemas.microsoft.com/office/drawing/2014/main" id="{FE918FBD-1123-437A-96EC-C48A57255145}"/>
+                <a16:creationId xmlns:a16="http://schemas.microsoft.com/office/drawing/2014/main" id="{86175F53-1417-4EAB-A8D3-E054FE7B63CA}"/>
               </a:ext>
             </a:extLst>
           </p:cNvPr>
@@ -5772,7 +5772,7 @@
                   <a:srgbClr val="BF3F35"/>
                 </a:solidFill>
               </a:rPr>
-              <a:t>MO</a:t>
+              <a:t>SC</a:t>
             </a:r>
           </a:p>
         </p:txBody>
@@ -5782,7 +5782,7 @@
           <p:cNvPr id="68" name="">
             <a:extLst xmlns:a="http://schemas.openxmlformats.org/drawingml/2006/main">
               <a:ext uri="{FF2B5EF4-FFF2-40B4-BE49-F238E27FC236}">
-                <a16:creationId xmlns:a16="http://schemas.microsoft.com/office/drawing/2014/main" id="{DD76E0FF-6BCA-45AB-8C69-E534BAAB965D}"/>
+                <a16:creationId xmlns:a16="http://schemas.microsoft.com/office/drawing/2014/main" id="{1A1EFAC0-3A79-4D5D-A1D1-A334B56F1EAC}"/>
               </a:ext>
             </a:extLst>
           </p:cNvPr>
@@ -5816,7 +5816,7 @@
           <p:cNvPr id="69" name="">
             <a:extLst xmlns:a="http://schemas.openxmlformats.org/drawingml/2006/main">
               <a:ext uri="{FF2B5EF4-FFF2-40B4-BE49-F238E27FC236}">
-                <a16:creationId xmlns:a16="http://schemas.microsoft.com/office/drawing/2014/main" id="{B8EB75BB-02ED-4FBC-AEBD-5E8C3248B56D}"/>
+                <a16:creationId xmlns:a16="http://schemas.microsoft.com/office/drawing/2014/main" id="{E2D83340-492A-48E2-A732-8FF5DE1237C3}"/>
               </a:ext>
             </a:extLst>
           </p:cNvPr>
@@ -5873,7 +5873,7 @@
           <p:cNvPr id="70" name="">
             <a:extLst xmlns:a="http://schemas.openxmlformats.org/drawingml/2006/main">
               <a:ext uri="{FF2B5EF4-FFF2-40B4-BE49-F238E27FC236}">
-                <a16:creationId xmlns:a16="http://schemas.microsoft.com/office/drawing/2014/main" id="{0F3F5F31-0CC1-4A80-8D34-723F8F5994F2}"/>
+                <a16:creationId xmlns:a16="http://schemas.microsoft.com/office/drawing/2014/main" id="{848B1E9C-3751-4956-8F80-1C5E479BAAAA}"/>
               </a:ext>
             </a:extLst>
           </p:cNvPr>
@@ -5907,7 +5907,7 @@
           <p:cNvPr id="71" name="">
             <a:extLst xmlns:a="http://schemas.openxmlformats.org/drawingml/2006/main">
               <a:ext uri="{FF2B5EF4-FFF2-40B4-BE49-F238E27FC236}">
-                <a16:creationId xmlns:a16="http://schemas.microsoft.com/office/drawing/2014/main" id="{25A20A58-A08D-40AF-81D8-05DB62339D3A}"/>
+                <a16:creationId xmlns:a16="http://schemas.microsoft.com/office/drawing/2014/main" id="{8B380641-8142-4E1C-BA49-EBF4FCFEC50A}"/>
               </a:ext>
             </a:extLst>
           </p:cNvPr>
@@ -5964,7 +5964,7 @@
           <p:cNvPr id="72" name="">
             <a:extLst xmlns:a="http://schemas.openxmlformats.org/drawingml/2006/main">
               <a:ext uri="{FF2B5EF4-FFF2-40B4-BE49-F238E27FC236}">
-                <a16:creationId xmlns:a16="http://schemas.microsoft.com/office/drawing/2014/main" id="{BA1AC209-26B8-4D7F-901A-DFA562970AA3}"/>
+                <a16:creationId xmlns:a16="http://schemas.microsoft.com/office/drawing/2014/main" id="{616B64AE-161D-4911-BD8E-71F9FD6B6653}"/>
               </a:ext>
             </a:extLst>
           </p:cNvPr>
@@ -6021,7 +6021,7 @@
           <p:cNvPr id="73" name="">
             <a:extLst xmlns:a="http://schemas.openxmlformats.org/drawingml/2006/main">
               <a:ext uri="{FF2B5EF4-FFF2-40B4-BE49-F238E27FC236}">
-                <a16:creationId xmlns:a16="http://schemas.microsoft.com/office/drawing/2014/main" id="{E74EAF0C-F117-4CFC-A53A-8C3DE78DEBD6}"/>
+                <a16:creationId xmlns:a16="http://schemas.microsoft.com/office/drawing/2014/main" id="{BFEE7D64-C555-4C2A-804C-442E9DA9FE55}"/>
               </a:ext>
             </a:extLst>
           </p:cNvPr>
@@ -6053,7 +6053,7 @@
           <p:cNvPr id="74" name="">
             <a:extLst xmlns:a="http://schemas.openxmlformats.org/drawingml/2006/main">
               <a:ext uri="{FF2B5EF4-FFF2-40B4-BE49-F238E27FC236}">
-                <a16:creationId xmlns:a16="http://schemas.microsoft.com/office/drawing/2014/main" id="{D7BB75E7-A150-4A28-896D-3F9FE0B46C15}"/>
+                <a16:creationId xmlns:a16="http://schemas.microsoft.com/office/drawing/2014/main" id="{FEE35523-B8EC-4927-B85D-293EE0B4A287}"/>
               </a:ext>
             </a:extLst>
           </p:cNvPr>
@@ -6108,7 +6108,7 @@
     </p:spTree>
     <p:extLst>
       <p:ext uri="{BB962C8B-B14F-4D97-AF65-F5344CB8AC3E}">
-        <p14:creationId xmlns:p14="http://schemas.microsoft.com/office/powerpoint/2010/main" val="803603281"/>
+        <p14:creationId xmlns:p14="http://schemas.microsoft.com/office/powerpoint/2010/main" val="2000481524"/>
       </p:ext>
     </p:extLst>
   </p:cSld>
@@ -6132,7 +6132,7 @@
           <p:cNvPr id="1" name="Slide Number Placeholder 5">
             <a:extLst xmlns:a="http://schemas.openxmlformats.org/drawingml/2006/main">
               <a:ext uri="{FF2B5EF4-FFF2-40B4-BE49-F238E27FC236}">
-                <a16:creationId xmlns:a16="http://schemas.microsoft.com/office/drawing/2014/main" id="{A38EE67A-5EB7-40DD-A2FB-C845C008A837}"/>
+                <a16:creationId xmlns:a16="http://schemas.microsoft.com/office/drawing/2014/main" id="{5CB0B9E6-D1CD-4D78-BE01-E7D92F1A92B6}"/>
               </a:ext>
             </a:extLst>
           </p:cNvPr>
@@ -6164,7 +6164,7 @@
           <p:cNvPr id="2" name="">
             <a:extLst xmlns:a="http://schemas.openxmlformats.org/drawingml/2006/main">
               <a:ext uri="{FF2B5EF4-FFF2-40B4-BE49-F238E27FC236}">
-                <a16:creationId xmlns:a16="http://schemas.microsoft.com/office/drawing/2014/main" id="{2FA4E1F8-7E87-4C1B-9912-D4D2B1F7D9F1}"/>
+                <a16:creationId xmlns:a16="http://schemas.microsoft.com/office/drawing/2014/main" id="{B467ADAB-C431-4033-9FEC-680EE4C970C5}"/>
               </a:ext>
             </a:extLst>
           </p:cNvPr>
@@ -6196,7 +6196,7 @@
           <p:cNvPr id="3" name="">
             <a:extLst xmlns:a="http://schemas.openxmlformats.org/drawingml/2006/main">
               <a:ext uri="{FF2B5EF4-FFF2-40B4-BE49-F238E27FC236}">
-                <a16:creationId xmlns:a16="http://schemas.microsoft.com/office/drawing/2014/main" id="{9078916D-4E25-45A2-95BA-839061BD30B4}"/>
+                <a16:creationId xmlns:a16="http://schemas.microsoft.com/office/drawing/2014/main" id="{6D869FE1-21EF-4A56-A253-CD21372530D9}"/>
               </a:ext>
             </a:extLst>
           </p:cNvPr>
@@ -6253,7 +6253,7 @@
           <p:cNvPr id="4" name="">
             <a:extLst xmlns:a="http://schemas.openxmlformats.org/drawingml/2006/main">
               <a:ext uri="{FF2B5EF4-FFF2-40B4-BE49-F238E27FC236}">
-                <a16:creationId xmlns:a16="http://schemas.microsoft.com/office/drawing/2014/main" id="{033D3968-B28F-445E-8E95-F1CB6E6FB3D7}"/>
+                <a16:creationId xmlns:a16="http://schemas.microsoft.com/office/drawing/2014/main" id="{41623FCD-274F-41F7-8CDB-79AD9B898B90}"/>
               </a:ext>
             </a:extLst>
           </p:cNvPr>
@@ -6310,7 +6310,7 @@
           <p:cNvPr id="5" name="">
             <a:extLst xmlns:a="http://schemas.openxmlformats.org/drawingml/2006/main">
               <a:ext uri="{FF2B5EF4-FFF2-40B4-BE49-F238E27FC236}">
-                <a16:creationId xmlns:a16="http://schemas.microsoft.com/office/drawing/2014/main" id="{90B0765D-A26A-4D24-BD07-E61313C58235}"/>
+                <a16:creationId xmlns:a16="http://schemas.microsoft.com/office/drawing/2014/main" id="{9FEA63ED-C525-4241-BEB6-8FDEC6D9DE11}"/>
               </a:ext>
             </a:extLst>
           </p:cNvPr>
@@ -6367,7 +6367,7 @@
           <p:cNvPr id="6" name="">
             <a:extLst xmlns:a="http://schemas.openxmlformats.org/drawingml/2006/main">
               <a:ext uri="{FF2B5EF4-FFF2-40B4-BE49-F238E27FC236}">
-                <a16:creationId xmlns:a16="http://schemas.microsoft.com/office/drawing/2014/main" id="{49A11421-6EFD-41DE-B911-14693B984AF1}"/>
+                <a16:creationId xmlns:a16="http://schemas.microsoft.com/office/drawing/2014/main" id="{F2F172F8-4FE8-40E0-99EC-AE1F4DC33ADC}"/>
               </a:ext>
             </a:extLst>
           </p:cNvPr>
@@ -6401,7 +6401,7 @@
           <p:cNvPr id="7" name="">
             <a:extLst xmlns:a="http://schemas.openxmlformats.org/drawingml/2006/main">
               <a:ext uri="{FF2B5EF4-FFF2-40B4-BE49-F238E27FC236}">
-                <a16:creationId xmlns:a16="http://schemas.microsoft.com/office/drawing/2014/main" id="{731D344A-E227-4775-AF72-039598234D36}"/>
+                <a16:creationId xmlns:a16="http://schemas.microsoft.com/office/drawing/2014/main" id="{5A38EB1D-5FC3-4EC3-BA93-CAC0EC468F8B}"/>
               </a:ext>
             </a:extLst>
           </p:cNvPr>
@@ -6435,7 +6435,7 @@
           <p:cNvPr id="8" name="">
             <a:extLst xmlns:a="http://schemas.openxmlformats.org/drawingml/2006/main">
               <a:ext uri="{FF2B5EF4-FFF2-40B4-BE49-F238E27FC236}">
-                <a16:creationId xmlns:a16="http://schemas.microsoft.com/office/drawing/2014/main" id="{9CA71769-36A3-462E-9AA2-CF4B6468C93E}"/>
+                <a16:creationId xmlns:a16="http://schemas.microsoft.com/office/drawing/2014/main" id="{6D685F08-E947-47B4-8BB5-E378EE4B0D82}"/>
               </a:ext>
             </a:extLst>
           </p:cNvPr>
@@ -6467,7 +6467,7 @@
           <p:cNvPr id="9" name="">
             <a:extLst xmlns:a="http://schemas.openxmlformats.org/drawingml/2006/main">
               <a:ext uri="{FF2B5EF4-FFF2-40B4-BE49-F238E27FC236}">
-                <a16:creationId xmlns:a16="http://schemas.microsoft.com/office/drawing/2014/main" id="{145C4DF5-B2A5-4359-B13B-CA5A0D5F126C}"/>
+                <a16:creationId xmlns:a16="http://schemas.microsoft.com/office/drawing/2014/main" id="{A9FEE5C1-A921-438F-BC72-9C2BA41656CD}"/>
               </a:ext>
             </a:extLst>
           </p:cNvPr>
@@ -6499,7 +6499,7 @@
           <p:cNvPr id="10" name="">
             <a:extLst xmlns:a="http://schemas.openxmlformats.org/drawingml/2006/main">
               <a:ext uri="{FF2B5EF4-FFF2-40B4-BE49-F238E27FC236}">
-                <a16:creationId xmlns:a16="http://schemas.microsoft.com/office/drawing/2014/main" id="{33F92728-D1C2-49E4-98C9-3B2210B72218}"/>
+                <a16:creationId xmlns:a16="http://schemas.microsoft.com/office/drawing/2014/main" id="{8245E4D3-A736-494F-BA6A-106907CB2DCC}"/>
               </a:ext>
             </a:extLst>
           </p:cNvPr>
@@ -6556,7 +6556,7 @@
           <p:cNvPr id="11" name="">
             <a:extLst xmlns:a="http://schemas.openxmlformats.org/drawingml/2006/main">
               <a:ext uri="{FF2B5EF4-FFF2-40B4-BE49-F238E27FC236}">
-                <a16:creationId xmlns:a16="http://schemas.microsoft.com/office/drawing/2014/main" id="{97239022-8F71-4466-BCDB-EE0765FBDE0E}"/>
+                <a16:creationId xmlns:a16="http://schemas.microsoft.com/office/drawing/2014/main" id="{BCDF78DD-0986-47E7-A2E6-E6A6D8896C0A}"/>
               </a:ext>
             </a:extLst>
           </p:cNvPr>
@@ -6588,7 +6588,7 @@
           <p:cNvPr id="12" name="">
             <a:extLst xmlns:a="http://schemas.openxmlformats.org/drawingml/2006/main">
               <a:ext uri="{FF2B5EF4-FFF2-40B4-BE49-F238E27FC236}">
-                <a16:creationId xmlns:a16="http://schemas.microsoft.com/office/drawing/2014/main" id="{E2CC074F-724E-4D89-AE30-1FD229FCB75F}"/>
+                <a16:creationId xmlns:a16="http://schemas.microsoft.com/office/drawing/2014/main" id="{F1B20BAF-16EF-4122-A53A-0D4C3091683D}"/>
               </a:ext>
             </a:extLst>
           </p:cNvPr>
@@ -6645,7 +6645,7 @@
           <p:cNvPr id="13" name="">
             <a:extLst xmlns:a="http://schemas.openxmlformats.org/drawingml/2006/main">
               <a:ext uri="{FF2B5EF4-FFF2-40B4-BE49-F238E27FC236}">
-                <a16:creationId xmlns:a16="http://schemas.microsoft.com/office/drawing/2014/main" id="{62AAD1F9-9179-4A8C-9C80-6AF31A68AECC}"/>
+                <a16:creationId xmlns:a16="http://schemas.microsoft.com/office/drawing/2014/main" id="{A74ECCC0-0A0C-473D-882F-7D2279C16D00}"/>
               </a:ext>
             </a:extLst>
           </p:cNvPr>
@@ -6677,7 +6677,7 @@
           <p:cNvPr id="14" name="">
             <a:extLst xmlns:a="http://schemas.openxmlformats.org/drawingml/2006/main">
               <a:ext uri="{FF2B5EF4-FFF2-40B4-BE49-F238E27FC236}">
-                <a16:creationId xmlns:a16="http://schemas.microsoft.com/office/drawing/2014/main" id="{771B37F5-1B9C-468F-A755-03009F16E128}"/>
+                <a16:creationId xmlns:a16="http://schemas.microsoft.com/office/drawing/2014/main" id="{7282EF8E-3CE0-4E44-BB3A-D523E183DB9E}"/>
               </a:ext>
             </a:extLst>
           </p:cNvPr>
@@ -6734,7 +6734,7 @@
           <p:cNvPr id="15" name="">
             <a:extLst xmlns:a="http://schemas.openxmlformats.org/drawingml/2006/main">
               <a:ext uri="{FF2B5EF4-FFF2-40B4-BE49-F238E27FC236}">
-                <a16:creationId xmlns:a16="http://schemas.microsoft.com/office/drawing/2014/main" id="{BF7712E4-BD7A-4651-834B-0AE95E9D905D}"/>
+                <a16:creationId xmlns:a16="http://schemas.microsoft.com/office/drawing/2014/main" id="{58E27EDE-FF29-4AA3-95D0-5DFEE4544B6E}"/>
               </a:ext>
             </a:extLst>
           </p:cNvPr>
@@ -6766,7 +6766,7 @@
           <p:cNvPr id="16" name="">
             <a:extLst xmlns:a="http://schemas.openxmlformats.org/drawingml/2006/main">
               <a:ext uri="{FF2B5EF4-FFF2-40B4-BE49-F238E27FC236}">
-                <a16:creationId xmlns:a16="http://schemas.microsoft.com/office/drawing/2014/main" id="{EF58AAAD-715D-4C96-BA9A-4A34A118DF47}"/>
+                <a16:creationId xmlns:a16="http://schemas.microsoft.com/office/drawing/2014/main" id="{DC49661F-EB28-4A5F-A3B7-E1C843DA3BEF}"/>
               </a:ext>
             </a:extLst>
           </p:cNvPr>
@@ -6823,7 +6823,7 @@
           <p:cNvPr id="17" name="">
             <a:extLst xmlns:a="http://schemas.openxmlformats.org/drawingml/2006/main">
               <a:ext uri="{FF2B5EF4-FFF2-40B4-BE49-F238E27FC236}">
-                <a16:creationId xmlns:a16="http://schemas.microsoft.com/office/drawing/2014/main" id="{2B3E3615-2154-4835-B843-DF3438067C84}"/>
+                <a16:creationId xmlns:a16="http://schemas.microsoft.com/office/drawing/2014/main" id="{71070C84-BEAD-424E-AF7F-A4D6EE0BB017}"/>
               </a:ext>
             </a:extLst>
           </p:cNvPr>
@@ -6855,7 +6855,7 @@
           <p:cNvPr id="18" name="">
             <a:extLst xmlns:a="http://schemas.openxmlformats.org/drawingml/2006/main">
               <a:ext uri="{FF2B5EF4-FFF2-40B4-BE49-F238E27FC236}">
-                <a16:creationId xmlns:a16="http://schemas.microsoft.com/office/drawing/2014/main" id="{D7F60248-670E-46FF-A154-A03640C4241D}"/>
+                <a16:creationId xmlns:a16="http://schemas.microsoft.com/office/drawing/2014/main" id="{604154C2-9435-4040-814B-E69A58D24D0D}"/>
               </a:ext>
             </a:extLst>
           </p:cNvPr>
@@ -6912,7 +6912,7 @@
           <p:cNvPr id="19" name="">
             <a:extLst xmlns:a="http://schemas.openxmlformats.org/drawingml/2006/main">
               <a:ext uri="{FF2B5EF4-FFF2-40B4-BE49-F238E27FC236}">
-                <a16:creationId xmlns:a16="http://schemas.microsoft.com/office/drawing/2014/main" id="{600D8F2A-B209-4D53-B0FE-6F0604B67644}"/>
+                <a16:creationId xmlns:a16="http://schemas.microsoft.com/office/drawing/2014/main" id="{C27DAEAF-DD80-43E7-A8F1-FB4F837A9B82}"/>
               </a:ext>
             </a:extLst>
           </p:cNvPr>
@@ -6946,7 +6946,7 @@
           <p:cNvPr id="20" name="">
             <a:extLst xmlns:a="http://schemas.openxmlformats.org/drawingml/2006/main">
               <a:ext uri="{FF2B5EF4-FFF2-40B4-BE49-F238E27FC236}">
-                <a16:creationId xmlns:a16="http://schemas.microsoft.com/office/drawing/2014/main" id="{48E82309-F1EC-4B4F-950B-6B68DE3D625A}"/>
+                <a16:creationId xmlns:a16="http://schemas.microsoft.com/office/drawing/2014/main" id="{C049936C-CCEB-48E3-9D37-49164DA71BA5}"/>
               </a:ext>
             </a:extLst>
           </p:cNvPr>
@@ -7003,7 +7003,7 @@
           <p:cNvPr id="21" name="">
             <a:extLst xmlns:a="http://schemas.openxmlformats.org/drawingml/2006/main">
               <a:ext uri="{FF2B5EF4-FFF2-40B4-BE49-F238E27FC236}">
-                <a16:creationId xmlns:a16="http://schemas.microsoft.com/office/drawing/2014/main" id="{E3DB6AA9-9CA1-41BC-8D05-79D6EB7AC02B}"/>
+                <a16:creationId xmlns:a16="http://schemas.microsoft.com/office/drawing/2014/main" id="{A4E9BA38-CB21-4A08-BC04-7BF03D7AA665}"/>
               </a:ext>
             </a:extLst>
           </p:cNvPr>
@@ -7060,7 +7060,7 @@
           <p:cNvPr id="22" name="">
             <a:extLst xmlns:a="http://schemas.openxmlformats.org/drawingml/2006/main">
               <a:ext uri="{FF2B5EF4-FFF2-40B4-BE49-F238E27FC236}">
-                <a16:creationId xmlns:a16="http://schemas.microsoft.com/office/drawing/2014/main" id="{AF256204-EBFC-40DC-A806-E69034512D8A}"/>
+                <a16:creationId xmlns:a16="http://schemas.microsoft.com/office/drawing/2014/main" id="{3B44A423-989E-4225-8CAE-D07CD02E08E2}"/>
               </a:ext>
             </a:extLst>
           </p:cNvPr>
@@ -7094,7 +7094,7 @@
           <p:cNvPr id="23" name="">
             <a:extLst xmlns:a="http://schemas.openxmlformats.org/drawingml/2006/main">
               <a:ext uri="{FF2B5EF4-FFF2-40B4-BE49-F238E27FC236}">
-                <a16:creationId xmlns:a16="http://schemas.microsoft.com/office/drawing/2014/main" id="{244289A6-E8A9-4C81-9AAC-A4C667304A4F}"/>
+                <a16:creationId xmlns:a16="http://schemas.microsoft.com/office/drawing/2014/main" id="{662CA266-4A30-411F-9D85-E371562635D8}"/>
               </a:ext>
             </a:extLst>
           </p:cNvPr>
@@ -7128,7 +7128,7 @@
           <p:cNvPr id="24" name="">
             <a:extLst xmlns:a="http://schemas.openxmlformats.org/drawingml/2006/main">
               <a:ext uri="{FF2B5EF4-FFF2-40B4-BE49-F238E27FC236}">
-                <a16:creationId xmlns:a16="http://schemas.microsoft.com/office/drawing/2014/main" id="{8B9BFA09-849A-4D97-B804-C7B0A998BD03}"/>
+                <a16:creationId xmlns:a16="http://schemas.microsoft.com/office/drawing/2014/main" id="{57017884-0498-4CBD-8273-AD4320FA57B4}"/>
               </a:ext>
             </a:extLst>
           </p:cNvPr>
@@ -7162,7 +7162,7 @@
           <p:cNvPr id="25" name="">
             <a:extLst xmlns:a="http://schemas.openxmlformats.org/drawingml/2006/main">
               <a:ext uri="{FF2B5EF4-FFF2-40B4-BE49-F238E27FC236}">
-                <a16:creationId xmlns:a16="http://schemas.microsoft.com/office/drawing/2014/main" id="{F5710908-3F5F-41DA-AD21-E435F2FFE988}"/>
+                <a16:creationId xmlns:a16="http://schemas.microsoft.com/office/drawing/2014/main" id="{13F09E93-5CB5-4D60-B19B-AE9AFFC6E926}"/>
               </a:ext>
             </a:extLst>
           </p:cNvPr>
@@ -7219,7 +7219,7 @@
           <p:cNvPr id="26" name="">
             <a:extLst xmlns:a="http://schemas.openxmlformats.org/drawingml/2006/main">
               <a:ext uri="{FF2B5EF4-FFF2-40B4-BE49-F238E27FC236}">
-                <a16:creationId xmlns:a16="http://schemas.microsoft.com/office/drawing/2014/main" id="{566FDB87-845F-4D1C-A481-E1B47F1464BC}"/>
+                <a16:creationId xmlns:a16="http://schemas.microsoft.com/office/drawing/2014/main" id="{6F33D1CB-380B-43B5-8A34-DAB57A418AF4}"/>
               </a:ext>
             </a:extLst>
           </p:cNvPr>
@@ -7276,7 +7276,7 @@
           <p:cNvPr id="27" name="">
             <a:extLst xmlns:a="http://schemas.openxmlformats.org/drawingml/2006/main">
               <a:ext uri="{FF2B5EF4-FFF2-40B4-BE49-F238E27FC236}">
-                <a16:creationId xmlns:a16="http://schemas.microsoft.com/office/drawing/2014/main" id="{E37F1ED9-4DD4-47FC-9D22-9F703D2D73CD}"/>
+                <a16:creationId xmlns:a16="http://schemas.microsoft.com/office/drawing/2014/main" id="{896B2E26-74D8-4211-A17F-9A5D9CB0B164}"/>
               </a:ext>
             </a:extLst>
           </p:cNvPr>
@@ -7310,7 +7310,7 @@
           <p:cNvPr id="28" name="">
             <a:extLst xmlns:a="http://schemas.openxmlformats.org/drawingml/2006/main">
               <a:ext uri="{FF2B5EF4-FFF2-40B4-BE49-F238E27FC236}">
-                <a16:creationId xmlns:a16="http://schemas.microsoft.com/office/drawing/2014/main" id="{B26187E1-92B8-4EB5-BF06-9B7DEAEFA7CB}"/>
+                <a16:creationId xmlns:a16="http://schemas.microsoft.com/office/drawing/2014/main" id="{8B145291-B322-435B-AFCD-FDE3E1B909D6}"/>
               </a:ext>
             </a:extLst>
           </p:cNvPr>
@@ -7344,7 +7344,7 @@
           <p:cNvPr id="29" name="">
             <a:extLst xmlns:a="http://schemas.openxmlformats.org/drawingml/2006/main">
               <a:ext uri="{FF2B5EF4-FFF2-40B4-BE49-F238E27FC236}">
-                <a16:creationId xmlns:a16="http://schemas.microsoft.com/office/drawing/2014/main" id="{67FBC159-B9C7-4F74-BC98-D29D72137AD1}"/>
+                <a16:creationId xmlns:a16="http://schemas.microsoft.com/office/drawing/2014/main" id="{AA84FC95-34BF-44F5-815C-190D5ED5E81B}"/>
               </a:ext>
             </a:extLst>
           </p:cNvPr>
@@ -7378,7 +7378,7 @@
           <p:cNvPr id="30" name="">
             <a:extLst xmlns:a="http://schemas.openxmlformats.org/drawingml/2006/main">
               <a:ext uri="{FF2B5EF4-FFF2-40B4-BE49-F238E27FC236}">
-                <a16:creationId xmlns:a16="http://schemas.microsoft.com/office/drawing/2014/main" id="{98E5E250-EF1C-40DD-A0E6-F55CCBD25093}"/>
+                <a16:creationId xmlns:a16="http://schemas.microsoft.com/office/drawing/2014/main" id="{2EF058AE-AAFA-44E9-A23B-6DC210B55E59}"/>
               </a:ext>
             </a:extLst>
           </p:cNvPr>
@@ -7435,7 +7435,7 @@
           <p:cNvPr id="31" name="">
             <a:extLst xmlns:a="http://schemas.openxmlformats.org/drawingml/2006/main">
               <a:ext uri="{FF2B5EF4-FFF2-40B4-BE49-F238E27FC236}">
-                <a16:creationId xmlns:a16="http://schemas.microsoft.com/office/drawing/2014/main" id="{D03E9843-FE00-4C1A-A121-12A089125EC8}"/>
+                <a16:creationId xmlns:a16="http://schemas.microsoft.com/office/drawing/2014/main" id="{A8C9D6CD-7E7B-449A-9A35-6155EF1F3C07}"/>
               </a:ext>
             </a:extLst>
           </p:cNvPr>
@@ -7492,7 +7492,7 @@
           <p:cNvPr id="32" name="">
             <a:extLst xmlns:a="http://schemas.openxmlformats.org/drawingml/2006/main">
               <a:ext uri="{FF2B5EF4-FFF2-40B4-BE49-F238E27FC236}">
-                <a16:creationId xmlns:a16="http://schemas.microsoft.com/office/drawing/2014/main" id="{99730FB4-7B13-463F-AAB4-9A61D906CE31}"/>
+                <a16:creationId xmlns:a16="http://schemas.microsoft.com/office/drawing/2014/main" id="{A4FA010F-1CEE-4177-BB9F-1B8AB88FFD3A}"/>
               </a:ext>
             </a:extLst>
           </p:cNvPr>
@@ -7526,7 +7526,7 @@
           <p:cNvPr id="33" name="">
             <a:extLst xmlns:a="http://schemas.openxmlformats.org/drawingml/2006/main">
               <a:ext uri="{FF2B5EF4-FFF2-40B4-BE49-F238E27FC236}">
-                <a16:creationId xmlns:a16="http://schemas.microsoft.com/office/drawing/2014/main" id="{BFBB7245-3F10-4FAF-9955-6BF79FCB5481}"/>
+                <a16:creationId xmlns:a16="http://schemas.microsoft.com/office/drawing/2014/main" id="{C18FA604-8C7D-4A70-99F9-E9191F5FD6FA}"/>
               </a:ext>
             </a:extLst>
           </p:cNvPr>
@@ -7583,7 +7583,7 @@
           <p:cNvPr id="34" name="">
             <a:extLst xmlns:a="http://schemas.openxmlformats.org/drawingml/2006/main">
               <a:ext uri="{FF2B5EF4-FFF2-40B4-BE49-F238E27FC236}">
-                <a16:creationId xmlns:a16="http://schemas.microsoft.com/office/drawing/2014/main" id="{E13C4B0B-37A6-4975-A5F5-D8D82C537793}"/>
+                <a16:creationId xmlns:a16="http://schemas.microsoft.com/office/drawing/2014/main" id="{37F6C495-7A31-48DE-AB18-802B98F871D4}"/>
               </a:ext>
             </a:extLst>
           </p:cNvPr>
@@ -7617,7 +7617,7 @@
           <p:cNvPr id="35" name="">
             <a:extLst xmlns:a="http://schemas.openxmlformats.org/drawingml/2006/main">
               <a:ext uri="{FF2B5EF4-FFF2-40B4-BE49-F238E27FC236}">
-                <a16:creationId xmlns:a16="http://schemas.microsoft.com/office/drawing/2014/main" id="{EC3EFBA7-553A-4A85-AF63-BD990BBE192B}"/>
+                <a16:creationId xmlns:a16="http://schemas.microsoft.com/office/drawing/2014/main" id="{58EB8EE1-8521-4031-AABA-EF52E67751FC}"/>
               </a:ext>
             </a:extLst>
           </p:cNvPr>
@@ -7674,7 +7674,7 @@
           <p:cNvPr id="36" name="">
             <a:extLst xmlns:a="http://schemas.openxmlformats.org/drawingml/2006/main">
               <a:ext uri="{FF2B5EF4-FFF2-40B4-BE49-F238E27FC236}">
-                <a16:creationId xmlns:a16="http://schemas.microsoft.com/office/drawing/2014/main" id="{EEE36A2E-7822-4DE9-B186-2C7C5FB0A2A7}"/>
+                <a16:creationId xmlns:a16="http://schemas.microsoft.com/office/drawing/2014/main" id="{5A4FDE7D-78B7-409B-BCF1-5E0075A8088F}"/>
               </a:ext>
             </a:extLst>
           </p:cNvPr>
@@ -7708,7 +7708,7 @@
           <p:cNvPr id="37" name="">
             <a:extLst xmlns:a="http://schemas.openxmlformats.org/drawingml/2006/main">
               <a:ext uri="{FF2B5EF4-FFF2-40B4-BE49-F238E27FC236}">
-                <a16:creationId xmlns:a16="http://schemas.microsoft.com/office/drawing/2014/main" id="{DA9351A0-57E8-4E83-BD4F-EB6562491E8B}"/>
+                <a16:creationId xmlns:a16="http://schemas.microsoft.com/office/drawing/2014/main" id="{95E6993E-44B1-4359-A87A-308A4B8B97DE}"/>
               </a:ext>
             </a:extLst>
           </p:cNvPr>
@@ -7765,7 +7765,7 @@
           <p:cNvPr id="38" name="">
             <a:extLst xmlns:a="http://schemas.openxmlformats.org/drawingml/2006/main">
               <a:ext uri="{FF2B5EF4-FFF2-40B4-BE49-F238E27FC236}">
-                <a16:creationId xmlns:a16="http://schemas.microsoft.com/office/drawing/2014/main" id="{4D784D08-AE26-4744-A228-0B09F86398C1}"/>
+                <a16:creationId xmlns:a16="http://schemas.microsoft.com/office/drawing/2014/main" id="{036CABAF-A456-49D4-AE3C-BB9686C85CB2}"/>
               </a:ext>
             </a:extLst>
           </p:cNvPr>
@@ -7822,7 +7822,7 @@
           <p:cNvPr id="39" name="">
             <a:extLst xmlns:a="http://schemas.openxmlformats.org/drawingml/2006/main">
               <a:ext uri="{FF2B5EF4-FFF2-40B4-BE49-F238E27FC236}">
-                <a16:creationId xmlns:a16="http://schemas.microsoft.com/office/drawing/2014/main" id="{76127440-AA21-493A-B51D-8D8B98B5B696}"/>
+                <a16:creationId xmlns:a16="http://schemas.microsoft.com/office/drawing/2014/main" id="{B92C146D-18A8-4097-8F16-32AFBFA23BB2}"/>
               </a:ext>
             </a:extLst>
           </p:cNvPr>
@@ -7869,7 +7869,7 @@
                   <a:srgbClr val="52616F"/>
                 </a:solidFill>
               </a:rPr>
-              <a:t>MO currently owns 97 open tickets, including 20 high-severity items and 94 overdue follow-ups. That queue scores 203 points above the peer median on the executive backlog index.</a:t>
+              <a:t>MO currently owns 97 open tickets, including 20 high-severity items and 74 overdue follow-ups. That queue scores 123 points above the peer median on the executive backlog index.</a:t>
             </a:r>
           </a:p>
         </p:txBody>
@@ -7879,7 +7879,7 @@
           <p:cNvPr id="40" name="">
             <a:extLst xmlns:a="http://schemas.openxmlformats.org/drawingml/2006/main">
               <a:ext uri="{FF2B5EF4-FFF2-40B4-BE49-F238E27FC236}">
-                <a16:creationId xmlns:a16="http://schemas.microsoft.com/office/drawing/2014/main" id="{1A632372-F207-420A-993F-D3ED47E15586}"/>
+                <a16:creationId xmlns:a16="http://schemas.microsoft.com/office/drawing/2014/main" id="{7456856B-620A-46A8-BE6B-BBF88DD6639E}"/>
               </a:ext>
             </a:extLst>
           </p:cNvPr>
@@ -7913,7 +7913,7 @@
           <p:cNvPr id="41" name="">
             <a:extLst xmlns:a="http://schemas.openxmlformats.org/drawingml/2006/main">
               <a:ext uri="{FF2B5EF4-FFF2-40B4-BE49-F238E27FC236}">
-                <a16:creationId xmlns:a16="http://schemas.microsoft.com/office/drawing/2014/main" id="{5D29BBDE-5ECD-4DEE-99F5-A3E2A3BCFC75}"/>
+                <a16:creationId xmlns:a16="http://schemas.microsoft.com/office/drawing/2014/main" id="{B2CDF322-FC77-4309-AF9B-5A0D5555219D}"/>
               </a:ext>
             </a:extLst>
           </p:cNvPr>
@@ -7970,7 +7970,7 @@
           <p:cNvPr id="42" name="">
             <a:extLst xmlns:a="http://schemas.openxmlformats.org/drawingml/2006/main">
               <a:ext uri="{FF2B5EF4-FFF2-40B4-BE49-F238E27FC236}">
-                <a16:creationId xmlns:a16="http://schemas.microsoft.com/office/drawing/2014/main" id="{9454EEE3-4771-44E6-9AD7-6959C7A2830F}"/>
+                <a16:creationId xmlns:a16="http://schemas.microsoft.com/office/drawing/2014/main" id="{7F50030F-1FD7-4A2F-B43F-9D1564B59F1D}"/>
               </a:ext>
             </a:extLst>
           </p:cNvPr>
@@ -8027,7 +8027,7 @@
           <p:cNvPr id="43" name="">
             <a:extLst xmlns:a="http://schemas.openxmlformats.org/drawingml/2006/main">
               <a:ext uri="{FF2B5EF4-FFF2-40B4-BE49-F238E27FC236}">
-                <a16:creationId xmlns:a16="http://schemas.microsoft.com/office/drawing/2014/main" id="{6DDF35E6-FD35-418F-8EFF-DC89D3B33EBB}"/>
+                <a16:creationId xmlns:a16="http://schemas.microsoft.com/office/drawing/2014/main" id="{D41C05CB-6532-4779-B371-F17E98524BC1}"/>
               </a:ext>
             </a:extLst>
           </p:cNvPr>
@@ -8061,7 +8061,7 @@
           <p:cNvPr id="44" name="">
             <a:extLst xmlns:a="http://schemas.openxmlformats.org/drawingml/2006/main">
               <a:ext uri="{FF2B5EF4-FFF2-40B4-BE49-F238E27FC236}">
-                <a16:creationId xmlns:a16="http://schemas.microsoft.com/office/drawing/2014/main" id="{11B3F02A-9531-4A8D-A875-5A36724CDB1B}"/>
+                <a16:creationId xmlns:a16="http://schemas.microsoft.com/office/drawing/2014/main" id="{93FB758A-FC4A-425B-9872-F18F68D61325}"/>
               </a:ext>
             </a:extLst>
           </p:cNvPr>
@@ -8118,7 +8118,7 @@
           <p:cNvPr id="45" name="">
             <a:extLst xmlns:a="http://schemas.openxmlformats.org/drawingml/2006/main">
               <a:ext uri="{FF2B5EF4-FFF2-40B4-BE49-F238E27FC236}">
-                <a16:creationId xmlns:a16="http://schemas.microsoft.com/office/drawing/2014/main" id="{DA90ABAB-F0A7-49B9-B0B8-48CF1BE95799}"/>
+                <a16:creationId xmlns:a16="http://schemas.microsoft.com/office/drawing/2014/main" id="{418C5CCD-F615-4A52-BA51-132BCC0F11A0}"/>
               </a:ext>
             </a:extLst>
           </p:cNvPr>
@@ -8165,7 +8165,7 @@
                   <a:srgbClr val="17212B"/>
                 </a:solidFill>
               </a:rPr>
-              <a:t>97 open | 20 high | 94 overdue</a:t>
+              <a:t>97 open | 20 high | 74 overdue</a:t>
             </a:r>
           </a:p>
         </p:txBody>
@@ -8175,7 +8175,7 @@
           <p:cNvPr id="46" name="">
             <a:extLst xmlns:a="http://schemas.openxmlformats.org/drawingml/2006/main">
               <a:ext uri="{FF2B5EF4-FFF2-40B4-BE49-F238E27FC236}">
-                <a16:creationId xmlns:a16="http://schemas.microsoft.com/office/drawing/2014/main" id="{49DE6CCD-4339-443A-9B97-0142F796B0A2}"/>
+                <a16:creationId xmlns:a16="http://schemas.microsoft.com/office/drawing/2014/main" id="{8B94EFF7-7885-475C-A049-3B3EFF45705A}"/>
               </a:ext>
             </a:extLst>
           </p:cNvPr>
@@ -8209,7 +8209,7 @@
           <p:cNvPr id="47" name="">
             <a:extLst xmlns:a="http://schemas.openxmlformats.org/drawingml/2006/main">
               <a:ext uri="{FF2B5EF4-FFF2-40B4-BE49-F238E27FC236}">
-                <a16:creationId xmlns:a16="http://schemas.microsoft.com/office/drawing/2014/main" id="{EA1CD6A8-4B33-4855-BF79-D5820C5ABC77}"/>
+                <a16:creationId xmlns:a16="http://schemas.microsoft.com/office/drawing/2014/main" id="{2B57E324-29DA-4CD3-A508-D0D712F7D9A6}"/>
               </a:ext>
             </a:extLst>
           </p:cNvPr>
@@ -8266,7 +8266,7 @@
           <p:cNvPr id="48" name="">
             <a:extLst xmlns:a="http://schemas.openxmlformats.org/drawingml/2006/main">
               <a:ext uri="{FF2B5EF4-FFF2-40B4-BE49-F238E27FC236}">
-                <a16:creationId xmlns:a16="http://schemas.microsoft.com/office/drawing/2014/main" id="{B4FB6BDE-F545-4265-9F5E-8EE43304B379}"/>
+                <a16:creationId xmlns:a16="http://schemas.microsoft.com/office/drawing/2014/main" id="{5482225D-EDCA-4CC8-8946-FD9534E393CF}"/>
               </a:ext>
             </a:extLst>
           </p:cNvPr>
@@ -8321,7 +8321,7 @@
     </p:spTree>
     <p:extLst>
       <p:ext uri="{BB962C8B-B14F-4D97-AF65-F5344CB8AC3E}">
-        <p14:creationId xmlns:p14="http://schemas.microsoft.com/office/powerpoint/2010/main" val="1930267591"/>
+        <p14:creationId xmlns:p14="http://schemas.microsoft.com/office/powerpoint/2010/main" val="1623129023"/>
       </p:ext>
     </p:extLst>
   </p:cSld>
@@ -8345,7 +8345,7 @@
           <p:cNvPr id="1" name="Slide Number Placeholder 5">
             <a:extLst xmlns:a="http://schemas.openxmlformats.org/drawingml/2006/main">
               <a:ext uri="{FF2B5EF4-FFF2-40B4-BE49-F238E27FC236}">
-                <a16:creationId xmlns:a16="http://schemas.microsoft.com/office/drawing/2014/main" id="{A38EE67A-5EB7-40DD-A2FB-C845C008A837}"/>
+                <a16:creationId xmlns:a16="http://schemas.microsoft.com/office/drawing/2014/main" id="{5CB0B9E6-D1CD-4D78-BE01-E7D92F1A92B6}"/>
               </a:ext>
             </a:extLst>
           </p:cNvPr>
@@ -8377,7 +8377,7 @@
           <p:cNvPr id="2" name="">
             <a:extLst xmlns:a="http://schemas.openxmlformats.org/drawingml/2006/main">
               <a:ext uri="{FF2B5EF4-FFF2-40B4-BE49-F238E27FC236}">
-                <a16:creationId xmlns:a16="http://schemas.microsoft.com/office/drawing/2014/main" id="{4CC94506-5E0D-485F-9B5B-AC248759790F}"/>
+                <a16:creationId xmlns:a16="http://schemas.microsoft.com/office/drawing/2014/main" id="{C870BD7C-B7ED-421D-A995-D7C563ABB5F3}"/>
               </a:ext>
             </a:extLst>
           </p:cNvPr>
@@ -8409,7 +8409,7 @@
           <p:cNvPr id="3" name="">
             <a:extLst xmlns:a="http://schemas.openxmlformats.org/drawingml/2006/main">
               <a:ext uri="{FF2B5EF4-FFF2-40B4-BE49-F238E27FC236}">
-                <a16:creationId xmlns:a16="http://schemas.microsoft.com/office/drawing/2014/main" id="{B5E32B43-0534-4C58-9D01-7CBD58EB0A6A}"/>
+                <a16:creationId xmlns:a16="http://schemas.microsoft.com/office/drawing/2014/main" id="{920C0B91-9A76-4E65-8FBC-77FA2CF9242E}"/>
               </a:ext>
             </a:extLst>
           </p:cNvPr>
@@ -8466,7 +8466,7 @@
           <p:cNvPr id="4" name="">
             <a:extLst xmlns:a="http://schemas.openxmlformats.org/drawingml/2006/main">
               <a:ext uri="{FF2B5EF4-FFF2-40B4-BE49-F238E27FC236}">
-                <a16:creationId xmlns:a16="http://schemas.microsoft.com/office/drawing/2014/main" id="{C865383A-224C-4144-A923-92E189EF9E48}"/>
+                <a16:creationId xmlns:a16="http://schemas.microsoft.com/office/drawing/2014/main" id="{959D5CCB-946D-40C0-9279-741A937D762D}"/>
               </a:ext>
             </a:extLst>
           </p:cNvPr>
@@ -8523,7 +8523,7 @@
           <p:cNvPr id="5" name="">
             <a:extLst xmlns:a="http://schemas.openxmlformats.org/drawingml/2006/main">
               <a:ext uri="{FF2B5EF4-FFF2-40B4-BE49-F238E27FC236}">
-                <a16:creationId xmlns:a16="http://schemas.microsoft.com/office/drawing/2014/main" id="{EFC7E1A6-508E-4A0A-B7CA-79D09A4705A2}"/>
+                <a16:creationId xmlns:a16="http://schemas.microsoft.com/office/drawing/2014/main" id="{A4991085-C19C-49B2-B873-7F58751171F5}"/>
               </a:ext>
             </a:extLst>
           </p:cNvPr>
@@ -8580,7 +8580,7 @@
           <p:cNvPr id="6" name="">
             <a:extLst xmlns:a="http://schemas.openxmlformats.org/drawingml/2006/main">
               <a:ext uri="{FF2B5EF4-FFF2-40B4-BE49-F238E27FC236}">
-                <a16:creationId xmlns:a16="http://schemas.microsoft.com/office/drawing/2014/main" id="{572C2701-CAAE-4905-B4D9-B7ACA7C330DC}"/>
+                <a16:creationId xmlns:a16="http://schemas.microsoft.com/office/drawing/2014/main" id="{951AD1CD-387B-499F-A6A8-D8C884DDF9E3}"/>
               </a:ext>
             </a:extLst>
           </p:cNvPr>
@@ -8614,7 +8614,7 @@
           <p:cNvPr id="7" name="">
             <a:extLst xmlns:a="http://schemas.openxmlformats.org/drawingml/2006/main">
               <a:ext uri="{FF2B5EF4-FFF2-40B4-BE49-F238E27FC236}">
-                <a16:creationId xmlns:a16="http://schemas.microsoft.com/office/drawing/2014/main" id="{18AF9B13-CD24-4B05-8BBE-615A71B78AAF}"/>
+                <a16:creationId xmlns:a16="http://schemas.microsoft.com/office/drawing/2014/main" id="{EDF49E06-E369-4B54-89E8-C497677402EC}"/>
               </a:ext>
             </a:extLst>
           </p:cNvPr>
@@ -8648,7 +8648,7 @@
           <p:cNvPr id="8" name="">
             <a:extLst xmlns:a="http://schemas.openxmlformats.org/drawingml/2006/main">
               <a:ext uri="{FF2B5EF4-FFF2-40B4-BE49-F238E27FC236}">
-                <a16:creationId xmlns:a16="http://schemas.microsoft.com/office/drawing/2014/main" id="{B65E27FA-78EB-485D-8D76-08FB70C85F8D}"/>
+                <a16:creationId xmlns:a16="http://schemas.microsoft.com/office/drawing/2014/main" id="{26BEFD31-2626-4046-8C4E-FC771ED56A94}"/>
               </a:ext>
             </a:extLst>
           </p:cNvPr>
@@ -8680,7 +8680,7 @@
           <p:cNvPr id="9" name="">
             <a:extLst xmlns:a="http://schemas.openxmlformats.org/drawingml/2006/main">
               <a:ext uri="{FF2B5EF4-FFF2-40B4-BE49-F238E27FC236}">
-                <a16:creationId xmlns:a16="http://schemas.microsoft.com/office/drawing/2014/main" id="{77AE93A9-C749-4550-A4F1-605F0D88C6FA}"/>
+                <a16:creationId xmlns:a16="http://schemas.microsoft.com/office/drawing/2014/main" id="{F95FBBCF-3CBF-4A81-BF5E-7AF933E1E584}"/>
               </a:ext>
             </a:extLst>
           </p:cNvPr>
@@ -8712,7 +8712,7 @@
           <p:cNvPr id="10" name="">
             <a:extLst xmlns:a="http://schemas.openxmlformats.org/drawingml/2006/main">
               <a:ext uri="{FF2B5EF4-FFF2-40B4-BE49-F238E27FC236}">
-                <a16:creationId xmlns:a16="http://schemas.microsoft.com/office/drawing/2014/main" id="{4D66A420-2A01-4FEC-9C99-EF7017F5647E}"/>
+                <a16:creationId xmlns:a16="http://schemas.microsoft.com/office/drawing/2014/main" id="{39C679F3-943C-4103-811F-1B01BBE38BB3}"/>
               </a:ext>
             </a:extLst>
           </p:cNvPr>
@@ -8769,7 +8769,7 @@
           <p:cNvPr id="11" name="">
             <a:extLst xmlns:a="http://schemas.openxmlformats.org/drawingml/2006/main">
               <a:ext uri="{FF2B5EF4-FFF2-40B4-BE49-F238E27FC236}">
-                <a16:creationId xmlns:a16="http://schemas.microsoft.com/office/drawing/2014/main" id="{530BD3D4-B7F5-494B-9DEF-9B0B2ED379E4}"/>
+                <a16:creationId xmlns:a16="http://schemas.microsoft.com/office/drawing/2014/main" id="{8E35162F-1256-4D3E-A7EE-EA7D7F185373}"/>
               </a:ext>
             </a:extLst>
           </p:cNvPr>
@@ -8801,7 +8801,7 @@
           <p:cNvPr id="12" name="">
             <a:extLst xmlns:a="http://schemas.openxmlformats.org/drawingml/2006/main">
               <a:ext uri="{FF2B5EF4-FFF2-40B4-BE49-F238E27FC236}">
-                <a16:creationId xmlns:a16="http://schemas.microsoft.com/office/drawing/2014/main" id="{C039024D-1771-4E9C-A5D6-A91B1B512E9D}"/>
+                <a16:creationId xmlns:a16="http://schemas.microsoft.com/office/drawing/2014/main" id="{D73397D8-8A02-479B-9454-F84D5D21C3B4}"/>
               </a:ext>
             </a:extLst>
           </p:cNvPr>
@@ -8858,7 +8858,7 @@
           <p:cNvPr id="13" name="">
             <a:extLst xmlns:a="http://schemas.openxmlformats.org/drawingml/2006/main">
               <a:ext uri="{FF2B5EF4-FFF2-40B4-BE49-F238E27FC236}">
-                <a16:creationId xmlns:a16="http://schemas.microsoft.com/office/drawing/2014/main" id="{7207D2DD-680A-4612-833E-96B7BC8CD48F}"/>
+                <a16:creationId xmlns:a16="http://schemas.microsoft.com/office/drawing/2014/main" id="{B6455AA2-EFB9-4335-A891-881B4946D691}"/>
               </a:ext>
             </a:extLst>
           </p:cNvPr>
@@ -8890,7 +8890,7 @@
           <p:cNvPr id="14" name="">
             <a:extLst xmlns:a="http://schemas.openxmlformats.org/drawingml/2006/main">
               <a:ext uri="{FF2B5EF4-FFF2-40B4-BE49-F238E27FC236}">
-                <a16:creationId xmlns:a16="http://schemas.microsoft.com/office/drawing/2014/main" id="{7F05CD44-4C4E-458D-9E45-1AF050A28D3C}"/>
+                <a16:creationId xmlns:a16="http://schemas.microsoft.com/office/drawing/2014/main" id="{82A266E6-5BF2-422E-A60E-B352D4C95435}"/>
               </a:ext>
             </a:extLst>
           </p:cNvPr>
@@ -8947,7 +8947,7 @@
           <p:cNvPr id="15" name="">
             <a:extLst xmlns:a="http://schemas.openxmlformats.org/drawingml/2006/main">
               <a:ext uri="{FF2B5EF4-FFF2-40B4-BE49-F238E27FC236}">
-                <a16:creationId xmlns:a16="http://schemas.microsoft.com/office/drawing/2014/main" id="{C55DBF4D-25E3-4C92-B915-27D11161AB8C}"/>
+                <a16:creationId xmlns:a16="http://schemas.microsoft.com/office/drawing/2014/main" id="{6B4A6531-FBED-421C-8DB7-BDC7CD7BAFD4}"/>
               </a:ext>
             </a:extLst>
           </p:cNvPr>
@@ -8979,7 +8979,7 @@
           <p:cNvPr id="16" name="">
             <a:extLst xmlns:a="http://schemas.openxmlformats.org/drawingml/2006/main">
               <a:ext uri="{FF2B5EF4-FFF2-40B4-BE49-F238E27FC236}">
-                <a16:creationId xmlns:a16="http://schemas.microsoft.com/office/drawing/2014/main" id="{DC5B3E1C-FB49-43D8-9606-406122EA8E7E}"/>
+                <a16:creationId xmlns:a16="http://schemas.microsoft.com/office/drawing/2014/main" id="{7ACCD798-4261-48FD-870F-6C8822E707DC}"/>
               </a:ext>
             </a:extLst>
           </p:cNvPr>
@@ -9036,7 +9036,7 @@
           <p:cNvPr id="17" name="">
             <a:extLst xmlns:a="http://schemas.openxmlformats.org/drawingml/2006/main">
               <a:ext uri="{FF2B5EF4-FFF2-40B4-BE49-F238E27FC236}">
-                <a16:creationId xmlns:a16="http://schemas.microsoft.com/office/drawing/2014/main" id="{17DA66B4-E731-4A95-9C10-D5BBF0F02812}"/>
+                <a16:creationId xmlns:a16="http://schemas.microsoft.com/office/drawing/2014/main" id="{882D30DF-963D-4E4C-AE52-741175EF870E}"/>
               </a:ext>
             </a:extLst>
           </p:cNvPr>
@@ -9068,7 +9068,7 @@
           <p:cNvPr id="18" name="">
             <a:extLst xmlns:a="http://schemas.openxmlformats.org/drawingml/2006/main">
               <a:ext uri="{FF2B5EF4-FFF2-40B4-BE49-F238E27FC236}">
-                <a16:creationId xmlns:a16="http://schemas.microsoft.com/office/drawing/2014/main" id="{0531D665-C1E2-4F2C-B950-578AE7888A24}"/>
+                <a16:creationId xmlns:a16="http://schemas.microsoft.com/office/drawing/2014/main" id="{064E11F8-D91F-42C4-B6B2-067D5D1F4740}"/>
               </a:ext>
             </a:extLst>
           </p:cNvPr>
@@ -9125,7 +9125,7 @@
           <p:cNvPr id="19" name="">
             <a:extLst xmlns:a="http://schemas.openxmlformats.org/drawingml/2006/main">
               <a:ext uri="{FF2B5EF4-FFF2-40B4-BE49-F238E27FC236}">
-                <a16:creationId xmlns:a16="http://schemas.microsoft.com/office/drawing/2014/main" id="{D7F9A4C8-9775-4009-B933-270227F3BF70}"/>
+                <a16:creationId xmlns:a16="http://schemas.microsoft.com/office/drawing/2014/main" id="{E5F2C84D-5126-4C7F-B3F1-6A1AC6047E66}"/>
               </a:ext>
             </a:extLst>
           </p:cNvPr>
@@ -9159,7 +9159,7 @@
           <p:cNvPr id="20" name="">
             <a:extLst xmlns:a="http://schemas.openxmlformats.org/drawingml/2006/main">
               <a:ext uri="{FF2B5EF4-FFF2-40B4-BE49-F238E27FC236}">
-                <a16:creationId xmlns:a16="http://schemas.microsoft.com/office/drawing/2014/main" id="{508BD020-8872-45E0-9A80-8C6B62126E5A}"/>
+                <a16:creationId xmlns:a16="http://schemas.microsoft.com/office/drawing/2014/main" id="{BB7665D7-9771-427A-B79B-BF6216EDB453}"/>
               </a:ext>
             </a:extLst>
           </p:cNvPr>
@@ -9216,7 +9216,7 @@
           <p:cNvPr id="21" name="">
             <a:extLst xmlns:a="http://schemas.openxmlformats.org/drawingml/2006/main">
               <a:ext uri="{FF2B5EF4-FFF2-40B4-BE49-F238E27FC236}">
-                <a16:creationId xmlns:a16="http://schemas.microsoft.com/office/drawing/2014/main" id="{1AE27179-886B-4AD4-A84A-87EFF5ADE9D5}"/>
+                <a16:creationId xmlns:a16="http://schemas.microsoft.com/office/drawing/2014/main" id="{6F0C8732-25C8-4692-9B4F-65CBF1800105}"/>
               </a:ext>
             </a:extLst>
           </p:cNvPr>
@@ -9250,7 +9250,7 @@
           <p:cNvPr id="22" name="">
             <a:extLst xmlns:a="http://schemas.openxmlformats.org/drawingml/2006/main">
               <a:ext uri="{FF2B5EF4-FFF2-40B4-BE49-F238E27FC236}">
-                <a16:creationId xmlns:a16="http://schemas.microsoft.com/office/drawing/2014/main" id="{BEE4880E-59E8-4201-862F-7C6D3046F44C}"/>
+                <a16:creationId xmlns:a16="http://schemas.microsoft.com/office/drawing/2014/main" id="{4D7CB4B8-390C-4645-9B6A-E9ABD0FEC526}"/>
               </a:ext>
             </a:extLst>
           </p:cNvPr>
@@ -9284,7 +9284,7 @@
           <p:cNvPr id="23" name="">
             <a:extLst xmlns:a="http://schemas.openxmlformats.org/drawingml/2006/main">
               <a:ext uri="{FF2B5EF4-FFF2-40B4-BE49-F238E27FC236}">
-                <a16:creationId xmlns:a16="http://schemas.microsoft.com/office/drawing/2014/main" id="{980F610B-2C43-40E1-91C1-DE99DC570847}"/>
+                <a16:creationId xmlns:a16="http://schemas.microsoft.com/office/drawing/2014/main" id="{9C950ABF-6703-48F5-9930-55E421A68D5A}"/>
               </a:ext>
             </a:extLst>
           </p:cNvPr>
@@ -9341,7 +9341,7 @@
           <p:cNvPr id="24" name="">
             <a:extLst xmlns:a="http://schemas.openxmlformats.org/drawingml/2006/main">
               <a:ext uri="{FF2B5EF4-FFF2-40B4-BE49-F238E27FC236}">
-                <a16:creationId xmlns:a16="http://schemas.microsoft.com/office/drawing/2014/main" id="{1F02447F-EBB7-40A6-B38E-B1D86B16BFD7}"/>
+                <a16:creationId xmlns:a16="http://schemas.microsoft.com/office/drawing/2014/main" id="{20456092-9C1F-4F49-8546-D54FA48FB4AD}"/>
               </a:ext>
             </a:extLst>
           </p:cNvPr>
@@ -9375,7 +9375,7 @@
           <p:cNvPr id="25" name="">
             <a:extLst xmlns:a="http://schemas.openxmlformats.org/drawingml/2006/main">
               <a:ext uri="{FF2B5EF4-FFF2-40B4-BE49-F238E27FC236}">
-                <a16:creationId xmlns:a16="http://schemas.microsoft.com/office/drawing/2014/main" id="{43C7CE6D-CB23-446D-96EE-4F6742F83744}"/>
+                <a16:creationId xmlns:a16="http://schemas.microsoft.com/office/drawing/2014/main" id="{91D82200-355B-41C8-A081-F11D43F3A382}"/>
               </a:ext>
             </a:extLst>
           </p:cNvPr>
@@ -9409,7 +9409,7 @@
           <p:cNvPr id="26" name="">
             <a:extLst xmlns:a="http://schemas.openxmlformats.org/drawingml/2006/main">
               <a:ext uri="{FF2B5EF4-FFF2-40B4-BE49-F238E27FC236}">
-                <a16:creationId xmlns:a16="http://schemas.microsoft.com/office/drawing/2014/main" id="{4A94F7B9-5DC9-4B46-967B-6F6810A23ACE}"/>
+                <a16:creationId xmlns:a16="http://schemas.microsoft.com/office/drawing/2014/main" id="{B2B9C105-4A85-464D-BCE5-9BB3CBD74803}"/>
               </a:ext>
             </a:extLst>
           </p:cNvPr>
@@ -9466,7 +9466,7 @@
           <p:cNvPr id="27" name="">
             <a:extLst xmlns:a="http://schemas.openxmlformats.org/drawingml/2006/main">
               <a:ext uri="{FF2B5EF4-FFF2-40B4-BE49-F238E27FC236}">
-                <a16:creationId xmlns:a16="http://schemas.microsoft.com/office/drawing/2014/main" id="{6E2FA646-ABFF-4BFB-8E68-0D367EABAAE9}"/>
+                <a16:creationId xmlns:a16="http://schemas.microsoft.com/office/drawing/2014/main" id="{F7A24354-5D74-42F4-BD30-E0F6ED385F02}"/>
               </a:ext>
             </a:extLst>
           </p:cNvPr>
@@ -9500,7 +9500,7 @@
           <p:cNvPr id="28" name="">
             <a:extLst xmlns:a="http://schemas.openxmlformats.org/drawingml/2006/main">
               <a:ext uri="{FF2B5EF4-FFF2-40B4-BE49-F238E27FC236}">
-                <a16:creationId xmlns:a16="http://schemas.microsoft.com/office/drawing/2014/main" id="{B9AED49E-D9E4-4C6F-B1F1-559510B5F643}"/>
+                <a16:creationId xmlns:a16="http://schemas.microsoft.com/office/drawing/2014/main" id="{E4468597-9AAD-4B0A-A858-039D64FABC87}"/>
               </a:ext>
             </a:extLst>
           </p:cNvPr>
@@ -9534,7 +9534,7 @@
           <p:cNvPr id="29" name="">
             <a:extLst xmlns:a="http://schemas.openxmlformats.org/drawingml/2006/main">
               <a:ext uri="{FF2B5EF4-FFF2-40B4-BE49-F238E27FC236}">
-                <a16:creationId xmlns:a16="http://schemas.microsoft.com/office/drawing/2014/main" id="{F1969714-E69D-4347-BFE7-E149FCC7A343}"/>
+                <a16:creationId xmlns:a16="http://schemas.microsoft.com/office/drawing/2014/main" id="{451902E5-E8C9-499E-8041-C288BB020DC0}"/>
               </a:ext>
             </a:extLst>
           </p:cNvPr>
@@ -9591,7 +9591,7 @@
           <p:cNvPr id="30" name="">
             <a:extLst xmlns:a="http://schemas.openxmlformats.org/drawingml/2006/main">
               <a:ext uri="{FF2B5EF4-FFF2-40B4-BE49-F238E27FC236}">
-                <a16:creationId xmlns:a16="http://schemas.microsoft.com/office/drawing/2014/main" id="{0740791A-36B6-4450-8AF9-AF11C5238C44}"/>
+                <a16:creationId xmlns:a16="http://schemas.microsoft.com/office/drawing/2014/main" id="{505250C6-21A1-4BB7-80CD-6C3A5DC5CD9D}"/>
               </a:ext>
             </a:extLst>
           </p:cNvPr>
@@ -9625,7 +9625,7 @@
           <p:cNvPr id="31" name="">
             <a:extLst xmlns:a="http://schemas.openxmlformats.org/drawingml/2006/main">
               <a:ext uri="{FF2B5EF4-FFF2-40B4-BE49-F238E27FC236}">
-                <a16:creationId xmlns:a16="http://schemas.microsoft.com/office/drawing/2014/main" id="{93F12C60-D06B-42DF-AF24-6EC4C0141830}"/>
+                <a16:creationId xmlns:a16="http://schemas.microsoft.com/office/drawing/2014/main" id="{26F5AE33-82A9-494F-A464-B65CD8BDC365}"/>
               </a:ext>
             </a:extLst>
           </p:cNvPr>
@@ -9659,7 +9659,7 @@
           <p:cNvPr id="32" name="">
             <a:extLst xmlns:a="http://schemas.openxmlformats.org/drawingml/2006/main">
               <a:ext uri="{FF2B5EF4-FFF2-40B4-BE49-F238E27FC236}">
-                <a16:creationId xmlns:a16="http://schemas.microsoft.com/office/drawing/2014/main" id="{D2DCE060-3167-42AA-AD55-86A36B1B15B7}"/>
+                <a16:creationId xmlns:a16="http://schemas.microsoft.com/office/drawing/2014/main" id="{3EFF7407-8806-4322-A524-EC50A868F096}"/>
               </a:ext>
             </a:extLst>
           </p:cNvPr>
@@ -9716,7 +9716,7 @@
           <p:cNvPr id="33" name="">
             <a:extLst xmlns:a="http://schemas.openxmlformats.org/drawingml/2006/main">
               <a:ext uri="{FF2B5EF4-FFF2-40B4-BE49-F238E27FC236}">
-                <a16:creationId xmlns:a16="http://schemas.microsoft.com/office/drawing/2014/main" id="{BBA52B31-C257-457D-B670-E1CC2D497720}"/>
+                <a16:creationId xmlns:a16="http://schemas.microsoft.com/office/drawing/2014/main" id="{5D0B9FC7-DB2A-4D92-909E-958AC8144024}"/>
               </a:ext>
             </a:extLst>
           </p:cNvPr>
@@ -9750,7 +9750,7 @@
           <p:cNvPr id="34" name="">
             <a:extLst xmlns:a="http://schemas.openxmlformats.org/drawingml/2006/main">
               <a:ext uri="{FF2B5EF4-FFF2-40B4-BE49-F238E27FC236}">
-                <a16:creationId xmlns:a16="http://schemas.microsoft.com/office/drawing/2014/main" id="{EFBD3D2E-7EF5-431F-B2ED-58893219DE59}"/>
+                <a16:creationId xmlns:a16="http://schemas.microsoft.com/office/drawing/2014/main" id="{DB2347BE-6FEB-4B21-85B3-2F89E7AAF028}"/>
               </a:ext>
             </a:extLst>
           </p:cNvPr>
@@ -9807,7 +9807,7 @@
           <p:cNvPr id="35" name="">
             <a:extLst xmlns:a="http://schemas.openxmlformats.org/drawingml/2006/main">
               <a:ext uri="{FF2B5EF4-FFF2-40B4-BE49-F238E27FC236}">
-                <a16:creationId xmlns:a16="http://schemas.microsoft.com/office/drawing/2014/main" id="{22321BC9-D30D-46FE-91D5-85F8C41C005A}"/>
+                <a16:creationId xmlns:a16="http://schemas.microsoft.com/office/drawing/2014/main" id="{CF9E939D-9112-4C46-98FB-E54CAD5DC0BC}"/>
               </a:ext>
             </a:extLst>
           </p:cNvPr>
@@ -9864,23 +9864,23 @@
           <p:cNvPr id="36" name="">
             <a:extLst xmlns:a="http://schemas.openxmlformats.org/drawingml/2006/main">
               <a:ext uri="{FF2B5EF4-FFF2-40B4-BE49-F238E27FC236}">
-                <a16:creationId xmlns:a16="http://schemas.microsoft.com/office/drawing/2014/main" id="{855BD166-9954-4126-B781-A4930D1A0B3A}"/>
-              </a:ext>
-            </a:extLst>
-          </p:cNvPr>
-          <p:cNvSpPr>
-            <a:spLocks xmlns:a="http://schemas.openxmlformats.org/drawingml/2006/main" noGrp="1"/>
-          </p:cNvSpPr>
-          <p:nvPr/>
-        </p:nvSpPr>
-        <p:spPr>
-          <a:xfrm xmlns:a="http://schemas.openxmlformats.org/drawingml/2006/main">
-            <a:off x="7486650" y="2038350"/>
-            <a:ext cx="3905250" cy="1085850"/>
+                <a16:creationId xmlns:a16="http://schemas.microsoft.com/office/drawing/2014/main" id="{5C24B9F8-D472-4133-8723-2BCCB2585B34}"/>
+              </a:ext>
+            </a:extLst>
+          </p:cNvPr>
+          <p:cNvSpPr>
+            <a:spLocks xmlns:a="http://schemas.openxmlformats.org/drawingml/2006/main" noGrp="1"/>
+          </p:cNvSpPr>
+          <p:nvPr/>
+        </p:nvSpPr>
+        <p:spPr>
+          <a:xfrm xmlns:a="http://schemas.openxmlformats.org/drawingml/2006/main">
+            <a:off x="7486650" y="1981200"/>
+            <a:ext cx="3905250" cy="1200150"/>
           </a:xfrm>
           <a:prstGeom xmlns:a="http://schemas.openxmlformats.org/drawingml/2006/main" prst="roundRect">
             <a:avLst>
-              <a:gd name="adj" fmla="val 7018"/>
+              <a:gd name="adj" fmla="val 6349"/>
             </a:avLst>
           </a:prstGeom>
           <a:solidFill xmlns:a="http://schemas.openxmlformats.org/drawingml/2006/main">
@@ -9898,49 +9898,51 @@
           <p:cNvPr id="37" name="">
             <a:extLst xmlns:a="http://schemas.openxmlformats.org/drawingml/2006/main">
               <a:ext uri="{FF2B5EF4-FFF2-40B4-BE49-F238E27FC236}">
-                <a16:creationId xmlns:a16="http://schemas.microsoft.com/office/drawing/2014/main" id="{2FF1A054-09C3-4FCC-B5A2-A993EB258502}"/>
-              </a:ext>
-            </a:extLst>
-          </p:cNvPr>
-          <p:cNvSpPr>
-            <a:spLocks xmlns:a="http://schemas.openxmlformats.org/drawingml/2006/main" noGrp="1"/>
-          </p:cNvSpPr>
-          <p:nvPr/>
-        </p:nvSpPr>
-        <p:spPr>
-          <a:xfrm xmlns:a="http://schemas.openxmlformats.org/drawingml/2006/main">
-            <a:off x="7677150" y="2152650"/>
-            <a:ext cx="2381250" cy="247650"/>
-          </a:xfrm>
-          <a:prstGeom xmlns:a="http://schemas.openxmlformats.org/drawingml/2006/main" prst="rect">
-            <a:avLst/>
-          </a:prstGeom>
-          <a:solidFill xmlns:a="http://schemas.openxmlformats.org/drawingml/2006/main">
-            <a:srgbClr val="FFFFFF">
-              <a:alpha val="0"/>
-            </a:srgbClr>
-          </a:solidFill>
-          <a:ln xmlns:a="http://schemas.openxmlformats.org/drawingml/2006/main" w="0">
-            <a:solidFill>
-              <a:srgbClr val="FFFFFF">
-                <a:alpha val="0"/>
-              </a:srgbClr>
-            </a:solidFill>
-          </a:ln>
-        </p:spPr>
-        <p:txBody>
-          <a:bodyPr xmlns:a="http://schemas.openxmlformats.org/drawingml/2006/main" lIns="76200" tIns="38100" rIns="76200" bIns="38100" anchor="ctr"/>
+                <a16:creationId xmlns:a16="http://schemas.microsoft.com/office/drawing/2014/main" id="{0D588DA0-BC71-43D5-9D30-C88D5ED10CA8}"/>
+              </a:ext>
+            </a:extLst>
+          </p:cNvPr>
+          <p:cNvSpPr>
+            <a:spLocks xmlns:a="http://schemas.openxmlformats.org/drawingml/2006/main" noGrp="1"/>
+          </p:cNvSpPr>
+          <p:nvPr/>
+        </p:nvSpPr>
+        <p:spPr>
+          <a:xfrm xmlns:a="http://schemas.openxmlformats.org/drawingml/2006/main">
+            <a:off x="7677150" y="2095500"/>
+            <a:ext cx="2209800" cy="381000"/>
+          </a:xfrm>
+          <a:prstGeom xmlns:a="http://schemas.openxmlformats.org/drawingml/2006/main" prst="rect">
+            <a:avLst/>
+          </a:prstGeom>
+          <a:solidFill xmlns:a="http://schemas.openxmlformats.org/drawingml/2006/main">
+            <a:srgbClr val="FFFFFF">
+              <a:alpha val="0"/>
+            </a:srgbClr>
+          </a:solidFill>
+          <a:ln xmlns:a="http://schemas.openxmlformats.org/drawingml/2006/main" w="0">
+            <a:solidFill>
+              <a:srgbClr val="FFFFFF">
+                <a:alpha val="0"/>
+              </a:srgbClr>
+            </a:solidFill>
+          </a:ln>
+        </p:spPr>
+        <p:txBody>
+          <a:bodyPr xmlns:a="http://schemas.openxmlformats.org/drawingml/2006/main" lIns="0" tIns="0" rIns="57150" bIns="0" anchor="t">
+            <a:normAutofit fontScale="100000"/>
+          </a:bodyPr>
           <a:lstStyle xmlns:a="http://schemas.openxmlformats.org/drawingml/2006/main"/>
           <a:p xmlns:a="http://schemas.openxmlformats.org/drawingml/2006/main">
             <a:pPr algn="l">
-              <a:defRPr sz="1200" b="1">
+              <a:defRPr sz="1275" b="1">
                 <a:solidFill>
                   <a:srgbClr val="1A8D55"/>
                 </a:solidFill>
               </a:defRPr>
             </a:pPr>
             <a:r>
-              <a:rPr sz="1200" b="1">
+              <a:rPr sz="1275" b="1">
                 <a:solidFill>
                   <a:srgbClr val="1A8D55"/>
                 </a:solidFill>
@@ -9955,49 +9957,51 @@
           <p:cNvPr id="38" name="">
             <a:extLst xmlns:a="http://schemas.openxmlformats.org/drawingml/2006/main">
               <a:ext uri="{FF2B5EF4-FFF2-40B4-BE49-F238E27FC236}">
-                <a16:creationId xmlns:a16="http://schemas.microsoft.com/office/drawing/2014/main" id="{38F43D38-C37E-45E6-B35B-E0E1B609F361}"/>
-              </a:ext>
-            </a:extLst>
-          </p:cNvPr>
-          <p:cNvSpPr>
-            <a:spLocks xmlns:a="http://schemas.openxmlformats.org/drawingml/2006/main" noGrp="1"/>
-          </p:cNvSpPr>
-          <p:nvPr/>
-        </p:nvSpPr>
-        <p:spPr>
-          <a:xfrm xmlns:a="http://schemas.openxmlformats.org/drawingml/2006/main">
-            <a:off x="10001250" y="2133600"/>
-            <a:ext cx="1143000" cy="323850"/>
-          </a:xfrm>
-          <a:prstGeom xmlns:a="http://schemas.openxmlformats.org/drawingml/2006/main" prst="rect">
-            <a:avLst/>
-          </a:prstGeom>
-          <a:solidFill xmlns:a="http://schemas.openxmlformats.org/drawingml/2006/main">
-            <a:srgbClr val="FFFFFF">
-              <a:alpha val="0"/>
-            </a:srgbClr>
-          </a:solidFill>
-          <a:ln xmlns:a="http://schemas.openxmlformats.org/drawingml/2006/main" w="0">
-            <a:solidFill>
-              <a:srgbClr val="FFFFFF">
-                <a:alpha val="0"/>
-              </a:srgbClr>
-            </a:solidFill>
-          </a:ln>
-        </p:spPr>
-        <p:txBody>
-          <a:bodyPr xmlns:a="http://schemas.openxmlformats.org/drawingml/2006/main" lIns="76200" tIns="38100" rIns="76200" bIns="38100" anchor="ctr"/>
+                <a16:creationId xmlns:a16="http://schemas.microsoft.com/office/drawing/2014/main" id="{1B1E9946-4F0C-48EE-B367-25C31FFDE434}"/>
+              </a:ext>
+            </a:extLst>
+          </p:cNvPr>
+          <p:cNvSpPr>
+            <a:spLocks xmlns:a="http://schemas.openxmlformats.org/drawingml/2006/main" noGrp="1"/>
+          </p:cNvSpPr>
+          <p:nvPr/>
+        </p:nvSpPr>
+        <p:spPr>
+          <a:xfrm xmlns:a="http://schemas.openxmlformats.org/drawingml/2006/main">
+            <a:off x="10287000" y="2076450"/>
+            <a:ext cx="857250" cy="323850"/>
+          </a:xfrm>
+          <a:prstGeom xmlns:a="http://schemas.openxmlformats.org/drawingml/2006/main" prst="rect">
+            <a:avLst/>
+          </a:prstGeom>
+          <a:solidFill xmlns:a="http://schemas.openxmlformats.org/drawingml/2006/main">
+            <a:srgbClr val="FFFFFF">
+              <a:alpha val="0"/>
+            </a:srgbClr>
+          </a:solidFill>
+          <a:ln xmlns:a="http://schemas.openxmlformats.org/drawingml/2006/main" w="0">
+            <a:solidFill>
+              <a:srgbClr val="FFFFFF">
+                <a:alpha val="0"/>
+              </a:srgbClr>
+            </a:solidFill>
+          </a:ln>
+        </p:spPr>
+        <p:txBody>
+          <a:bodyPr xmlns:a="http://schemas.openxmlformats.org/drawingml/2006/main" lIns="0" tIns="0" rIns="0" bIns="0" anchor="t">
+            <a:normAutofit fontScale="100000"/>
+          </a:bodyPr>
           <a:lstStyle xmlns:a="http://schemas.openxmlformats.org/drawingml/2006/main"/>
           <a:p xmlns:a="http://schemas.openxmlformats.org/drawingml/2006/main">
             <a:pPr algn="r">
-              <a:defRPr sz="1800" b="1">
+              <a:defRPr sz="1650" b="1">
                 <a:solidFill>
                   <a:srgbClr val="17212B"/>
                 </a:solidFill>
               </a:defRPr>
             </a:pPr>
             <a:r>
-              <a:rPr sz="1800" b="1">
+              <a:rPr sz="1650" b="1">
                 <a:solidFill>
                   <a:srgbClr val="17212B"/>
                 </a:solidFill>
@@ -10012,49 +10016,51 @@
           <p:cNvPr id="39" name="">
             <a:extLst xmlns:a="http://schemas.openxmlformats.org/drawingml/2006/main">
               <a:ext uri="{FF2B5EF4-FFF2-40B4-BE49-F238E27FC236}">
-                <a16:creationId xmlns:a16="http://schemas.microsoft.com/office/drawing/2014/main" id="{326C3C15-4944-4AC0-B3D1-9E38B9C84926}"/>
-              </a:ext>
-            </a:extLst>
-          </p:cNvPr>
-          <p:cNvSpPr>
-            <a:spLocks xmlns:a="http://schemas.openxmlformats.org/drawingml/2006/main" noGrp="1"/>
-          </p:cNvSpPr>
-          <p:nvPr/>
-        </p:nvSpPr>
-        <p:spPr>
-          <a:xfrm xmlns:a="http://schemas.openxmlformats.org/drawingml/2006/main">
-            <a:off x="9906000" y="2457450"/>
-            <a:ext cx="1238250" cy="171450"/>
-          </a:xfrm>
-          <a:prstGeom xmlns:a="http://schemas.openxmlformats.org/drawingml/2006/main" prst="rect">
-            <a:avLst/>
-          </a:prstGeom>
-          <a:solidFill xmlns:a="http://schemas.openxmlformats.org/drawingml/2006/main">
-            <a:srgbClr val="FFFFFF">
-              <a:alpha val="0"/>
-            </a:srgbClr>
-          </a:solidFill>
-          <a:ln xmlns:a="http://schemas.openxmlformats.org/drawingml/2006/main" w="0">
-            <a:solidFill>
-              <a:srgbClr val="FFFFFF">
-                <a:alpha val="0"/>
-              </a:srgbClr>
-            </a:solidFill>
-          </a:ln>
-        </p:spPr>
-        <p:txBody>
-          <a:bodyPr xmlns:a="http://schemas.openxmlformats.org/drawingml/2006/main" lIns="76200" tIns="38100" rIns="76200" bIns="38100" anchor="ctr"/>
+                <a16:creationId xmlns:a16="http://schemas.microsoft.com/office/drawing/2014/main" id="{8C6D3020-5C1E-499C-A443-1446486C5EAD}"/>
+              </a:ext>
+            </a:extLst>
+          </p:cNvPr>
+          <p:cNvSpPr>
+            <a:spLocks xmlns:a="http://schemas.openxmlformats.org/drawingml/2006/main" noGrp="1"/>
+          </p:cNvSpPr>
+          <p:nvPr/>
+        </p:nvSpPr>
+        <p:spPr>
+          <a:xfrm xmlns:a="http://schemas.openxmlformats.org/drawingml/2006/main">
+            <a:off x="10115550" y="2362200"/>
+            <a:ext cx="1028700" cy="266700"/>
+          </a:xfrm>
+          <a:prstGeom xmlns:a="http://schemas.openxmlformats.org/drawingml/2006/main" prst="rect">
+            <a:avLst/>
+          </a:prstGeom>
+          <a:solidFill xmlns:a="http://schemas.openxmlformats.org/drawingml/2006/main">
+            <a:srgbClr val="FFFFFF">
+              <a:alpha val="0"/>
+            </a:srgbClr>
+          </a:solidFill>
+          <a:ln xmlns:a="http://schemas.openxmlformats.org/drawingml/2006/main" w="0">
+            <a:solidFill>
+              <a:srgbClr val="FFFFFF">
+                <a:alpha val="0"/>
+              </a:srgbClr>
+            </a:solidFill>
+          </a:ln>
+        </p:spPr>
+        <p:txBody>
+          <a:bodyPr xmlns:a="http://schemas.openxmlformats.org/drawingml/2006/main" lIns="38100" tIns="0" rIns="0" bIns="0" anchor="t">
+            <a:normAutofit fontScale="100000"/>
+          </a:bodyPr>
           <a:lstStyle xmlns:a="http://schemas.openxmlformats.org/drawingml/2006/main"/>
           <a:p xmlns:a="http://schemas.openxmlformats.org/drawingml/2006/main">
             <a:pPr algn="r">
-              <a:defRPr sz="825" b="1">
+              <a:defRPr sz="750" b="1">
                 <a:solidFill>
                   <a:srgbClr val="52616F"/>
                 </a:solidFill>
               </a:defRPr>
             </a:pPr>
             <a:r>
-              <a:rPr sz="825" b="1">
+              <a:rPr sz="750" b="1">
                 <a:solidFill>
                   <a:srgbClr val="52616F"/>
                 </a:solidFill>
@@ -10069,49 +10075,51 @@
           <p:cNvPr id="40" name="">
             <a:extLst xmlns:a="http://schemas.openxmlformats.org/drawingml/2006/main">
               <a:ext uri="{FF2B5EF4-FFF2-40B4-BE49-F238E27FC236}">
-                <a16:creationId xmlns:a16="http://schemas.microsoft.com/office/drawing/2014/main" id="{8592C76C-1E34-4D1A-80A3-5D50583CE0AB}"/>
-              </a:ext>
-            </a:extLst>
-          </p:cNvPr>
-          <p:cNvSpPr>
-            <a:spLocks xmlns:a="http://schemas.openxmlformats.org/drawingml/2006/main" noGrp="1"/>
-          </p:cNvSpPr>
-          <p:nvPr/>
-        </p:nvSpPr>
-        <p:spPr>
-          <a:xfrm xmlns:a="http://schemas.openxmlformats.org/drawingml/2006/main">
-            <a:off x="7677150" y="2514600"/>
-            <a:ext cx="3333750" cy="457200"/>
-          </a:xfrm>
-          <a:prstGeom xmlns:a="http://schemas.openxmlformats.org/drawingml/2006/main" prst="rect">
-            <a:avLst/>
-          </a:prstGeom>
-          <a:solidFill xmlns:a="http://schemas.openxmlformats.org/drawingml/2006/main">
-            <a:srgbClr val="FFFFFF">
-              <a:alpha val="0"/>
-            </a:srgbClr>
-          </a:solidFill>
-          <a:ln xmlns:a="http://schemas.openxmlformats.org/drawingml/2006/main" w="0">
-            <a:solidFill>
-              <a:srgbClr val="FFFFFF">
-                <a:alpha val="0"/>
-              </a:srgbClr>
-            </a:solidFill>
-          </a:ln>
-        </p:spPr>
-        <p:txBody>
-          <a:bodyPr xmlns:a="http://schemas.openxmlformats.org/drawingml/2006/main" lIns="76200" tIns="38100" rIns="76200" bIns="38100" anchor="ctr"/>
+                <a16:creationId xmlns:a16="http://schemas.microsoft.com/office/drawing/2014/main" id="{261C3ADB-2C60-4099-A0B0-1B6256BB3057}"/>
+              </a:ext>
+            </a:extLst>
+          </p:cNvPr>
+          <p:cNvSpPr>
+            <a:spLocks xmlns:a="http://schemas.openxmlformats.org/drawingml/2006/main" noGrp="1"/>
+          </p:cNvSpPr>
+          <p:nvPr/>
+        </p:nvSpPr>
+        <p:spPr>
+          <a:xfrm xmlns:a="http://schemas.openxmlformats.org/drawingml/2006/main">
+            <a:off x="7677150" y="2552700"/>
+            <a:ext cx="2400300" cy="495300"/>
+          </a:xfrm>
+          <a:prstGeom xmlns:a="http://schemas.openxmlformats.org/drawingml/2006/main" prst="rect">
+            <a:avLst/>
+          </a:prstGeom>
+          <a:solidFill xmlns:a="http://schemas.openxmlformats.org/drawingml/2006/main">
+            <a:srgbClr val="FFFFFF">
+              <a:alpha val="0"/>
+            </a:srgbClr>
+          </a:solidFill>
+          <a:ln xmlns:a="http://schemas.openxmlformats.org/drawingml/2006/main" w="0">
+            <a:solidFill>
+              <a:srgbClr val="FFFFFF">
+                <a:alpha val="0"/>
+              </a:srgbClr>
+            </a:solidFill>
+          </a:ln>
+        </p:spPr>
+        <p:txBody>
+          <a:bodyPr xmlns:a="http://schemas.openxmlformats.org/drawingml/2006/main" lIns="0" tIns="0" rIns="114300" bIns="0" anchor="t">
+            <a:normAutofit fontScale="63771"/>
+          </a:bodyPr>
           <a:lstStyle xmlns:a="http://schemas.openxmlformats.org/drawingml/2006/main"/>
           <a:p xmlns:a="http://schemas.openxmlformats.org/drawingml/2006/main">
             <a:pPr algn="l">
-              <a:defRPr sz="975" b="0">
+              <a:defRPr sz="900" b="0">
                 <a:solidFill>
                   <a:srgbClr val="17212B"/>
                 </a:solidFill>
               </a:defRPr>
             </a:pPr>
             <a:r>
-              <a:rPr sz="975" b="0">
+              <a:rPr sz="900" b="0">
                 <a:solidFill>
                   <a:srgbClr val="17212B"/>
                 </a:solidFill>
@@ -10126,23 +10134,23 @@
           <p:cNvPr id="41" name="">
             <a:extLst xmlns:a="http://schemas.openxmlformats.org/drawingml/2006/main">
               <a:ext uri="{FF2B5EF4-FFF2-40B4-BE49-F238E27FC236}">
-                <a16:creationId xmlns:a16="http://schemas.microsoft.com/office/drawing/2014/main" id="{2C0D5BE0-5692-4E5A-B9B4-A5C3B3921368}"/>
-              </a:ext>
-            </a:extLst>
-          </p:cNvPr>
-          <p:cNvSpPr>
-            <a:spLocks xmlns:a="http://schemas.openxmlformats.org/drawingml/2006/main" noGrp="1"/>
-          </p:cNvSpPr>
-          <p:nvPr/>
-        </p:nvSpPr>
-        <p:spPr>
-          <a:xfrm xmlns:a="http://schemas.openxmlformats.org/drawingml/2006/main">
-            <a:off x="7486650" y="3314700"/>
-            <a:ext cx="3905250" cy="1085850"/>
+                <a16:creationId xmlns:a16="http://schemas.microsoft.com/office/drawing/2014/main" id="{156523A1-4CD9-4FEE-A17E-D19900063EB4}"/>
+              </a:ext>
+            </a:extLst>
+          </p:cNvPr>
+          <p:cNvSpPr>
+            <a:spLocks xmlns:a="http://schemas.openxmlformats.org/drawingml/2006/main" noGrp="1"/>
+          </p:cNvSpPr>
+          <p:nvPr/>
+        </p:nvSpPr>
+        <p:spPr>
+          <a:xfrm xmlns:a="http://schemas.openxmlformats.org/drawingml/2006/main">
+            <a:off x="7486650" y="3295650"/>
+            <a:ext cx="3905250" cy="1200150"/>
           </a:xfrm>
           <a:prstGeom xmlns:a="http://schemas.openxmlformats.org/drawingml/2006/main" prst="roundRect">
             <a:avLst>
-              <a:gd name="adj" fmla="val 7018"/>
+              <a:gd name="adj" fmla="val 6349"/>
             </a:avLst>
           </a:prstGeom>
           <a:solidFill xmlns:a="http://schemas.openxmlformats.org/drawingml/2006/main">
@@ -10160,49 +10168,51 @@
           <p:cNvPr id="42" name="">
             <a:extLst xmlns:a="http://schemas.openxmlformats.org/drawingml/2006/main">
               <a:ext uri="{FF2B5EF4-FFF2-40B4-BE49-F238E27FC236}">
-                <a16:creationId xmlns:a16="http://schemas.microsoft.com/office/drawing/2014/main" id="{E9AE82C9-A538-461B-8797-8D9A19785472}"/>
-              </a:ext>
-            </a:extLst>
-          </p:cNvPr>
-          <p:cNvSpPr>
-            <a:spLocks xmlns:a="http://schemas.openxmlformats.org/drawingml/2006/main" noGrp="1"/>
-          </p:cNvSpPr>
-          <p:nvPr/>
-        </p:nvSpPr>
-        <p:spPr>
-          <a:xfrm xmlns:a="http://schemas.openxmlformats.org/drawingml/2006/main">
-            <a:off x="7677150" y="3429000"/>
-            <a:ext cx="2381250" cy="247650"/>
-          </a:xfrm>
-          <a:prstGeom xmlns:a="http://schemas.openxmlformats.org/drawingml/2006/main" prst="rect">
-            <a:avLst/>
-          </a:prstGeom>
-          <a:solidFill xmlns:a="http://schemas.openxmlformats.org/drawingml/2006/main">
-            <a:srgbClr val="FFFFFF">
-              <a:alpha val="0"/>
-            </a:srgbClr>
-          </a:solidFill>
-          <a:ln xmlns:a="http://schemas.openxmlformats.org/drawingml/2006/main" w="0">
-            <a:solidFill>
-              <a:srgbClr val="FFFFFF">
-                <a:alpha val="0"/>
-              </a:srgbClr>
-            </a:solidFill>
-          </a:ln>
-        </p:spPr>
-        <p:txBody>
-          <a:bodyPr xmlns:a="http://schemas.openxmlformats.org/drawingml/2006/main" lIns="76200" tIns="38100" rIns="76200" bIns="38100" anchor="ctr"/>
+                <a16:creationId xmlns:a16="http://schemas.microsoft.com/office/drawing/2014/main" id="{8719D76D-D4DE-4E97-9336-FDCE5079D29F}"/>
+              </a:ext>
+            </a:extLst>
+          </p:cNvPr>
+          <p:cNvSpPr>
+            <a:spLocks xmlns:a="http://schemas.openxmlformats.org/drawingml/2006/main" noGrp="1"/>
+          </p:cNvSpPr>
+          <p:nvPr/>
+        </p:nvSpPr>
+        <p:spPr>
+          <a:xfrm xmlns:a="http://schemas.openxmlformats.org/drawingml/2006/main">
+            <a:off x="7677150" y="3409950"/>
+            <a:ext cx="2209800" cy="381000"/>
+          </a:xfrm>
+          <a:prstGeom xmlns:a="http://schemas.openxmlformats.org/drawingml/2006/main" prst="rect">
+            <a:avLst/>
+          </a:prstGeom>
+          <a:solidFill xmlns:a="http://schemas.openxmlformats.org/drawingml/2006/main">
+            <a:srgbClr val="FFFFFF">
+              <a:alpha val="0"/>
+            </a:srgbClr>
+          </a:solidFill>
+          <a:ln xmlns:a="http://schemas.openxmlformats.org/drawingml/2006/main" w="0">
+            <a:solidFill>
+              <a:srgbClr val="FFFFFF">
+                <a:alpha val="0"/>
+              </a:srgbClr>
+            </a:solidFill>
+          </a:ln>
+        </p:spPr>
+        <p:txBody>
+          <a:bodyPr xmlns:a="http://schemas.openxmlformats.org/drawingml/2006/main" lIns="0" tIns="0" rIns="57150" bIns="0" anchor="t">
+            <a:normAutofit fontScale="96352"/>
+          </a:bodyPr>
           <a:lstStyle xmlns:a="http://schemas.openxmlformats.org/drawingml/2006/main"/>
           <a:p xmlns:a="http://schemas.openxmlformats.org/drawingml/2006/main">
             <a:pPr algn="l">
-              <a:defRPr sz="1200" b="1">
+              <a:defRPr sz="1275" b="1">
                 <a:solidFill>
                   <a:srgbClr val="1A8D55"/>
                 </a:solidFill>
               </a:defRPr>
             </a:pPr>
             <a:r>
-              <a:rPr sz="1200" b="1">
+              <a:rPr sz="1275" b="1">
                 <a:solidFill>
                   <a:srgbClr val="1A8D55"/>
                 </a:solidFill>
@@ -10217,49 +10227,51 @@
           <p:cNvPr id="43" name="">
             <a:extLst xmlns:a="http://schemas.openxmlformats.org/drawingml/2006/main">
               <a:ext uri="{FF2B5EF4-FFF2-40B4-BE49-F238E27FC236}">
-                <a16:creationId xmlns:a16="http://schemas.microsoft.com/office/drawing/2014/main" id="{30AF0327-3773-4EE9-956F-9D2FFEBBC57F}"/>
-              </a:ext>
-            </a:extLst>
-          </p:cNvPr>
-          <p:cNvSpPr>
-            <a:spLocks xmlns:a="http://schemas.openxmlformats.org/drawingml/2006/main" noGrp="1"/>
-          </p:cNvSpPr>
-          <p:nvPr/>
-        </p:nvSpPr>
-        <p:spPr>
-          <a:xfrm xmlns:a="http://schemas.openxmlformats.org/drawingml/2006/main">
-            <a:off x="10001250" y="3409950"/>
-            <a:ext cx="1143000" cy="323850"/>
-          </a:xfrm>
-          <a:prstGeom xmlns:a="http://schemas.openxmlformats.org/drawingml/2006/main" prst="rect">
-            <a:avLst/>
-          </a:prstGeom>
-          <a:solidFill xmlns:a="http://schemas.openxmlformats.org/drawingml/2006/main">
-            <a:srgbClr val="FFFFFF">
-              <a:alpha val="0"/>
-            </a:srgbClr>
-          </a:solidFill>
-          <a:ln xmlns:a="http://schemas.openxmlformats.org/drawingml/2006/main" w="0">
-            <a:solidFill>
-              <a:srgbClr val="FFFFFF">
-                <a:alpha val="0"/>
-              </a:srgbClr>
-            </a:solidFill>
-          </a:ln>
-        </p:spPr>
-        <p:txBody>
-          <a:bodyPr xmlns:a="http://schemas.openxmlformats.org/drawingml/2006/main" lIns="76200" tIns="38100" rIns="76200" bIns="38100" anchor="ctr"/>
+                <a16:creationId xmlns:a16="http://schemas.microsoft.com/office/drawing/2014/main" id="{05D594B3-A25D-483F-834D-B667D6573A62}"/>
+              </a:ext>
+            </a:extLst>
+          </p:cNvPr>
+          <p:cNvSpPr>
+            <a:spLocks xmlns:a="http://schemas.openxmlformats.org/drawingml/2006/main" noGrp="1"/>
+          </p:cNvSpPr>
+          <p:nvPr/>
+        </p:nvSpPr>
+        <p:spPr>
+          <a:xfrm xmlns:a="http://schemas.openxmlformats.org/drawingml/2006/main">
+            <a:off x="10287000" y="3390900"/>
+            <a:ext cx="857250" cy="323850"/>
+          </a:xfrm>
+          <a:prstGeom xmlns:a="http://schemas.openxmlformats.org/drawingml/2006/main" prst="rect">
+            <a:avLst/>
+          </a:prstGeom>
+          <a:solidFill xmlns:a="http://schemas.openxmlformats.org/drawingml/2006/main">
+            <a:srgbClr val="FFFFFF">
+              <a:alpha val="0"/>
+            </a:srgbClr>
+          </a:solidFill>
+          <a:ln xmlns:a="http://schemas.openxmlformats.org/drawingml/2006/main" w="0">
+            <a:solidFill>
+              <a:srgbClr val="FFFFFF">
+                <a:alpha val="0"/>
+              </a:srgbClr>
+            </a:solidFill>
+          </a:ln>
+        </p:spPr>
+        <p:txBody>
+          <a:bodyPr xmlns:a="http://schemas.openxmlformats.org/drawingml/2006/main" lIns="0" tIns="0" rIns="0" bIns="0" anchor="t">
+            <a:normAutofit fontScale="100000"/>
+          </a:bodyPr>
           <a:lstStyle xmlns:a="http://schemas.openxmlformats.org/drawingml/2006/main"/>
           <a:p xmlns:a="http://schemas.openxmlformats.org/drawingml/2006/main">
             <a:pPr algn="r">
-              <a:defRPr sz="1800" b="1">
+              <a:defRPr sz="1650" b="1">
                 <a:solidFill>
                   <a:srgbClr val="17212B"/>
                 </a:solidFill>
               </a:defRPr>
             </a:pPr>
             <a:r>
-              <a:rPr sz="1800" b="1">
+              <a:rPr sz="1650" b="1">
                 <a:solidFill>
                   <a:srgbClr val="17212B"/>
                 </a:solidFill>
@@ -10274,49 +10286,51 @@
           <p:cNvPr id="44" name="">
             <a:extLst xmlns:a="http://schemas.openxmlformats.org/drawingml/2006/main">
               <a:ext uri="{FF2B5EF4-FFF2-40B4-BE49-F238E27FC236}">
-                <a16:creationId xmlns:a16="http://schemas.microsoft.com/office/drawing/2014/main" id="{17F3F939-8094-45A9-AD55-C65DFB5F63D2}"/>
-              </a:ext>
-            </a:extLst>
-          </p:cNvPr>
-          <p:cNvSpPr>
-            <a:spLocks xmlns:a="http://schemas.openxmlformats.org/drawingml/2006/main" noGrp="1"/>
-          </p:cNvSpPr>
-          <p:nvPr/>
-        </p:nvSpPr>
-        <p:spPr>
-          <a:xfrm xmlns:a="http://schemas.openxmlformats.org/drawingml/2006/main">
-            <a:off x="9906000" y="3733800"/>
-            <a:ext cx="1238250" cy="171450"/>
-          </a:xfrm>
-          <a:prstGeom xmlns:a="http://schemas.openxmlformats.org/drawingml/2006/main" prst="rect">
-            <a:avLst/>
-          </a:prstGeom>
-          <a:solidFill xmlns:a="http://schemas.openxmlformats.org/drawingml/2006/main">
-            <a:srgbClr val="FFFFFF">
-              <a:alpha val="0"/>
-            </a:srgbClr>
-          </a:solidFill>
-          <a:ln xmlns:a="http://schemas.openxmlformats.org/drawingml/2006/main" w="0">
-            <a:solidFill>
-              <a:srgbClr val="FFFFFF">
-                <a:alpha val="0"/>
-              </a:srgbClr>
-            </a:solidFill>
-          </a:ln>
-        </p:spPr>
-        <p:txBody>
-          <a:bodyPr xmlns:a="http://schemas.openxmlformats.org/drawingml/2006/main" lIns="76200" tIns="38100" rIns="76200" bIns="38100" anchor="ctr"/>
+                <a16:creationId xmlns:a16="http://schemas.microsoft.com/office/drawing/2014/main" id="{0C8482C4-8211-4D4E-9346-FA71228280D9}"/>
+              </a:ext>
+            </a:extLst>
+          </p:cNvPr>
+          <p:cNvSpPr>
+            <a:spLocks xmlns:a="http://schemas.openxmlformats.org/drawingml/2006/main" noGrp="1"/>
+          </p:cNvSpPr>
+          <p:nvPr/>
+        </p:nvSpPr>
+        <p:spPr>
+          <a:xfrm xmlns:a="http://schemas.openxmlformats.org/drawingml/2006/main">
+            <a:off x="10115550" y="3676650"/>
+            <a:ext cx="1028700" cy="266700"/>
+          </a:xfrm>
+          <a:prstGeom xmlns:a="http://schemas.openxmlformats.org/drawingml/2006/main" prst="rect">
+            <a:avLst/>
+          </a:prstGeom>
+          <a:solidFill xmlns:a="http://schemas.openxmlformats.org/drawingml/2006/main">
+            <a:srgbClr val="FFFFFF">
+              <a:alpha val="0"/>
+            </a:srgbClr>
+          </a:solidFill>
+          <a:ln xmlns:a="http://schemas.openxmlformats.org/drawingml/2006/main" w="0">
+            <a:solidFill>
+              <a:srgbClr val="FFFFFF">
+                <a:alpha val="0"/>
+              </a:srgbClr>
+            </a:solidFill>
+          </a:ln>
+        </p:spPr>
+        <p:txBody>
+          <a:bodyPr xmlns:a="http://schemas.openxmlformats.org/drawingml/2006/main" lIns="38100" tIns="0" rIns="0" bIns="0" anchor="t">
+            <a:normAutofit fontScale="100000"/>
+          </a:bodyPr>
           <a:lstStyle xmlns:a="http://schemas.openxmlformats.org/drawingml/2006/main"/>
           <a:p xmlns:a="http://schemas.openxmlformats.org/drawingml/2006/main">
             <a:pPr algn="r">
-              <a:defRPr sz="825" b="1">
+              <a:defRPr sz="750" b="1">
                 <a:solidFill>
                   <a:srgbClr val="52616F"/>
                 </a:solidFill>
               </a:defRPr>
             </a:pPr>
             <a:r>
-              <a:rPr sz="825" b="1">
+              <a:rPr sz="750" b="1">
                 <a:solidFill>
                   <a:srgbClr val="52616F"/>
                 </a:solidFill>
@@ -10331,49 +10345,51 @@
           <p:cNvPr id="45" name="">
             <a:extLst xmlns:a="http://schemas.openxmlformats.org/drawingml/2006/main">
               <a:ext uri="{FF2B5EF4-FFF2-40B4-BE49-F238E27FC236}">
-                <a16:creationId xmlns:a16="http://schemas.microsoft.com/office/drawing/2014/main" id="{3324CBE0-0452-49F4-886A-6B939FEC73DC}"/>
-              </a:ext>
-            </a:extLst>
-          </p:cNvPr>
-          <p:cNvSpPr>
-            <a:spLocks xmlns:a="http://schemas.openxmlformats.org/drawingml/2006/main" noGrp="1"/>
-          </p:cNvSpPr>
-          <p:nvPr/>
-        </p:nvSpPr>
-        <p:spPr>
-          <a:xfrm xmlns:a="http://schemas.openxmlformats.org/drawingml/2006/main">
-            <a:off x="7677150" y="3790950"/>
-            <a:ext cx="3333750" cy="457200"/>
-          </a:xfrm>
-          <a:prstGeom xmlns:a="http://schemas.openxmlformats.org/drawingml/2006/main" prst="rect">
-            <a:avLst/>
-          </a:prstGeom>
-          <a:solidFill xmlns:a="http://schemas.openxmlformats.org/drawingml/2006/main">
-            <a:srgbClr val="FFFFFF">
-              <a:alpha val="0"/>
-            </a:srgbClr>
-          </a:solidFill>
-          <a:ln xmlns:a="http://schemas.openxmlformats.org/drawingml/2006/main" w="0">
-            <a:solidFill>
-              <a:srgbClr val="FFFFFF">
-                <a:alpha val="0"/>
-              </a:srgbClr>
-            </a:solidFill>
-          </a:ln>
-        </p:spPr>
-        <p:txBody>
-          <a:bodyPr xmlns:a="http://schemas.openxmlformats.org/drawingml/2006/main" lIns="76200" tIns="38100" rIns="76200" bIns="38100" anchor="ctr"/>
+                <a16:creationId xmlns:a16="http://schemas.microsoft.com/office/drawing/2014/main" id="{3FA263F7-7B97-4FA1-A5FC-2250C5E1C2D8}"/>
+              </a:ext>
+            </a:extLst>
+          </p:cNvPr>
+          <p:cNvSpPr>
+            <a:spLocks xmlns:a="http://schemas.openxmlformats.org/drawingml/2006/main" noGrp="1"/>
+          </p:cNvSpPr>
+          <p:nvPr/>
+        </p:nvSpPr>
+        <p:spPr>
+          <a:xfrm xmlns:a="http://schemas.openxmlformats.org/drawingml/2006/main">
+            <a:off x="7677150" y="3867150"/>
+            <a:ext cx="2400300" cy="495300"/>
+          </a:xfrm>
+          <a:prstGeom xmlns:a="http://schemas.openxmlformats.org/drawingml/2006/main" prst="rect">
+            <a:avLst/>
+          </a:prstGeom>
+          <a:solidFill xmlns:a="http://schemas.openxmlformats.org/drawingml/2006/main">
+            <a:srgbClr val="FFFFFF">
+              <a:alpha val="0"/>
+            </a:srgbClr>
+          </a:solidFill>
+          <a:ln xmlns:a="http://schemas.openxmlformats.org/drawingml/2006/main" w="0">
+            <a:solidFill>
+              <a:srgbClr val="FFFFFF">
+                <a:alpha val="0"/>
+              </a:srgbClr>
+            </a:solidFill>
+          </a:ln>
+        </p:spPr>
+        <p:txBody>
+          <a:bodyPr xmlns:a="http://schemas.openxmlformats.org/drawingml/2006/main" lIns="0" tIns="0" rIns="114300" bIns="0" anchor="t">
+            <a:normAutofit fontScale="90808"/>
+          </a:bodyPr>
           <a:lstStyle xmlns:a="http://schemas.openxmlformats.org/drawingml/2006/main"/>
           <a:p xmlns:a="http://schemas.openxmlformats.org/drawingml/2006/main">
             <a:pPr algn="l">
-              <a:defRPr sz="975" b="0">
+              <a:defRPr sz="900" b="0">
                 <a:solidFill>
                   <a:srgbClr val="17212B"/>
                 </a:solidFill>
               </a:defRPr>
             </a:pPr>
             <a:r>
-              <a:rPr sz="975" b="0">
+              <a:rPr sz="900" b="0">
                 <a:solidFill>
                   <a:srgbClr val="17212B"/>
                 </a:solidFill>
@@ -10388,23 +10404,23 @@
           <p:cNvPr id="46" name="">
             <a:extLst xmlns:a="http://schemas.openxmlformats.org/drawingml/2006/main">
               <a:ext uri="{FF2B5EF4-FFF2-40B4-BE49-F238E27FC236}">
-                <a16:creationId xmlns:a16="http://schemas.microsoft.com/office/drawing/2014/main" id="{0D0CEF04-1B90-4D55-8B59-DF5B37BAEA40}"/>
-              </a:ext>
-            </a:extLst>
-          </p:cNvPr>
-          <p:cNvSpPr>
-            <a:spLocks xmlns:a="http://schemas.openxmlformats.org/drawingml/2006/main" noGrp="1"/>
-          </p:cNvSpPr>
-          <p:nvPr/>
-        </p:nvSpPr>
-        <p:spPr>
-          <a:xfrm xmlns:a="http://schemas.openxmlformats.org/drawingml/2006/main">
-            <a:off x="7486650" y="4591050"/>
-            <a:ext cx="3905250" cy="1085850"/>
+                <a16:creationId xmlns:a16="http://schemas.microsoft.com/office/drawing/2014/main" id="{92FC0422-AA05-4E6E-8935-C48FB6802F21}"/>
+              </a:ext>
+            </a:extLst>
+          </p:cNvPr>
+          <p:cNvSpPr>
+            <a:spLocks xmlns:a="http://schemas.openxmlformats.org/drawingml/2006/main" noGrp="1"/>
+          </p:cNvSpPr>
+          <p:nvPr/>
+        </p:nvSpPr>
+        <p:spPr>
+          <a:xfrm xmlns:a="http://schemas.openxmlformats.org/drawingml/2006/main">
+            <a:off x="7486650" y="4610100"/>
+            <a:ext cx="3905250" cy="1200150"/>
           </a:xfrm>
           <a:prstGeom xmlns:a="http://schemas.openxmlformats.org/drawingml/2006/main" prst="roundRect">
             <a:avLst>
-              <a:gd name="adj" fmla="val 7018"/>
+              <a:gd name="adj" fmla="val 6349"/>
             </a:avLst>
           </a:prstGeom>
           <a:solidFill xmlns:a="http://schemas.openxmlformats.org/drawingml/2006/main">
@@ -10422,49 +10438,51 @@
           <p:cNvPr id="47" name="">
             <a:extLst xmlns:a="http://schemas.openxmlformats.org/drawingml/2006/main">
               <a:ext uri="{FF2B5EF4-FFF2-40B4-BE49-F238E27FC236}">
-                <a16:creationId xmlns:a16="http://schemas.microsoft.com/office/drawing/2014/main" id="{A5C31439-A8CF-484E-B62D-F6FEED800D85}"/>
-              </a:ext>
-            </a:extLst>
-          </p:cNvPr>
-          <p:cNvSpPr>
-            <a:spLocks xmlns:a="http://schemas.openxmlformats.org/drawingml/2006/main" noGrp="1"/>
-          </p:cNvSpPr>
-          <p:nvPr/>
-        </p:nvSpPr>
-        <p:spPr>
-          <a:xfrm xmlns:a="http://schemas.openxmlformats.org/drawingml/2006/main">
-            <a:off x="7677150" y="4705350"/>
-            <a:ext cx="2381250" cy="247650"/>
-          </a:xfrm>
-          <a:prstGeom xmlns:a="http://schemas.openxmlformats.org/drawingml/2006/main" prst="rect">
-            <a:avLst/>
-          </a:prstGeom>
-          <a:solidFill xmlns:a="http://schemas.openxmlformats.org/drawingml/2006/main">
-            <a:srgbClr val="FFFFFF">
-              <a:alpha val="0"/>
-            </a:srgbClr>
-          </a:solidFill>
-          <a:ln xmlns:a="http://schemas.openxmlformats.org/drawingml/2006/main" w="0">
-            <a:solidFill>
-              <a:srgbClr val="FFFFFF">
-                <a:alpha val="0"/>
-              </a:srgbClr>
-            </a:solidFill>
-          </a:ln>
-        </p:spPr>
-        <p:txBody>
-          <a:bodyPr xmlns:a="http://schemas.openxmlformats.org/drawingml/2006/main" lIns="76200" tIns="38100" rIns="76200" bIns="38100" anchor="ctr"/>
+                <a16:creationId xmlns:a16="http://schemas.microsoft.com/office/drawing/2014/main" id="{212DA9FF-CCE6-4CA2-998D-AC52FEA749F3}"/>
+              </a:ext>
+            </a:extLst>
+          </p:cNvPr>
+          <p:cNvSpPr>
+            <a:spLocks xmlns:a="http://schemas.openxmlformats.org/drawingml/2006/main" noGrp="1"/>
+          </p:cNvSpPr>
+          <p:nvPr/>
+        </p:nvSpPr>
+        <p:spPr>
+          <a:xfrm xmlns:a="http://schemas.openxmlformats.org/drawingml/2006/main">
+            <a:off x="7677150" y="4724400"/>
+            <a:ext cx="2209800" cy="381000"/>
+          </a:xfrm>
+          <a:prstGeom xmlns:a="http://schemas.openxmlformats.org/drawingml/2006/main" prst="rect">
+            <a:avLst/>
+          </a:prstGeom>
+          <a:solidFill xmlns:a="http://schemas.openxmlformats.org/drawingml/2006/main">
+            <a:srgbClr val="FFFFFF">
+              <a:alpha val="0"/>
+            </a:srgbClr>
+          </a:solidFill>
+          <a:ln xmlns:a="http://schemas.openxmlformats.org/drawingml/2006/main" w="0">
+            <a:solidFill>
+              <a:srgbClr val="FFFFFF">
+                <a:alpha val="0"/>
+              </a:srgbClr>
+            </a:solidFill>
+          </a:ln>
+        </p:spPr>
+        <p:txBody>
+          <a:bodyPr xmlns:a="http://schemas.openxmlformats.org/drawingml/2006/main" lIns="0" tIns="0" rIns="57150" bIns="0" anchor="t">
+            <a:normAutofit fontScale="96352"/>
+          </a:bodyPr>
           <a:lstStyle xmlns:a="http://schemas.openxmlformats.org/drawingml/2006/main"/>
           <a:p xmlns:a="http://schemas.openxmlformats.org/drawingml/2006/main">
             <a:pPr algn="l">
-              <a:defRPr sz="1200" b="1">
+              <a:defRPr sz="1275" b="1">
                 <a:solidFill>
                   <a:srgbClr val="BF3F35"/>
                 </a:solidFill>
               </a:defRPr>
             </a:pPr>
             <a:r>
-              <a:rPr sz="1200" b="1">
+              <a:rPr sz="1275" b="1">
                 <a:solidFill>
                   <a:srgbClr val="BF3F35"/>
                 </a:solidFill>
@@ -10479,49 +10497,51 @@
           <p:cNvPr id="48" name="">
             <a:extLst xmlns:a="http://schemas.openxmlformats.org/drawingml/2006/main">
               <a:ext uri="{FF2B5EF4-FFF2-40B4-BE49-F238E27FC236}">
-                <a16:creationId xmlns:a16="http://schemas.microsoft.com/office/drawing/2014/main" id="{09611E73-15D2-4CF2-9C94-5B95E6AF5AC5}"/>
-              </a:ext>
-            </a:extLst>
-          </p:cNvPr>
-          <p:cNvSpPr>
-            <a:spLocks xmlns:a="http://schemas.openxmlformats.org/drawingml/2006/main" noGrp="1"/>
-          </p:cNvSpPr>
-          <p:nvPr/>
-        </p:nvSpPr>
-        <p:spPr>
-          <a:xfrm xmlns:a="http://schemas.openxmlformats.org/drawingml/2006/main">
-            <a:off x="10001250" y="4686300"/>
-            <a:ext cx="1143000" cy="323850"/>
-          </a:xfrm>
-          <a:prstGeom xmlns:a="http://schemas.openxmlformats.org/drawingml/2006/main" prst="rect">
-            <a:avLst/>
-          </a:prstGeom>
-          <a:solidFill xmlns:a="http://schemas.openxmlformats.org/drawingml/2006/main">
-            <a:srgbClr val="FFFFFF">
-              <a:alpha val="0"/>
-            </a:srgbClr>
-          </a:solidFill>
-          <a:ln xmlns:a="http://schemas.openxmlformats.org/drawingml/2006/main" w="0">
-            <a:solidFill>
-              <a:srgbClr val="FFFFFF">
-                <a:alpha val="0"/>
-              </a:srgbClr>
-            </a:solidFill>
-          </a:ln>
-        </p:spPr>
-        <p:txBody>
-          <a:bodyPr xmlns:a="http://schemas.openxmlformats.org/drawingml/2006/main" lIns="76200" tIns="38100" rIns="76200" bIns="38100" anchor="ctr"/>
+                <a16:creationId xmlns:a16="http://schemas.microsoft.com/office/drawing/2014/main" id="{0AE1F940-4B68-4E8C-9025-A0144DE6781E}"/>
+              </a:ext>
+            </a:extLst>
+          </p:cNvPr>
+          <p:cNvSpPr>
+            <a:spLocks xmlns:a="http://schemas.openxmlformats.org/drawingml/2006/main" noGrp="1"/>
+          </p:cNvSpPr>
+          <p:nvPr/>
+        </p:nvSpPr>
+        <p:spPr>
+          <a:xfrm xmlns:a="http://schemas.openxmlformats.org/drawingml/2006/main">
+            <a:off x="10287000" y="4705350"/>
+            <a:ext cx="857250" cy="323850"/>
+          </a:xfrm>
+          <a:prstGeom xmlns:a="http://schemas.openxmlformats.org/drawingml/2006/main" prst="rect">
+            <a:avLst/>
+          </a:prstGeom>
+          <a:solidFill xmlns:a="http://schemas.openxmlformats.org/drawingml/2006/main">
+            <a:srgbClr val="FFFFFF">
+              <a:alpha val="0"/>
+            </a:srgbClr>
+          </a:solidFill>
+          <a:ln xmlns:a="http://schemas.openxmlformats.org/drawingml/2006/main" w="0">
+            <a:solidFill>
+              <a:srgbClr val="FFFFFF">
+                <a:alpha val="0"/>
+              </a:srgbClr>
+            </a:solidFill>
+          </a:ln>
+        </p:spPr>
+        <p:txBody>
+          <a:bodyPr xmlns:a="http://schemas.openxmlformats.org/drawingml/2006/main" lIns="0" tIns="0" rIns="0" bIns="0" anchor="t">
+            <a:normAutofit fontScale="100000"/>
+          </a:bodyPr>
           <a:lstStyle xmlns:a="http://schemas.openxmlformats.org/drawingml/2006/main"/>
           <a:p xmlns:a="http://schemas.openxmlformats.org/drawingml/2006/main">
             <a:pPr algn="r">
-              <a:defRPr sz="1800" b="1">
+              <a:defRPr sz="1650" b="1">
                 <a:solidFill>
                   <a:srgbClr val="17212B"/>
                 </a:solidFill>
               </a:defRPr>
             </a:pPr>
             <a:r>
-              <a:rPr sz="1800" b="1">
+              <a:rPr sz="1650" b="1">
                 <a:solidFill>
                   <a:srgbClr val="17212B"/>
                 </a:solidFill>
@@ -10536,49 +10556,51 @@
           <p:cNvPr id="49" name="">
             <a:extLst xmlns:a="http://schemas.openxmlformats.org/drawingml/2006/main">
               <a:ext uri="{FF2B5EF4-FFF2-40B4-BE49-F238E27FC236}">
-                <a16:creationId xmlns:a16="http://schemas.microsoft.com/office/drawing/2014/main" id="{BC775837-DB2C-4BEB-A78A-5D8E2CFC872A}"/>
-              </a:ext>
-            </a:extLst>
-          </p:cNvPr>
-          <p:cNvSpPr>
-            <a:spLocks xmlns:a="http://schemas.openxmlformats.org/drawingml/2006/main" noGrp="1"/>
-          </p:cNvSpPr>
-          <p:nvPr/>
-        </p:nvSpPr>
-        <p:spPr>
-          <a:xfrm xmlns:a="http://schemas.openxmlformats.org/drawingml/2006/main">
-            <a:off x="9906000" y="5010150"/>
-            <a:ext cx="1238250" cy="171450"/>
-          </a:xfrm>
-          <a:prstGeom xmlns:a="http://schemas.openxmlformats.org/drawingml/2006/main" prst="rect">
-            <a:avLst/>
-          </a:prstGeom>
-          <a:solidFill xmlns:a="http://schemas.openxmlformats.org/drawingml/2006/main">
-            <a:srgbClr val="FFFFFF">
-              <a:alpha val="0"/>
-            </a:srgbClr>
-          </a:solidFill>
-          <a:ln xmlns:a="http://schemas.openxmlformats.org/drawingml/2006/main" w="0">
-            <a:solidFill>
-              <a:srgbClr val="FFFFFF">
-                <a:alpha val="0"/>
-              </a:srgbClr>
-            </a:solidFill>
-          </a:ln>
-        </p:spPr>
-        <p:txBody>
-          <a:bodyPr xmlns:a="http://schemas.openxmlformats.org/drawingml/2006/main" lIns="76200" tIns="38100" rIns="76200" bIns="38100" anchor="ctr"/>
+                <a16:creationId xmlns:a16="http://schemas.microsoft.com/office/drawing/2014/main" id="{4BAE208A-3892-47E7-BCB3-E8674B827067}"/>
+              </a:ext>
+            </a:extLst>
+          </p:cNvPr>
+          <p:cNvSpPr>
+            <a:spLocks xmlns:a="http://schemas.openxmlformats.org/drawingml/2006/main" noGrp="1"/>
+          </p:cNvSpPr>
+          <p:nvPr/>
+        </p:nvSpPr>
+        <p:spPr>
+          <a:xfrm xmlns:a="http://schemas.openxmlformats.org/drawingml/2006/main">
+            <a:off x="10115550" y="4991100"/>
+            <a:ext cx="1028700" cy="266700"/>
+          </a:xfrm>
+          <a:prstGeom xmlns:a="http://schemas.openxmlformats.org/drawingml/2006/main" prst="rect">
+            <a:avLst/>
+          </a:prstGeom>
+          <a:solidFill xmlns:a="http://schemas.openxmlformats.org/drawingml/2006/main">
+            <a:srgbClr val="FFFFFF">
+              <a:alpha val="0"/>
+            </a:srgbClr>
+          </a:solidFill>
+          <a:ln xmlns:a="http://schemas.openxmlformats.org/drawingml/2006/main" w="0">
+            <a:solidFill>
+              <a:srgbClr val="FFFFFF">
+                <a:alpha val="0"/>
+              </a:srgbClr>
+            </a:solidFill>
+          </a:ln>
+        </p:spPr>
+        <p:txBody>
+          <a:bodyPr xmlns:a="http://schemas.openxmlformats.org/drawingml/2006/main" lIns="38100" tIns="0" rIns="0" bIns="0" anchor="t">
+            <a:normAutofit fontScale="100000"/>
+          </a:bodyPr>
           <a:lstStyle xmlns:a="http://schemas.openxmlformats.org/drawingml/2006/main"/>
           <a:p xmlns:a="http://schemas.openxmlformats.org/drawingml/2006/main">
             <a:pPr algn="r">
-              <a:defRPr sz="825" b="1">
+              <a:defRPr sz="750" b="1">
                 <a:solidFill>
                   <a:srgbClr val="52616F"/>
                 </a:solidFill>
               </a:defRPr>
             </a:pPr>
             <a:r>
-              <a:rPr sz="825" b="1">
+              <a:rPr sz="750" b="1">
                 <a:solidFill>
                   <a:srgbClr val="52616F"/>
                 </a:solidFill>
@@ -10593,54 +10615,56 @@
           <p:cNvPr id="50" name="">
             <a:extLst xmlns:a="http://schemas.openxmlformats.org/drawingml/2006/main">
               <a:ext uri="{FF2B5EF4-FFF2-40B4-BE49-F238E27FC236}">
-                <a16:creationId xmlns:a16="http://schemas.microsoft.com/office/drawing/2014/main" id="{8DD5F219-EF7B-4E67-B54C-DB1C53A20DFA}"/>
-              </a:ext>
-            </a:extLst>
-          </p:cNvPr>
-          <p:cNvSpPr>
-            <a:spLocks xmlns:a="http://schemas.openxmlformats.org/drawingml/2006/main" noGrp="1"/>
-          </p:cNvSpPr>
-          <p:nvPr/>
-        </p:nvSpPr>
-        <p:spPr>
-          <a:xfrm xmlns:a="http://schemas.openxmlformats.org/drawingml/2006/main">
-            <a:off x="7677150" y="5067300"/>
-            <a:ext cx="3333750" cy="457200"/>
-          </a:xfrm>
-          <a:prstGeom xmlns:a="http://schemas.openxmlformats.org/drawingml/2006/main" prst="rect">
-            <a:avLst/>
-          </a:prstGeom>
-          <a:solidFill xmlns:a="http://schemas.openxmlformats.org/drawingml/2006/main">
-            <a:srgbClr val="FFFFFF">
-              <a:alpha val="0"/>
-            </a:srgbClr>
-          </a:solidFill>
-          <a:ln xmlns:a="http://schemas.openxmlformats.org/drawingml/2006/main" w="0">
-            <a:solidFill>
-              <a:srgbClr val="FFFFFF">
-                <a:alpha val="0"/>
-              </a:srgbClr>
-            </a:solidFill>
-          </a:ln>
-        </p:spPr>
-        <p:txBody>
-          <a:bodyPr xmlns:a="http://schemas.openxmlformats.org/drawingml/2006/main" lIns="76200" tIns="38100" rIns="76200" bIns="38100" anchor="ctr"/>
+                <a16:creationId xmlns:a16="http://schemas.microsoft.com/office/drawing/2014/main" id="{612E82A7-EF45-4FC2-94F9-E3D793B92A7A}"/>
+              </a:ext>
+            </a:extLst>
+          </p:cNvPr>
+          <p:cNvSpPr>
+            <a:spLocks xmlns:a="http://schemas.openxmlformats.org/drawingml/2006/main" noGrp="1"/>
+          </p:cNvSpPr>
+          <p:nvPr/>
+        </p:nvSpPr>
+        <p:spPr>
+          <a:xfrm xmlns:a="http://schemas.openxmlformats.org/drawingml/2006/main">
+            <a:off x="7677150" y="5181600"/>
+            <a:ext cx="2400300" cy="495300"/>
+          </a:xfrm>
+          <a:prstGeom xmlns:a="http://schemas.openxmlformats.org/drawingml/2006/main" prst="rect">
+            <a:avLst/>
+          </a:prstGeom>
+          <a:solidFill xmlns:a="http://schemas.openxmlformats.org/drawingml/2006/main">
+            <a:srgbClr val="FFFFFF">
+              <a:alpha val="0"/>
+            </a:srgbClr>
+          </a:solidFill>
+          <a:ln xmlns:a="http://schemas.openxmlformats.org/drawingml/2006/main" w="0">
+            <a:solidFill>
+              <a:srgbClr val="FFFFFF">
+                <a:alpha val="0"/>
+              </a:srgbClr>
+            </a:solidFill>
+          </a:ln>
+        </p:spPr>
+        <p:txBody>
+          <a:bodyPr xmlns:a="http://schemas.openxmlformats.org/drawingml/2006/main" lIns="0" tIns="0" rIns="114300" bIns="0" anchor="t">
+            <a:normAutofit fontScale="90808"/>
+          </a:bodyPr>
           <a:lstStyle xmlns:a="http://schemas.openxmlformats.org/drawingml/2006/main"/>
           <a:p xmlns:a="http://schemas.openxmlformats.org/drawingml/2006/main">
             <a:pPr algn="l">
-              <a:defRPr sz="975" b="0">
+              <a:defRPr sz="900" b="0">
                 <a:solidFill>
                   <a:srgbClr val="17212B"/>
                 </a:solidFill>
               </a:defRPr>
             </a:pPr>
             <a:r>
-              <a:rPr sz="975" b="0">
+              <a:rPr sz="900" b="0">
                 <a:solidFill>
                   <a:srgbClr val="17212B"/>
                 </a:solidFill>
               </a:rPr>
-              <a:t>MO currently owns 97 open tickets, including 20 high-severity items and 94 overdue follow-ups. That queue scores 203 points above the peer median on the executive backlog index.</a:t>
+              <a:t>MO currently owns 97 open tickets, including 20 high-severity items and 74 overdue follow-ups. That queue scores 123 points above the peer median on the executive backlog index.</a:t>
             </a:r>
           </a:p>
         </p:txBody>
@@ -10648,7 +10672,7 @@
     </p:spTree>
     <p:extLst>
       <p:ext uri="{BB962C8B-B14F-4D97-AF65-F5344CB8AC3E}">
-        <p14:creationId xmlns:p14="http://schemas.microsoft.com/office/powerpoint/2010/main" val="1402346270"/>
+        <p14:creationId xmlns:p14="http://schemas.microsoft.com/office/powerpoint/2010/main" val="1192565152"/>
       </p:ext>
     </p:extLst>
   </p:cSld>

</xml_diff>